<commit_message>
change chapter 1 to pptx/ppt format
</commit_message>
<xml_diff>
--- a/20242-NLP-LLM/lecture notes/Part 1 - Introduction to NLP/1-introduction to NLP.pptx
+++ b/20242-NLP-LLM/lecture notes/Part 1 - Introduction to NLP/1-introduction to NLP.pptx
@@ -5,7 +5,7 @@
     <p:sldMasterId id="2147483648" r:id="rId1"/>
   </p:sldMasterIdLst>
   <p:notesMasterIdLst>
-    <p:notesMasterId r:id="rId32"/>
+    <p:notesMasterId r:id="rId35"/>
   </p:notesMasterIdLst>
   <p:sldIdLst>
     <p:sldId id="455" r:id="rId2"/>
@@ -37,7 +37,10 @@
     <p:sldId id="555" r:id="rId28"/>
     <p:sldId id="549" r:id="rId29"/>
     <p:sldId id="547" r:id="rId30"/>
-    <p:sldId id="548" r:id="rId31"/>
+    <p:sldId id="557" r:id="rId31"/>
+    <p:sldId id="548" r:id="rId32"/>
+    <p:sldId id="556" r:id="rId33"/>
+    <p:sldId id="558" r:id="rId34"/>
   </p:sldIdLst>
   <p:sldSz cx="12192000" cy="6858000"/>
   <p:notesSz cx="6858000" cy="9144000"/>
@@ -154,7 +157,7 @@
 <p1510:revInfo xmlns:a="http://schemas.openxmlformats.org/drawingml/2006/main" xmlns:r="http://schemas.openxmlformats.org/officeDocument/2006/relationships" xmlns:p1510="http://schemas.microsoft.com/office/powerpoint/2015/10/main">
   <p1510:revLst>
     <p1510:client id="{1BAE7373-BC78-49F1-9262-209B991CDE28}" v="31" dt="2025-03-15T11:49:33.004"/>
-    <p1510:client id="{534F862C-5423-415F-8625-CCE86B4944CE}" v="38" dt="2025-03-15T15:11:24.982"/>
+    <p1510:client id="{534F862C-5423-415F-8625-CCE86B4944CE}" v="42" dt="2025-03-15T15:46:18.147"/>
   </p1510:revLst>
 </p1510:revInfo>
 </file>
@@ -1624,7 +1627,7 @@
   <pc:docChgLst>
     <pc:chgData name="Mohammed Fasha" userId="cc64f42d-a1a6-4f08-b97b-0c37f877119f" providerId="ADAL" clId="{534F862C-5423-415F-8625-CCE86B4944CE}"/>
     <pc:docChg chg="undo redo custSel addSld delSld modSld sldOrd">
-      <pc:chgData name="Mohammed Fasha" userId="cc64f42d-a1a6-4f08-b97b-0c37f877119f" providerId="ADAL" clId="{534F862C-5423-415F-8625-CCE86B4944CE}" dt="2025-03-15T15:25:49.352" v="1061" actId="20577"/>
+      <pc:chgData name="Mohammed Fasha" userId="cc64f42d-a1a6-4f08-b97b-0c37f877119f" providerId="ADAL" clId="{534F862C-5423-415F-8625-CCE86B4944CE}" dt="2025-03-15T15:46:18.147" v="1203"/>
       <pc:docMkLst>
         <pc:docMk/>
       </pc:docMkLst>
@@ -2352,13 +2355,13 @@
         </pc:spChg>
       </pc:sldChg>
       <pc:sldChg chg="modSp add mod">
-        <pc:chgData name="Mohammed Fasha" userId="cc64f42d-a1a6-4f08-b97b-0c37f877119f" providerId="ADAL" clId="{534F862C-5423-415F-8625-CCE86B4944CE}" dt="2025-03-15T14:56:50.704" v="775" actId="5793"/>
+        <pc:chgData name="Mohammed Fasha" userId="cc64f42d-a1a6-4f08-b97b-0c37f877119f" providerId="ADAL" clId="{534F862C-5423-415F-8625-CCE86B4944CE}" dt="2025-03-15T15:37:47.199" v="1107" actId="20577"/>
         <pc:sldMkLst>
           <pc:docMk/>
           <pc:sldMk cId="184126415" sldId="547"/>
         </pc:sldMkLst>
         <pc:spChg chg="mod">
-          <ac:chgData name="Mohammed Fasha" userId="cc64f42d-a1a6-4f08-b97b-0c37f877119f" providerId="ADAL" clId="{534F862C-5423-415F-8625-CCE86B4944CE}" dt="2025-03-15T14:56:01.910" v="747"/>
+          <ac:chgData name="Mohammed Fasha" userId="cc64f42d-a1a6-4f08-b97b-0c37f877119f" providerId="ADAL" clId="{534F862C-5423-415F-8625-CCE86B4944CE}" dt="2025-03-15T15:37:32.307" v="1099" actId="21"/>
           <ac:spMkLst>
             <pc:docMk/>
             <pc:sldMk cId="184126415" sldId="547"/>
@@ -2366,7 +2369,7 @@
           </ac:spMkLst>
         </pc:spChg>
         <pc:spChg chg="mod">
-          <ac:chgData name="Mohammed Fasha" userId="cc64f42d-a1a6-4f08-b97b-0c37f877119f" providerId="ADAL" clId="{534F862C-5423-415F-8625-CCE86B4944CE}" dt="2025-03-15T14:56:50.704" v="775" actId="5793"/>
+          <ac:chgData name="Mohammed Fasha" userId="cc64f42d-a1a6-4f08-b97b-0c37f877119f" providerId="ADAL" clId="{534F862C-5423-415F-8625-CCE86B4944CE}" dt="2025-03-15T15:37:47.199" v="1107" actId="20577"/>
           <ac:spMkLst>
             <pc:docMk/>
             <pc:sldMk cId="184126415" sldId="547"/>
@@ -2444,7 +2447,7 @@
         </pc:spChg>
       </pc:sldChg>
       <pc:sldChg chg="addSp modSp new mod">
-        <pc:chgData name="Mohammed Fasha" userId="cc64f42d-a1a6-4f08-b97b-0c37f877119f" providerId="ADAL" clId="{534F862C-5423-415F-8625-CCE86B4944CE}" dt="2025-03-15T15:07:03.442" v="895" actId="15"/>
+        <pc:chgData name="Mohammed Fasha" userId="cc64f42d-a1a6-4f08-b97b-0c37f877119f" providerId="ADAL" clId="{534F862C-5423-415F-8625-CCE86B4944CE}" dt="2025-03-15T15:46:18.147" v="1203"/>
         <pc:sldMkLst>
           <pc:docMk/>
           <pc:sldMk cId="51728829" sldId="550"/>
@@ -2458,7 +2461,7 @@
           </ac:spMkLst>
         </pc:spChg>
         <pc:spChg chg="mod">
-          <ac:chgData name="Mohammed Fasha" userId="cc64f42d-a1a6-4f08-b97b-0c37f877119f" providerId="ADAL" clId="{534F862C-5423-415F-8625-CCE86B4944CE}" dt="2025-03-15T15:07:03.442" v="895" actId="15"/>
+          <ac:chgData name="Mohammed Fasha" userId="cc64f42d-a1a6-4f08-b97b-0c37f877119f" providerId="ADAL" clId="{534F862C-5423-415F-8625-CCE86B4944CE}" dt="2025-03-15T15:41:10.824" v="1163" actId="1076"/>
           <ac:spMkLst>
             <pc:docMk/>
             <pc:sldMk cId="51728829" sldId="550"/>
@@ -2473,6 +2476,22 @@
             <ac:spMk id="4" creationId="{FDD15BE4-049C-3B76-CA33-46995EADA93B}"/>
           </ac:spMkLst>
         </pc:spChg>
+        <pc:spChg chg="add mod">
+          <ac:chgData name="Mohammed Fasha" userId="cc64f42d-a1a6-4f08-b97b-0c37f877119f" providerId="ADAL" clId="{534F862C-5423-415F-8625-CCE86B4944CE}" dt="2025-03-15T15:43:27.748" v="1202" actId="1076"/>
+          <ac:spMkLst>
+            <pc:docMk/>
+            <pc:sldMk cId="51728829" sldId="550"/>
+            <ac:spMk id="5" creationId="{E4B45F60-6A90-D73F-5226-35583B598BAF}"/>
+          </ac:spMkLst>
+        </pc:spChg>
+        <pc:picChg chg="add mod">
+          <ac:chgData name="Mohammed Fasha" userId="cc64f42d-a1a6-4f08-b97b-0c37f877119f" providerId="ADAL" clId="{534F862C-5423-415F-8625-CCE86B4944CE}" dt="2025-03-15T15:46:18.147" v="1203"/>
+          <ac:picMkLst>
+            <pc:docMk/>
+            <pc:sldMk cId="51728829" sldId="550"/>
+            <ac:picMk id="7" creationId="{4E45092A-0334-B657-140F-ACD092334510}"/>
+          </ac:picMkLst>
+        </pc:picChg>
       </pc:sldChg>
       <pc:sldChg chg="addSp delSp modSp new mod modClrScheme chgLayout">
         <pc:chgData name="Mohammed Fasha" userId="cc64f42d-a1a6-4f08-b97b-0c37f877119f" providerId="ADAL" clId="{534F862C-5423-415F-8625-CCE86B4944CE}" dt="2025-03-15T15:03:53.820" v="869"/>
@@ -2618,6 +2637,75 @@
             <pc:docMk/>
             <pc:sldMk cId="1685077969" sldId="555"/>
             <ac:spMk id="5" creationId="{B46EFC3A-E068-E521-28EF-F622AF72DE4A}"/>
+          </ac:spMkLst>
+        </pc:spChg>
+      </pc:sldChg>
+      <pc:sldChg chg="modSp new mod ord">
+        <pc:chgData name="Mohammed Fasha" userId="cc64f42d-a1a6-4f08-b97b-0c37f877119f" providerId="ADAL" clId="{534F862C-5423-415F-8625-CCE86B4944CE}" dt="2025-03-15T15:38:28.503" v="1122"/>
+        <pc:sldMkLst>
+          <pc:docMk/>
+          <pc:sldMk cId="2953760213" sldId="556"/>
+        </pc:sldMkLst>
+        <pc:spChg chg="mod">
+          <ac:chgData name="Mohammed Fasha" userId="cc64f42d-a1a6-4f08-b97b-0c37f877119f" providerId="ADAL" clId="{534F862C-5423-415F-8625-CCE86B4944CE}" dt="2025-03-15T15:35:34.357" v="1071" actId="27636"/>
+          <ac:spMkLst>
+            <pc:docMk/>
+            <pc:sldMk cId="2953760213" sldId="556"/>
+            <ac:spMk id="2" creationId="{AAE809B9-C541-93EC-3335-246077D074AB}"/>
+          </ac:spMkLst>
+        </pc:spChg>
+        <pc:spChg chg="mod">
+          <ac:chgData name="Mohammed Fasha" userId="cc64f42d-a1a6-4f08-b97b-0c37f877119f" providerId="ADAL" clId="{534F862C-5423-415F-8625-CCE86B4944CE}" dt="2025-03-15T15:35:56.072" v="1095" actId="12"/>
+          <ac:spMkLst>
+            <pc:docMk/>
+            <pc:sldMk cId="2953760213" sldId="556"/>
+            <ac:spMk id="3" creationId="{69D30B70-3D40-0B59-B5B7-CE324493CD2A}"/>
+          </ac:spMkLst>
+        </pc:spChg>
+      </pc:sldChg>
+      <pc:sldChg chg="modSp new mod">
+        <pc:chgData name="Mohammed Fasha" userId="cc64f42d-a1a6-4f08-b97b-0c37f877119f" providerId="ADAL" clId="{534F862C-5423-415F-8625-CCE86B4944CE}" dt="2025-03-15T15:38:18.785" v="1118" actId="12"/>
+        <pc:sldMkLst>
+          <pc:docMk/>
+          <pc:sldMk cId="47443413" sldId="557"/>
+        </pc:sldMkLst>
+        <pc:spChg chg="mod">
+          <ac:chgData name="Mohammed Fasha" userId="cc64f42d-a1a6-4f08-b97b-0c37f877119f" providerId="ADAL" clId="{534F862C-5423-415F-8625-CCE86B4944CE}" dt="2025-03-15T15:38:07.870" v="1116" actId="27636"/>
+          <ac:spMkLst>
+            <pc:docMk/>
+            <pc:sldMk cId="47443413" sldId="557"/>
+            <ac:spMk id="2" creationId="{67BDB5D0-D88F-6743-CED4-6F576F09C5F4}"/>
+          </ac:spMkLst>
+        </pc:spChg>
+        <pc:spChg chg="mod">
+          <ac:chgData name="Mohammed Fasha" userId="cc64f42d-a1a6-4f08-b97b-0c37f877119f" providerId="ADAL" clId="{534F862C-5423-415F-8625-CCE86B4944CE}" dt="2025-03-15T15:38:18.785" v="1118" actId="12"/>
+          <ac:spMkLst>
+            <pc:docMk/>
+            <pc:sldMk cId="47443413" sldId="557"/>
+            <ac:spMk id="3" creationId="{F7989134-F312-1A22-436B-CB5CF1A8549A}"/>
+          </ac:spMkLst>
+        </pc:spChg>
+      </pc:sldChg>
+      <pc:sldChg chg="modSp new mod">
+        <pc:chgData name="Mohammed Fasha" userId="cc64f42d-a1a6-4f08-b97b-0c37f877119f" providerId="ADAL" clId="{534F862C-5423-415F-8625-CCE86B4944CE}" dt="2025-03-15T15:40:29.246" v="1136" actId="20577"/>
+        <pc:sldMkLst>
+          <pc:docMk/>
+          <pc:sldMk cId="421367154" sldId="558"/>
+        </pc:sldMkLst>
+        <pc:spChg chg="mod">
+          <ac:chgData name="Mohammed Fasha" userId="cc64f42d-a1a6-4f08-b97b-0c37f877119f" providerId="ADAL" clId="{534F862C-5423-415F-8625-CCE86B4944CE}" dt="2025-03-15T15:40:29.246" v="1136" actId="20577"/>
+          <ac:spMkLst>
+            <pc:docMk/>
+            <pc:sldMk cId="421367154" sldId="558"/>
+            <ac:spMk id="2" creationId="{B21FD281-A534-66DD-A1FD-4A9DBA92E8BE}"/>
+          </ac:spMkLst>
+        </pc:spChg>
+        <pc:spChg chg="mod">
+          <ac:chgData name="Mohammed Fasha" userId="cc64f42d-a1a6-4f08-b97b-0c37f877119f" providerId="ADAL" clId="{534F862C-5423-415F-8625-CCE86B4944CE}" dt="2025-03-15T15:40:25.174" v="1126" actId="21"/>
+          <ac:spMkLst>
+            <pc:docMk/>
+            <pc:sldMk cId="421367154" sldId="558"/>
+            <ac:spMk id="3" creationId="{13B04378-246B-4FE4-2C64-C63653A45260}"/>
           </ac:spMkLst>
         </pc:spChg>
       </pc:sldChg>
@@ -6433,22 +6521,18 @@
               <a:t>307307</a:t>
             </a:r>
             <a:br>
-              <a:rPr lang="en-US" sz="3600"/>
+              <a:rPr lang="en-US" sz="3600" dirty="0"/>
             </a:br>
             <a:r>
-              <a:rPr lang="en-US" sz="3600"/>
+              <a:rPr lang="en-US" sz="3600" dirty="0"/>
               <a:t>Introduction to Text Mining and </a:t>
             </a:r>
             <a:br>
-              <a:rPr lang="en-US" sz="3600"/>
+              <a:rPr lang="en-US" sz="3600" dirty="0"/>
             </a:br>
             <a:r>
-              <a:rPr lang="en-US" sz="3600"/>
-              <a:t>Natural </a:t>
-            </a:r>
-            <a:r>
               <a:rPr lang="en-US" sz="3600" dirty="0"/>
-              <a:t>Language Processing</a:t>
+              <a:t>Natural Language Processing</a:t>
             </a:r>
           </a:p>
         </p:txBody>
@@ -10970,7 +11054,12 @@
             <p:ph idx="1"/>
           </p:nvPr>
         </p:nvSpPr>
-        <p:spPr/>
+        <p:spPr>
+          <a:xfrm>
+            <a:off x="838200" y="1706008"/>
+            <a:ext cx="10515600" cy="3009684"/>
+          </a:xfrm>
+        </p:spPr>
         <p:txBody>
           <a:bodyPr/>
           <a:lstStyle/>
@@ -11017,6 +11106,245 @@
           </a:p>
         </p:txBody>
       </p:sp>
+      <p:sp>
+        <p:nvSpPr>
+          <p:cNvPr id="5" name="Content Placeholder 2">
+            <a:extLst>
+              <a:ext uri="{FF2B5EF4-FFF2-40B4-BE49-F238E27FC236}">
+                <a16:creationId xmlns:a16="http://schemas.microsoft.com/office/drawing/2014/main" id="{E4B45F60-6A90-D73F-5226-35583B598BAF}"/>
+              </a:ext>
+            </a:extLst>
+          </p:cNvPr>
+          <p:cNvSpPr txBox="1">
+            <a:spLocks/>
+          </p:cNvSpPr>
+          <p:nvPr/>
+        </p:nvSpPr>
+        <p:spPr>
+          <a:xfrm>
+            <a:off x="3503025" y="5256704"/>
+            <a:ext cx="2114006" cy="399925"/>
+          </a:xfrm>
+          <a:prstGeom prst="rect">
+            <a:avLst/>
+          </a:prstGeom>
+        </p:spPr>
+        <p:txBody>
+          <a:bodyPr vert="horz" lIns="91440" tIns="45720" rIns="91440" bIns="45720" rtlCol="0">
+            <a:normAutofit fontScale="92500"/>
+          </a:bodyPr>
+          <a:lstStyle>
+            <a:lvl1pPr marL="228600" indent="-228600" algn="l" defTabSz="914400" rtl="0" eaLnBrk="1" latinLnBrk="0" hangingPunct="1">
+              <a:lnSpc>
+                <a:spcPct val="90000"/>
+              </a:lnSpc>
+              <a:spcBef>
+                <a:spcPts val="1000"/>
+              </a:spcBef>
+              <a:buFont typeface="Arial" panose="020B0604020202020204" pitchFamily="34" charset="0"/>
+              <a:buChar char="•"/>
+              <a:defRPr sz="2400" kern="1200">
+                <a:solidFill>
+                  <a:schemeClr val="tx1"/>
+                </a:solidFill>
+                <a:latin typeface="+mn-lt"/>
+                <a:ea typeface="+mn-ea"/>
+                <a:cs typeface="+mn-cs"/>
+              </a:defRPr>
+            </a:lvl1pPr>
+            <a:lvl2pPr marL="685800" indent="-228600" algn="l" defTabSz="914400" rtl="0" eaLnBrk="1" latinLnBrk="0" hangingPunct="1">
+              <a:lnSpc>
+                <a:spcPct val="90000"/>
+              </a:lnSpc>
+              <a:spcBef>
+                <a:spcPts val="500"/>
+              </a:spcBef>
+              <a:buFont typeface="Arial" panose="020B0604020202020204" pitchFamily="34" charset="0"/>
+              <a:buChar char="•"/>
+              <a:defRPr sz="2000" kern="1200">
+                <a:solidFill>
+                  <a:schemeClr val="tx1"/>
+                </a:solidFill>
+                <a:latin typeface="+mn-lt"/>
+                <a:ea typeface="+mn-ea"/>
+                <a:cs typeface="+mn-cs"/>
+              </a:defRPr>
+            </a:lvl2pPr>
+            <a:lvl3pPr marL="1143000" indent="-228600" algn="l" defTabSz="914400" rtl="0" eaLnBrk="1" latinLnBrk="0" hangingPunct="1">
+              <a:lnSpc>
+                <a:spcPct val="90000"/>
+              </a:lnSpc>
+              <a:spcBef>
+                <a:spcPts val="500"/>
+              </a:spcBef>
+              <a:buFont typeface="Arial" panose="020B0604020202020204" pitchFamily="34" charset="0"/>
+              <a:buChar char="•"/>
+              <a:defRPr sz="1800" kern="1200">
+                <a:solidFill>
+                  <a:schemeClr val="tx1"/>
+                </a:solidFill>
+                <a:latin typeface="+mn-lt"/>
+                <a:ea typeface="+mn-ea"/>
+                <a:cs typeface="+mn-cs"/>
+              </a:defRPr>
+            </a:lvl3pPr>
+            <a:lvl4pPr marL="1600200" indent="-228600" algn="l" defTabSz="914400" rtl="0" eaLnBrk="1" latinLnBrk="0" hangingPunct="1">
+              <a:lnSpc>
+                <a:spcPct val="90000"/>
+              </a:lnSpc>
+              <a:spcBef>
+                <a:spcPts val="500"/>
+              </a:spcBef>
+              <a:buFont typeface="Arial" panose="020B0604020202020204" pitchFamily="34" charset="0"/>
+              <a:buChar char="•"/>
+              <a:defRPr sz="1600" kern="1200">
+                <a:solidFill>
+                  <a:schemeClr val="tx1"/>
+                </a:solidFill>
+                <a:latin typeface="+mn-lt"/>
+                <a:ea typeface="+mn-ea"/>
+                <a:cs typeface="+mn-cs"/>
+              </a:defRPr>
+            </a:lvl4pPr>
+            <a:lvl5pPr marL="2057400" indent="-228600" algn="l" defTabSz="914400" rtl="0" eaLnBrk="1" latinLnBrk="0" hangingPunct="1">
+              <a:lnSpc>
+                <a:spcPct val="90000"/>
+              </a:lnSpc>
+              <a:spcBef>
+                <a:spcPts val="500"/>
+              </a:spcBef>
+              <a:buFont typeface="Arial" panose="020B0604020202020204" pitchFamily="34" charset="0"/>
+              <a:buChar char="•"/>
+              <a:defRPr sz="1600" kern="1200">
+                <a:solidFill>
+                  <a:schemeClr val="tx1"/>
+                </a:solidFill>
+                <a:latin typeface="+mn-lt"/>
+                <a:ea typeface="+mn-ea"/>
+                <a:cs typeface="+mn-cs"/>
+              </a:defRPr>
+            </a:lvl5pPr>
+            <a:lvl6pPr marL="2514600" indent="-228600" algn="l" defTabSz="914400" rtl="0" eaLnBrk="1" latinLnBrk="0" hangingPunct="1">
+              <a:lnSpc>
+                <a:spcPct val="90000"/>
+              </a:lnSpc>
+              <a:spcBef>
+                <a:spcPts val="500"/>
+              </a:spcBef>
+              <a:buFont typeface="Arial" panose="020B0604020202020204" pitchFamily="34" charset="0"/>
+              <a:buChar char="•"/>
+              <a:defRPr sz="1800" kern="1200">
+                <a:solidFill>
+                  <a:schemeClr val="tx1"/>
+                </a:solidFill>
+                <a:latin typeface="+mn-lt"/>
+                <a:ea typeface="+mn-ea"/>
+                <a:cs typeface="+mn-cs"/>
+              </a:defRPr>
+            </a:lvl6pPr>
+            <a:lvl7pPr marL="2971800" indent="-228600" algn="l" defTabSz="914400" rtl="0" eaLnBrk="1" latinLnBrk="0" hangingPunct="1">
+              <a:lnSpc>
+                <a:spcPct val="90000"/>
+              </a:lnSpc>
+              <a:spcBef>
+                <a:spcPts val="500"/>
+              </a:spcBef>
+              <a:buFont typeface="Arial" panose="020B0604020202020204" pitchFamily="34" charset="0"/>
+              <a:buChar char="•"/>
+              <a:defRPr sz="1800" kern="1200">
+                <a:solidFill>
+                  <a:schemeClr val="tx1"/>
+                </a:solidFill>
+                <a:latin typeface="+mn-lt"/>
+                <a:ea typeface="+mn-ea"/>
+                <a:cs typeface="+mn-cs"/>
+              </a:defRPr>
+            </a:lvl7pPr>
+            <a:lvl8pPr marL="3429000" indent="-228600" algn="l" defTabSz="914400" rtl="0" eaLnBrk="1" latinLnBrk="0" hangingPunct="1">
+              <a:lnSpc>
+                <a:spcPct val="90000"/>
+              </a:lnSpc>
+              <a:spcBef>
+                <a:spcPts val="500"/>
+              </a:spcBef>
+              <a:buFont typeface="Arial" panose="020B0604020202020204" pitchFamily="34" charset="0"/>
+              <a:buChar char="•"/>
+              <a:defRPr sz="1800" kern="1200">
+                <a:solidFill>
+                  <a:schemeClr val="tx1"/>
+                </a:solidFill>
+                <a:latin typeface="+mn-lt"/>
+                <a:ea typeface="+mn-ea"/>
+                <a:cs typeface="+mn-cs"/>
+              </a:defRPr>
+            </a:lvl8pPr>
+            <a:lvl9pPr marL="3886200" indent="-228600" algn="l" defTabSz="914400" rtl="0" eaLnBrk="1" latinLnBrk="0" hangingPunct="1">
+              <a:lnSpc>
+                <a:spcPct val="90000"/>
+              </a:lnSpc>
+              <a:spcBef>
+                <a:spcPts val="500"/>
+              </a:spcBef>
+              <a:buFont typeface="Arial" panose="020B0604020202020204" pitchFamily="34" charset="0"/>
+              <a:buChar char="•"/>
+              <a:defRPr sz="1800" kern="1200">
+                <a:solidFill>
+                  <a:schemeClr val="tx1"/>
+                </a:solidFill>
+                <a:latin typeface="+mn-lt"/>
+                <a:ea typeface="+mn-ea"/>
+                <a:cs typeface="+mn-cs"/>
+              </a:defRPr>
+            </a:lvl9pPr>
+          </a:lstStyle>
+          <a:p>
+            <a:pPr marL="0" indent="0">
+              <a:buNone/>
+            </a:pPr>
+            <a:r>
+              <a:rPr lang="en-US" dirty="0"/>
+              <a:t>Click to code file</a:t>
+            </a:r>
+          </a:p>
+        </p:txBody>
+      </p:sp>
+      <p:pic>
+        <p:nvPicPr>
+          <p:cNvPr id="7" name="Graphic 6">
+            <a:hlinkClick r:id="rId2"/>
+            <a:extLst>
+              <a:ext uri="{FF2B5EF4-FFF2-40B4-BE49-F238E27FC236}">
+                <a16:creationId xmlns:a16="http://schemas.microsoft.com/office/drawing/2014/main" id="{4E45092A-0334-B657-140F-ACD092334510}"/>
+              </a:ext>
+            </a:extLst>
+          </p:cNvPr>
+          <p:cNvPicPr>
+            <a:picLocks noChangeAspect="1"/>
+          </p:cNvPicPr>
+          <p:nvPr/>
+        </p:nvPicPr>
+        <p:blipFill>
+          <a:blip r:embed="rId3">
+            <a:extLst>
+              <a:ext uri="{96DAC541-7B7A-43D3-8B79-37D633B846F1}">
+                <asvg:svgBlip xmlns:asvg="http://schemas.microsoft.com/office/drawing/2016/SVG/main" r:embed="rId4"/>
+              </a:ext>
+            </a:extLst>
+          </a:blip>
+          <a:stretch>
+            <a:fillRect/>
+          </a:stretch>
+        </p:blipFill>
+        <p:spPr>
+          <a:xfrm>
+            <a:off x="5780450" y="5361417"/>
+            <a:ext cx="1114425" cy="190500"/>
+          </a:xfrm>
+          <a:prstGeom prst="rect">
+            <a:avLst/>
+          </a:prstGeom>
+        </p:spPr>
+      </p:pic>
     </p:spTree>
     <p:extLst>
       <p:ext uri="{BB962C8B-B14F-4D97-AF65-F5344CB8AC3E}">
@@ -19280,7 +19608,7 @@
           <a:p>
             <a:r>
               <a:rPr lang="en-US" dirty="0"/>
-              <a:t>Classical Language Models: N-grams</a:t>
+              <a:t>Language Models: N-grams</a:t>
             </a:r>
           </a:p>
         </p:txBody>
@@ -19304,53 +19632,191 @@
         <p:spPr/>
         <p:txBody>
           <a:bodyPr>
-            <a:normAutofit/>
+            <a:normAutofit fontScale="77500" lnSpcReduction="20000"/>
           </a:bodyPr>
           <a:lstStyle/>
           <a:p>
+            <a:pPr marL="0" indent="0">
+              <a:buNone/>
+            </a:pPr>
             <a:r>
               <a:rPr lang="en-US" dirty="0"/>
-              <a:t>N-gram models were among the earliest statistical language models, predicting the probability of a sequence of words by analyzing patterns in training data.</a:t>
-            </a:r>
-          </a:p>
-          <a:p>
+              <a:t>Language models are statistical or neural models that capture the probability distribution of words or tokens in a language. </a:t>
+            </a:r>
+          </a:p>
+          <a:p>
+            <a:pPr marL="0" indent="0">
+              <a:buNone/>
+            </a:pPr>
             <a:r>
               <a:rPr lang="en-US" dirty="0"/>
-              <a:t>What are N-grams?</a:t>
-            </a:r>
-          </a:p>
-          <a:p>
+              <a:t>They predict the likelihood of a sequence of words occurring together, enabling machines to understand and generate human language.</a:t>
+            </a:r>
+          </a:p>
+          <a:p>
+            <a:pPr>
+              <a:buNone/>
+            </a:pPr>
+            <a:r>
+              <a:rPr lang="en-US" b="1" dirty="0"/>
+              <a:t>Types of Language Models</a:t>
+            </a:r>
+          </a:p>
+          <a:p>
+            <a:pPr>
+              <a:buNone/>
+            </a:pPr>
+            <a:r>
+              <a:rPr lang="en-US" b="1" dirty="0"/>
+              <a:t>1) Statistical Language Models</a:t>
+            </a:r>
+          </a:p>
+          <a:p>
+            <a:pPr>
+              <a:buFont typeface="Arial" panose="020B0604020202020204" pitchFamily="34" charset="0"/>
+              <a:buChar char="•"/>
+            </a:pPr>
+            <a:r>
+              <a:rPr lang="en-US" b="1" dirty="0"/>
+              <a:t>N-gram Models</a:t>
+            </a:r>
             <a:r>
               <a:rPr lang="en-US" dirty="0"/>
-              <a:t>N-grams are contiguous sequences of n items (words, characters, etc.) from a text:</a:t>
-            </a:r>
-          </a:p>
-          <a:p>
-            <a:pPr lvl="1"/>
+              <a:t>: Predict the next word based on the previous N-1 words </a:t>
+            </a:r>
+          </a:p>
+          <a:p>
+            <a:pPr marL="742950" lvl="1" indent="-285750">
+              <a:buFont typeface="Arial" panose="020B0604020202020204" pitchFamily="34" charset="0"/>
+              <a:buChar char="•"/>
+            </a:pPr>
             <a:r>
               <a:rPr lang="en-US" dirty="0"/>
-              <a:t>Unigrams: Single words (e.g., "language")</a:t>
-            </a:r>
-          </a:p>
-          <a:p>
-            <a:pPr lvl="1"/>
+              <a:t>Unigram: P(word) - individual word probabilities</a:t>
+            </a:r>
+          </a:p>
+          <a:p>
+            <a:pPr marL="742950" lvl="1" indent="-285750">
+              <a:buFont typeface="Arial" panose="020B0604020202020204" pitchFamily="34" charset="0"/>
+              <a:buChar char="•"/>
+            </a:pPr>
             <a:r>
               <a:rPr lang="en-US" dirty="0"/>
-              <a:t>Bigrams: Two consecutive words (e.g., "language models")</a:t>
-            </a:r>
-          </a:p>
-          <a:p>
-            <a:pPr lvl="1"/>
+              <a:t>Bigram: P(word₂|word₁) - probability of word₂ given word₁</a:t>
+            </a:r>
+          </a:p>
+          <a:p>
+            <a:pPr marL="742950" lvl="1" indent="-285750">
+              <a:buFont typeface="Arial" panose="020B0604020202020204" pitchFamily="34" charset="0"/>
+              <a:buChar char="•"/>
+            </a:pPr>
             <a:r>
               <a:rPr lang="en-US" dirty="0"/>
-              <a:t>Trigrams: Three consecutive words (e.g., "large language models")</a:t>
-            </a:r>
-          </a:p>
-          <a:p>
-            <a:pPr marL="0" indent="0">
-              <a:buNone/>
-            </a:pPr>
-            <a:endParaRPr lang="en-US" dirty="0"/>
+              <a:t>Trigram: P(word₃|</a:t>
+            </a:r>
+            <a:r>
+              <a:rPr lang="en-US" dirty="0" err="1"/>
+              <a:t>word₁,word</a:t>
+            </a:r>
+            <a:r>
+              <a:rPr lang="en-US" dirty="0"/>
+              <a:t>₂) - probability of word₃ given word₁ and word₂</a:t>
+            </a:r>
+          </a:p>
+          <a:p>
+            <a:pPr>
+              <a:buNone/>
+            </a:pPr>
+            <a:r>
+              <a:rPr lang="en-US" b="1" dirty="0"/>
+              <a:t>2) Neural Language Models</a:t>
+            </a:r>
+          </a:p>
+          <a:p>
+            <a:pPr>
+              <a:buFont typeface="Arial" panose="020B0604020202020204" pitchFamily="34" charset="0"/>
+              <a:buChar char="•"/>
+            </a:pPr>
+            <a:r>
+              <a:rPr lang="en-US" b="1" dirty="0"/>
+              <a:t>RNN/LSTM-based</a:t>
+            </a:r>
+            <a:r>
+              <a:rPr lang="en-US" dirty="0"/>
+              <a:t>: Process sequences by maintaining hidden states </a:t>
+            </a:r>
+          </a:p>
+          <a:p>
+            <a:pPr marL="742950" lvl="1" indent="-285750">
+              <a:buFont typeface="Arial" panose="020B0604020202020204" pitchFamily="34" charset="0"/>
+              <a:buChar char="•"/>
+            </a:pPr>
+            <a:r>
+              <a:rPr lang="en-US" dirty="0"/>
+              <a:t>Better at capturing long-range dependencies than n-grams</a:t>
+            </a:r>
+          </a:p>
+          <a:p>
+            <a:pPr marL="742950" lvl="1" indent="-285750">
+              <a:buFont typeface="Arial" panose="020B0604020202020204" pitchFamily="34" charset="0"/>
+              <a:buChar char="•"/>
+            </a:pPr>
+            <a:r>
+              <a:rPr lang="en-US" dirty="0"/>
+              <a:t>Examples: Early versions of Google Translate</a:t>
+            </a:r>
+          </a:p>
+          <a:p>
+            <a:pPr>
+              <a:buFont typeface="Arial" panose="020B0604020202020204" pitchFamily="34" charset="0"/>
+              <a:buChar char="•"/>
+            </a:pPr>
+            <a:r>
+              <a:rPr lang="en-US" b="1" dirty="0"/>
+              <a:t>Transformer-based</a:t>
+            </a:r>
+            <a:r>
+              <a:rPr lang="en-US" dirty="0"/>
+              <a:t>: Use attention mechanisms to process entire sequences </a:t>
+            </a:r>
+          </a:p>
+          <a:p>
+            <a:pPr marL="742950" lvl="1" indent="-285750">
+              <a:buFont typeface="Arial" panose="020B0604020202020204" pitchFamily="34" charset="0"/>
+              <a:buChar char="•"/>
+            </a:pPr>
+            <a:r>
+              <a:rPr lang="en-US" dirty="0"/>
+              <a:t>BERT: Bidirectional, focuses on understanding context</a:t>
+            </a:r>
+          </a:p>
+          <a:p>
+            <a:pPr marL="742950" lvl="1" indent="-285750">
+              <a:buFont typeface="Arial" panose="020B0604020202020204" pitchFamily="34" charset="0"/>
+              <a:buChar char="•"/>
+            </a:pPr>
+            <a:r>
+              <a:rPr lang="en-US" dirty="0"/>
+              <a:t>GPT: Autoregressive, focuses on text generation</a:t>
+            </a:r>
+          </a:p>
+          <a:p>
+            <a:pPr marL="742950" lvl="1" indent="-285750">
+              <a:buFont typeface="Arial" panose="020B0604020202020204" pitchFamily="34" charset="0"/>
+              <a:buChar char="•"/>
+            </a:pPr>
+            <a:r>
+              <a:rPr lang="en-US" dirty="0"/>
+              <a:t>T5, </a:t>
+            </a:r>
+            <a:r>
+              <a:rPr lang="en-US" dirty="0" err="1"/>
+              <a:t>RoBERTa</a:t>
+            </a:r>
+            <a:r>
+              <a:rPr lang="en-US" dirty="0"/>
+              <a:t>, ELECTRA: Refinements of transformer architecture</a:t>
+            </a:r>
           </a:p>
         </p:txBody>
       </p:sp>
@@ -19592,6 +20058,280 @@
   <p:cSld>
     <p:spTree>
       <p:nvGrpSpPr>
+        <p:cNvPr id="1" name=""/>
+        <p:cNvGrpSpPr/>
+        <p:nvPr/>
+      </p:nvGrpSpPr>
+      <p:grpSpPr>
+        <a:xfrm>
+          <a:off x="0" y="0"/>
+          <a:ext cx="0" cy="0"/>
+          <a:chOff x="0" y="0"/>
+          <a:chExt cx="0" cy="0"/>
+        </a:xfrm>
+      </p:grpSpPr>
+      <p:sp>
+        <p:nvSpPr>
+          <p:cNvPr id="2" name="Title 1">
+            <a:extLst>
+              <a:ext uri="{FF2B5EF4-FFF2-40B4-BE49-F238E27FC236}">
+                <a16:creationId xmlns:a16="http://schemas.microsoft.com/office/drawing/2014/main" id="{67BDB5D0-D88F-6743-CED4-6F576F09C5F4}"/>
+              </a:ext>
+            </a:extLst>
+          </p:cNvPr>
+          <p:cNvSpPr>
+            <a:spLocks noGrp="1"/>
+          </p:cNvSpPr>
+          <p:nvPr>
+            <p:ph type="title"/>
+          </p:nvPr>
+        </p:nvSpPr>
+        <p:spPr/>
+        <p:txBody>
+          <a:bodyPr>
+            <a:normAutofit/>
+          </a:bodyPr>
+          <a:lstStyle/>
+          <a:p>
+            <a:r>
+              <a:rPr lang="en-US" b="1" dirty="0"/>
+              <a:t>Core Concepts</a:t>
+            </a:r>
+            <a:endParaRPr lang="en-US" dirty="0"/>
+          </a:p>
+        </p:txBody>
+      </p:sp>
+      <p:sp>
+        <p:nvSpPr>
+          <p:cNvPr id="3" name="Content Placeholder 2">
+            <a:extLst>
+              <a:ext uri="{FF2B5EF4-FFF2-40B4-BE49-F238E27FC236}">
+                <a16:creationId xmlns:a16="http://schemas.microsoft.com/office/drawing/2014/main" id="{F7989134-F312-1A22-436B-CB5CF1A8549A}"/>
+              </a:ext>
+            </a:extLst>
+          </p:cNvPr>
+          <p:cNvSpPr>
+            <a:spLocks noGrp="1"/>
+          </p:cNvSpPr>
+          <p:nvPr>
+            <p:ph idx="1"/>
+          </p:nvPr>
+        </p:nvSpPr>
+        <p:spPr/>
+        <p:txBody>
+          <a:bodyPr>
+            <a:normAutofit fontScale="92500" lnSpcReduction="20000"/>
+          </a:bodyPr>
+          <a:lstStyle/>
+          <a:p>
+            <a:pPr>
+              <a:buFont typeface="+mj-lt"/>
+              <a:buAutoNum type="arabicPeriod"/>
+            </a:pPr>
+            <a:r>
+              <a:rPr lang="en-US" b="1" dirty="0"/>
+              <a:t>Tokenization</a:t>
+            </a:r>
+            <a:r>
+              <a:rPr lang="en-US" dirty="0"/>
+              <a:t>: Breaking text into tokens (words, </a:t>
+            </a:r>
+            <a:r>
+              <a:rPr lang="en-US" dirty="0" err="1"/>
+              <a:t>subwords</a:t>
+            </a:r>
+            <a:r>
+              <a:rPr lang="en-US" dirty="0"/>
+              <a:t>, or characters)</a:t>
+            </a:r>
+          </a:p>
+          <a:p>
+            <a:pPr>
+              <a:buFont typeface="+mj-lt"/>
+              <a:buAutoNum type="arabicPeriod"/>
+            </a:pPr>
+            <a:r>
+              <a:rPr lang="en-US" b="1" dirty="0"/>
+              <a:t>Embeddings</a:t>
+            </a:r>
+            <a:r>
+              <a:rPr lang="en-US" dirty="0"/>
+              <a:t>: Dense vector representations of words/tokens </a:t>
+            </a:r>
+          </a:p>
+          <a:p>
+            <a:pPr lvl="1"/>
+            <a:r>
+              <a:rPr lang="en-US" dirty="0"/>
+              <a:t>Word2Vec, </a:t>
+            </a:r>
+            <a:r>
+              <a:rPr lang="en-US" dirty="0" err="1"/>
+              <a:t>GloVe</a:t>
+            </a:r>
+            <a:r>
+              <a:rPr lang="en-US" dirty="0"/>
+              <a:t>: Context-independent embeddings</a:t>
+            </a:r>
+          </a:p>
+          <a:p>
+            <a:pPr lvl="1"/>
+            <a:r>
+              <a:rPr lang="en-US" dirty="0"/>
+              <a:t>Contextual embeddings: Different representations based on context</a:t>
+            </a:r>
+          </a:p>
+          <a:p>
+            <a:pPr>
+              <a:buFont typeface="+mj-lt"/>
+              <a:buAutoNum type="arabicPeriod"/>
+            </a:pPr>
+            <a:r>
+              <a:rPr lang="en-US" b="1" dirty="0"/>
+              <a:t>Perplexity</a:t>
+            </a:r>
+            <a:r>
+              <a:rPr lang="en-US" dirty="0"/>
+              <a:t>: Evaluation metric measuring how well a model predicts a sample </a:t>
+            </a:r>
+          </a:p>
+          <a:p>
+            <a:pPr lvl="1"/>
+            <a:r>
+              <a:rPr lang="en-US" dirty="0"/>
+              <a:t>Lower perplexity = better prediction</a:t>
+            </a:r>
+          </a:p>
+          <a:p>
+            <a:pPr>
+              <a:buFont typeface="+mj-lt"/>
+              <a:buAutoNum type="arabicPeriod"/>
+            </a:pPr>
+            <a:r>
+              <a:rPr lang="en-US" b="1" dirty="0"/>
+              <a:t>Fine-tuning</a:t>
+            </a:r>
+            <a:r>
+              <a:rPr lang="en-US" dirty="0"/>
+              <a:t>: Adapting pre-trained models to specific tasks</a:t>
+            </a:r>
+          </a:p>
+          <a:p>
+            <a:pPr>
+              <a:buNone/>
+            </a:pPr>
+            <a:r>
+              <a:rPr lang="en-US" b="1" dirty="0"/>
+              <a:t>Applications</a:t>
+            </a:r>
+          </a:p>
+          <a:p>
+            <a:pPr>
+              <a:buFont typeface="Arial" panose="020B0604020202020204" pitchFamily="34" charset="0"/>
+              <a:buChar char="•"/>
+            </a:pPr>
+            <a:r>
+              <a:rPr lang="en-US" b="1" dirty="0"/>
+              <a:t>Text Generation</a:t>
+            </a:r>
+            <a:r>
+              <a:rPr lang="en-US" dirty="0"/>
+              <a:t>: Writing assistance, content creation</a:t>
+            </a:r>
+          </a:p>
+          <a:p>
+            <a:pPr>
+              <a:buFont typeface="Arial" panose="020B0604020202020204" pitchFamily="34" charset="0"/>
+              <a:buChar char="•"/>
+            </a:pPr>
+            <a:r>
+              <a:rPr lang="en-US" b="1" dirty="0"/>
+              <a:t>Machine Translation</a:t>
+            </a:r>
+            <a:r>
+              <a:rPr lang="en-US" dirty="0"/>
+              <a:t>: Converting text between languages</a:t>
+            </a:r>
+          </a:p>
+          <a:p>
+            <a:pPr>
+              <a:buFont typeface="Arial" panose="020B0604020202020204" pitchFamily="34" charset="0"/>
+              <a:buChar char="•"/>
+            </a:pPr>
+            <a:r>
+              <a:rPr lang="en-US" b="1" dirty="0"/>
+              <a:t>Summarization</a:t>
+            </a:r>
+            <a:r>
+              <a:rPr lang="en-US" dirty="0"/>
+              <a:t>: Condensing documents while preserving meaning</a:t>
+            </a:r>
+          </a:p>
+          <a:p>
+            <a:pPr>
+              <a:buFont typeface="Arial" panose="020B0604020202020204" pitchFamily="34" charset="0"/>
+              <a:buChar char="•"/>
+            </a:pPr>
+            <a:r>
+              <a:rPr lang="en-US" b="1" dirty="0"/>
+              <a:t>Question Answering</a:t>
+            </a:r>
+            <a:r>
+              <a:rPr lang="en-US" dirty="0"/>
+              <a:t>: Understanding and responding to queries</a:t>
+            </a:r>
+          </a:p>
+          <a:p>
+            <a:pPr>
+              <a:buFont typeface="Arial" panose="020B0604020202020204" pitchFamily="34" charset="0"/>
+              <a:buChar char="•"/>
+            </a:pPr>
+            <a:r>
+              <a:rPr lang="en-US" b="1" dirty="0"/>
+              <a:t>Text Classification</a:t>
+            </a:r>
+            <a:r>
+              <a:rPr lang="en-US" dirty="0"/>
+              <a:t>: Sentiment analysis, topic categorization</a:t>
+            </a:r>
+          </a:p>
+          <a:p>
+            <a:pPr>
+              <a:buFont typeface="Arial" panose="020B0604020202020204" pitchFamily="34" charset="0"/>
+              <a:buChar char="•"/>
+            </a:pPr>
+            <a:r>
+              <a:rPr lang="en-US" b="1" dirty="0"/>
+              <a:t>Dialogue Systems</a:t>
+            </a:r>
+            <a:r>
+              <a:rPr lang="en-US" dirty="0"/>
+              <a:t>: Conversational agents and chatbots</a:t>
+            </a:r>
+          </a:p>
+          <a:p>
+            <a:endParaRPr lang="en-US" dirty="0"/>
+          </a:p>
+        </p:txBody>
+      </p:sp>
+    </p:spTree>
+    <p:extLst>
+      <p:ext uri="{BB962C8B-B14F-4D97-AF65-F5344CB8AC3E}">
+        <p14:creationId xmlns:p14="http://schemas.microsoft.com/office/powerpoint/2010/main" val="47443413"/>
+      </p:ext>
+    </p:extLst>
+  </p:cSld>
+  <p:clrMapOvr>
+    <a:masterClrMapping/>
+  </p:clrMapOvr>
+</p:sld>
+</file>
+
+<file path=ppt/slides/slide31.xml><?xml version="1.0" encoding="utf-8"?>
+<p:sld xmlns:a="http://schemas.openxmlformats.org/drawingml/2006/main" xmlns:r="http://schemas.openxmlformats.org/officeDocument/2006/relationships" xmlns:p="http://schemas.openxmlformats.org/presentationml/2006/main">
+  <p:cSld>
+    <p:spTree>
+      <p:nvGrpSpPr>
         <p:cNvPr id="1" name="">
           <a:extLst>
             <a:ext uri="{FF2B5EF4-FFF2-40B4-BE49-F238E27FC236}">
@@ -21729,6 +22469,368 @@
     <p:extLst>
       <p:ext uri="{BB962C8B-B14F-4D97-AF65-F5344CB8AC3E}">
         <p14:creationId xmlns:p14="http://schemas.microsoft.com/office/powerpoint/2010/main" val="1532144506"/>
+      </p:ext>
+    </p:extLst>
+  </p:cSld>
+  <p:clrMapOvr>
+    <a:masterClrMapping/>
+  </p:clrMapOvr>
+</p:sld>
+</file>
+
+<file path=ppt/slides/slide32.xml><?xml version="1.0" encoding="utf-8"?>
+<p:sld xmlns:a="http://schemas.openxmlformats.org/drawingml/2006/main" xmlns:r="http://schemas.openxmlformats.org/officeDocument/2006/relationships" xmlns:p="http://schemas.openxmlformats.org/presentationml/2006/main">
+  <p:cSld>
+    <p:spTree>
+      <p:nvGrpSpPr>
+        <p:cNvPr id="1" name=""/>
+        <p:cNvGrpSpPr/>
+        <p:nvPr/>
+      </p:nvGrpSpPr>
+      <p:grpSpPr>
+        <a:xfrm>
+          <a:off x="0" y="0"/>
+          <a:ext cx="0" cy="0"/>
+          <a:chOff x="0" y="0"/>
+          <a:chExt cx="0" cy="0"/>
+        </a:xfrm>
+      </p:grpSpPr>
+      <p:sp>
+        <p:nvSpPr>
+          <p:cNvPr id="2" name="Title 1">
+            <a:extLst>
+              <a:ext uri="{FF2B5EF4-FFF2-40B4-BE49-F238E27FC236}">
+                <a16:creationId xmlns:a16="http://schemas.microsoft.com/office/drawing/2014/main" id="{AAE809B9-C541-93EC-3335-246077D074AB}"/>
+              </a:ext>
+            </a:extLst>
+          </p:cNvPr>
+          <p:cNvSpPr>
+            <a:spLocks noGrp="1"/>
+          </p:cNvSpPr>
+          <p:nvPr>
+            <p:ph type="title"/>
+          </p:nvPr>
+        </p:nvSpPr>
+        <p:spPr/>
+        <p:txBody>
+          <a:bodyPr>
+            <a:normAutofit/>
+          </a:bodyPr>
+          <a:lstStyle/>
+          <a:p>
+            <a:r>
+              <a:rPr lang="en-US" dirty="0"/>
+              <a:t>Limitations of N-gram Models</a:t>
+            </a:r>
+          </a:p>
+        </p:txBody>
+      </p:sp>
+      <p:sp>
+        <p:nvSpPr>
+          <p:cNvPr id="3" name="Content Placeholder 2">
+            <a:extLst>
+              <a:ext uri="{FF2B5EF4-FFF2-40B4-BE49-F238E27FC236}">
+                <a16:creationId xmlns:a16="http://schemas.microsoft.com/office/drawing/2014/main" id="{69D30B70-3D40-0B59-B5B7-CE324493CD2A}"/>
+              </a:ext>
+            </a:extLst>
+          </p:cNvPr>
+          <p:cNvSpPr>
+            <a:spLocks noGrp="1"/>
+          </p:cNvSpPr>
+          <p:nvPr>
+            <p:ph idx="1"/>
+          </p:nvPr>
+        </p:nvSpPr>
+        <p:spPr/>
+        <p:txBody>
+          <a:bodyPr/>
+          <a:lstStyle/>
+          <a:p>
+            <a:r>
+              <a:rPr lang="en-US" dirty="0"/>
+              <a:t>Limited context: Only consider a fixed number of previous words</a:t>
+            </a:r>
+          </a:p>
+          <a:p>
+            <a:r>
+              <a:rPr lang="en-US" dirty="0"/>
+              <a:t>Data sparsity: Many valid word combinations don't appear in training data</a:t>
+            </a:r>
+          </a:p>
+          <a:p>
+            <a:r>
+              <a:rPr lang="en-US" dirty="0"/>
+              <a:t>No semantic understanding: Model captures statistical patterns but not meaning</a:t>
+            </a:r>
+          </a:p>
+          <a:p>
+            <a:r>
+              <a:rPr lang="en-US" dirty="0"/>
+              <a:t>Memory intensive: Storing all possible n-grams requires significant space</a:t>
+            </a:r>
+          </a:p>
+          <a:p>
+            <a:r>
+              <a:rPr lang="en-US" dirty="0"/>
+              <a:t>No long-range dependencies: Cannot capture relationships between distant words</a:t>
+            </a:r>
+          </a:p>
+        </p:txBody>
+      </p:sp>
+    </p:spTree>
+    <p:extLst>
+      <p:ext uri="{BB962C8B-B14F-4D97-AF65-F5344CB8AC3E}">
+        <p14:creationId xmlns:p14="http://schemas.microsoft.com/office/powerpoint/2010/main" val="2953760213"/>
+      </p:ext>
+    </p:extLst>
+  </p:cSld>
+  <p:clrMapOvr>
+    <a:masterClrMapping/>
+  </p:clrMapOvr>
+</p:sld>
+</file>
+
+<file path=ppt/slides/slide33.xml><?xml version="1.0" encoding="utf-8"?>
+<p:sld xmlns:a="http://schemas.openxmlformats.org/drawingml/2006/main" xmlns:r="http://schemas.openxmlformats.org/officeDocument/2006/relationships" xmlns:p="http://schemas.openxmlformats.org/presentationml/2006/main">
+  <p:cSld>
+    <p:spTree>
+      <p:nvGrpSpPr>
+        <p:cNvPr id="1" name=""/>
+        <p:cNvGrpSpPr/>
+        <p:nvPr/>
+      </p:nvGrpSpPr>
+      <p:grpSpPr>
+        <a:xfrm>
+          <a:off x="0" y="0"/>
+          <a:ext cx="0" cy="0"/>
+          <a:chOff x="0" y="0"/>
+          <a:chExt cx="0" cy="0"/>
+        </a:xfrm>
+      </p:grpSpPr>
+      <p:sp>
+        <p:nvSpPr>
+          <p:cNvPr id="2" name="Title 1">
+            <a:extLst>
+              <a:ext uri="{FF2B5EF4-FFF2-40B4-BE49-F238E27FC236}">
+                <a16:creationId xmlns:a16="http://schemas.microsoft.com/office/drawing/2014/main" id="{B21FD281-A534-66DD-A1FD-4A9DBA92E8BE}"/>
+              </a:ext>
+            </a:extLst>
+          </p:cNvPr>
+          <p:cNvSpPr>
+            <a:spLocks noGrp="1"/>
+          </p:cNvSpPr>
+          <p:nvPr>
+            <p:ph type="title"/>
+          </p:nvPr>
+        </p:nvSpPr>
+        <p:spPr/>
+        <p:txBody>
+          <a:bodyPr/>
+          <a:lstStyle/>
+          <a:p>
+            <a:r>
+              <a:rPr lang="en-US" dirty="0"/>
+              <a:t>Perplexity</a:t>
+            </a:r>
+          </a:p>
+        </p:txBody>
+      </p:sp>
+      <p:sp>
+        <p:nvSpPr>
+          <p:cNvPr id="3" name="Content Placeholder 2">
+            <a:extLst>
+              <a:ext uri="{FF2B5EF4-FFF2-40B4-BE49-F238E27FC236}">
+                <a16:creationId xmlns:a16="http://schemas.microsoft.com/office/drawing/2014/main" id="{13B04378-246B-4FE4-2C64-C63653A45260}"/>
+              </a:ext>
+            </a:extLst>
+          </p:cNvPr>
+          <p:cNvSpPr>
+            <a:spLocks noGrp="1"/>
+          </p:cNvSpPr>
+          <p:nvPr>
+            <p:ph idx="1"/>
+          </p:nvPr>
+        </p:nvSpPr>
+        <p:spPr/>
+        <p:txBody>
+          <a:bodyPr>
+            <a:normAutofit fontScale="55000" lnSpcReduction="20000"/>
+          </a:bodyPr>
+          <a:lstStyle/>
+          <a:p>
+            <a:pPr>
+              <a:buNone/>
+            </a:pPr>
+            <a:r>
+              <a:rPr lang="en-US" dirty="0"/>
+              <a:t>Perplexity measures how confused a language model is when predicting text.</a:t>
+            </a:r>
+          </a:p>
+          <a:p>
+            <a:pPr>
+              <a:buNone/>
+            </a:pPr>
+            <a:r>
+              <a:rPr lang="en-US" b="1" dirty="0"/>
+              <a:t>What It Means</a:t>
+            </a:r>
+          </a:p>
+          <a:p>
+            <a:pPr>
+              <a:buFont typeface="Arial" panose="020B0604020202020204" pitchFamily="34" charset="0"/>
+              <a:buChar char="•"/>
+            </a:pPr>
+            <a:r>
+              <a:rPr lang="en-US" b="1" dirty="0"/>
+              <a:t>Lower perplexity</a:t>
+            </a:r>
+            <a:r>
+              <a:rPr lang="en-US" dirty="0"/>
+              <a:t> = Model is more confident and accurate</a:t>
+            </a:r>
+          </a:p>
+          <a:p>
+            <a:pPr>
+              <a:buFont typeface="Arial" panose="020B0604020202020204" pitchFamily="34" charset="0"/>
+              <a:buChar char="•"/>
+            </a:pPr>
+            <a:r>
+              <a:rPr lang="en-US" b="1" dirty="0"/>
+              <a:t>Higher perplexity</a:t>
+            </a:r>
+            <a:r>
+              <a:rPr lang="en-US" dirty="0"/>
+              <a:t> = Model is more uncertain and confused</a:t>
+            </a:r>
+          </a:p>
+          <a:p>
+            <a:pPr>
+              <a:buNone/>
+            </a:pPr>
+            <a:r>
+              <a:rPr lang="en-US" b="1" dirty="0"/>
+              <a:t>Simple Example</a:t>
+            </a:r>
+          </a:p>
+          <a:p>
+            <a:pPr>
+              <a:buNone/>
+            </a:pPr>
+            <a:r>
+              <a:rPr lang="en-US" dirty="0"/>
+              <a:t>Imagine you're trying to predict the next word in: "I went to the _____"</a:t>
+            </a:r>
+          </a:p>
+          <a:p>
+            <a:pPr>
+              <a:buFont typeface="Arial" panose="020B0604020202020204" pitchFamily="34" charset="0"/>
+              <a:buChar char="•"/>
+            </a:pPr>
+            <a:r>
+              <a:rPr lang="en-US" dirty="0"/>
+              <a:t>A good model might assign high probability to words like "store," "park," "beach"</a:t>
+            </a:r>
+          </a:p>
+          <a:p>
+            <a:pPr>
+              <a:buFont typeface="Arial" panose="020B0604020202020204" pitchFamily="34" charset="0"/>
+              <a:buChar char="•"/>
+            </a:pPr>
+            <a:r>
+              <a:rPr lang="en-US" dirty="0"/>
+              <a:t>A confused model might spread probabilities evenly across thousands of words</a:t>
+            </a:r>
+          </a:p>
+          <a:p>
+            <a:pPr>
+              <a:buNone/>
+            </a:pPr>
+            <a:r>
+              <a:rPr lang="en-US" dirty="0"/>
+              <a:t>Perplexity essentially counts how many reasonable options the model is considering. If the model has a perplexity of 10, it's like the model is equally confused between 10 possible words.</a:t>
+            </a:r>
+          </a:p>
+          <a:p>
+            <a:pPr>
+              <a:buNone/>
+            </a:pPr>
+            <a:r>
+              <a:rPr lang="en-US" b="1" dirty="0"/>
+              <a:t>Real-World Comparison</a:t>
+            </a:r>
+          </a:p>
+          <a:p>
+            <a:pPr>
+              <a:buNone/>
+            </a:pPr>
+            <a:r>
+              <a:rPr lang="en-US" dirty="0"/>
+              <a:t>If your phone keyboard suggests 3 very likely next words, it has low perplexity. If it suggests random unrelated words, it has high perplexity.</a:t>
+            </a:r>
+          </a:p>
+          <a:p>
+            <a:pPr>
+              <a:buNone/>
+            </a:pPr>
+            <a:r>
+              <a:rPr lang="en-US" b="1" dirty="0"/>
+              <a:t>Why It Matters</a:t>
+            </a:r>
+          </a:p>
+          <a:p>
+            <a:pPr>
+              <a:buNone/>
+            </a:pPr>
+            <a:r>
+              <a:rPr lang="en-US" dirty="0"/>
+              <a:t>Think of perplexity as a "confusion score" that helps researchers:</a:t>
+            </a:r>
+          </a:p>
+          <a:p>
+            <a:pPr>
+              <a:buFont typeface="Arial" panose="020B0604020202020204" pitchFamily="34" charset="0"/>
+              <a:buChar char="•"/>
+            </a:pPr>
+            <a:r>
+              <a:rPr lang="en-US" dirty="0"/>
+              <a:t>Compare different language models</a:t>
+            </a:r>
+          </a:p>
+          <a:p>
+            <a:pPr>
+              <a:buFont typeface="Arial" panose="020B0604020202020204" pitchFamily="34" charset="0"/>
+              <a:buChar char="•"/>
+            </a:pPr>
+            <a:r>
+              <a:rPr lang="en-US" dirty="0"/>
+              <a:t>Check if a model is improving during training</a:t>
+            </a:r>
+          </a:p>
+          <a:p>
+            <a:pPr>
+              <a:buFont typeface="Arial" panose="020B0604020202020204" pitchFamily="34" charset="0"/>
+              <a:buChar char="•"/>
+            </a:pPr>
+            <a:r>
+              <a:rPr lang="en-US" dirty="0"/>
+              <a:t>Identify when a model works better for certain types of text</a:t>
+            </a:r>
+          </a:p>
+          <a:p>
+            <a:r>
+              <a:rPr lang="en-US" dirty="0"/>
+              <a:t>The best language models today have much lower perplexity than older models, which is why they produce more natural-sounding text.</a:t>
+            </a:r>
+          </a:p>
+          <a:p>
+            <a:endParaRPr lang="en-US" dirty="0"/>
+          </a:p>
+        </p:txBody>
+      </p:sp>
+    </p:spTree>
+    <p:extLst>
+      <p:ext uri="{BB962C8B-B14F-4D97-AF65-F5344CB8AC3E}">
+        <p14:creationId xmlns:p14="http://schemas.microsoft.com/office/powerpoint/2010/main" val="421367154"/>
       </p:ext>
     </p:extLst>
   </p:cSld>

</xml_diff>

<commit_message>
convert chapter 1 into pptx
</commit_message>
<xml_diff>
--- a/20242-NLP-LLM/lecture notes/Part 1 - Introduction to NLP/1-introduction to NLP.pptx
+++ b/20242-NLP-LLM/lecture notes/Part 1 - Introduction to NLP/1-introduction to NLP.pptx
@@ -5,7 +5,7 @@
     <p:sldMasterId id="2147483648" r:id="rId1"/>
   </p:sldMasterIdLst>
   <p:notesMasterIdLst>
-    <p:notesMasterId r:id="rId35"/>
+    <p:notesMasterId r:id="rId36"/>
   </p:notesMasterIdLst>
   <p:sldIdLst>
     <p:sldId id="455" r:id="rId2"/>
@@ -22,25 +22,26 @@
     <p:sldId id="536" r:id="rId13"/>
     <p:sldId id="537" r:id="rId14"/>
     <p:sldId id="538" r:id="rId15"/>
-    <p:sldId id="539" r:id="rId16"/>
-    <p:sldId id="542" r:id="rId17"/>
-    <p:sldId id="540" r:id="rId18"/>
-    <p:sldId id="543" r:id="rId19"/>
-    <p:sldId id="544" r:id="rId20"/>
-    <p:sldId id="545" r:id="rId21"/>
-    <p:sldId id="546" r:id="rId22"/>
-    <p:sldId id="551" r:id="rId23"/>
-    <p:sldId id="550" r:id="rId24"/>
-    <p:sldId id="552" r:id="rId25"/>
-    <p:sldId id="553" r:id="rId26"/>
-    <p:sldId id="554" r:id="rId27"/>
-    <p:sldId id="555" r:id="rId28"/>
-    <p:sldId id="549" r:id="rId29"/>
-    <p:sldId id="547" r:id="rId30"/>
-    <p:sldId id="557" r:id="rId31"/>
-    <p:sldId id="548" r:id="rId32"/>
-    <p:sldId id="556" r:id="rId33"/>
-    <p:sldId id="558" r:id="rId34"/>
+    <p:sldId id="559" r:id="rId16"/>
+    <p:sldId id="539" r:id="rId17"/>
+    <p:sldId id="542" r:id="rId18"/>
+    <p:sldId id="540" r:id="rId19"/>
+    <p:sldId id="543" r:id="rId20"/>
+    <p:sldId id="544" r:id="rId21"/>
+    <p:sldId id="545" r:id="rId22"/>
+    <p:sldId id="546" r:id="rId23"/>
+    <p:sldId id="551" r:id="rId24"/>
+    <p:sldId id="550" r:id="rId25"/>
+    <p:sldId id="552" r:id="rId26"/>
+    <p:sldId id="553" r:id="rId27"/>
+    <p:sldId id="554" r:id="rId28"/>
+    <p:sldId id="555" r:id="rId29"/>
+    <p:sldId id="549" r:id="rId30"/>
+    <p:sldId id="547" r:id="rId31"/>
+    <p:sldId id="557" r:id="rId32"/>
+    <p:sldId id="548" r:id="rId33"/>
+    <p:sldId id="556" r:id="rId34"/>
+    <p:sldId id="558" r:id="rId35"/>
   </p:sldIdLst>
   <p:sldSz cx="12192000" cy="6858000"/>
   <p:notesSz cx="6858000" cy="9144000"/>
@@ -166,19 +167,6 @@
 <pc:chgInfo xmlns:a="http://schemas.openxmlformats.org/drawingml/2006/main" xmlns:r="http://schemas.openxmlformats.org/officeDocument/2006/relationships" xmlns:ac="http://schemas.microsoft.com/office/drawing/2013/main/command" xmlns:pc="http://schemas.microsoft.com/office/powerpoint/2013/main/command">
   <pc:docChgLst>
     <pc:chgData name="Mohammed Fasha" userId="cc64f42d-a1a6-4f08-b97b-0c37f877119f" providerId="ADAL" clId="{5980B3BB-4EB6-4E37-92BF-3A2A8F4B2C7A}"/>
-    <pc:docChg chg="custSel modSld">
-      <pc:chgData name="Mohammed Fasha" userId="cc64f42d-a1a6-4f08-b97b-0c37f877119f" providerId="ADAL" clId="{5980B3BB-4EB6-4E37-92BF-3A2A8F4B2C7A}" dt="2024-10-15T02:28:13.535" v="0" actId="478"/>
-      <pc:docMkLst>
-        <pc:docMk/>
-      </pc:docMkLst>
-      <pc:sldChg chg="delSp mod">
-        <pc:chgData name="Mohammed Fasha" userId="cc64f42d-a1a6-4f08-b97b-0c37f877119f" providerId="ADAL" clId="{5980B3BB-4EB6-4E37-92BF-3A2A8F4B2C7A}" dt="2024-10-15T02:28:13.535" v="0" actId="478"/>
-        <pc:sldMkLst>
-          <pc:docMk/>
-          <pc:sldMk cId="2297456757" sldId="483"/>
-        </pc:sldMkLst>
-      </pc:sldChg>
-    </pc:docChg>
   </pc:docChgLst>
   <pc:docChgLst>
     <pc:chgData name="Mohammed Fasha" userId="cc64f42d-a1a6-4f08-b97b-0c37f877119f" providerId="ADAL" clId="{4C71ED24-115E-432D-933D-C801DA3E52F1}"/>
@@ -187,27 +175,6 @@
       <pc:docMkLst>
         <pc:docMk/>
       </pc:docMkLst>
-      <pc:sldChg chg="del">
-        <pc:chgData name="Mohammed Fasha" userId="cc64f42d-a1a6-4f08-b97b-0c37f877119f" providerId="ADAL" clId="{4C71ED24-115E-432D-933D-C801DA3E52F1}" dt="2024-12-29T03:12:48.360" v="0" actId="47"/>
-        <pc:sldMkLst>
-          <pc:docMk/>
-          <pc:sldMk cId="2341000601" sldId="701"/>
-        </pc:sldMkLst>
-      </pc:sldChg>
-      <pc:sldChg chg="del">
-        <pc:chgData name="Mohammed Fasha" userId="cc64f42d-a1a6-4f08-b97b-0c37f877119f" providerId="ADAL" clId="{4C71ED24-115E-432D-933D-C801DA3E52F1}" dt="2024-12-29T03:12:49.133" v="1" actId="47"/>
-        <pc:sldMkLst>
-          <pc:docMk/>
-          <pc:sldMk cId="3519698944" sldId="702"/>
-        </pc:sldMkLst>
-      </pc:sldChg>
-      <pc:sldChg chg="del">
-        <pc:chgData name="Mohammed Fasha" userId="cc64f42d-a1a6-4f08-b97b-0c37f877119f" providerId="ADAL" clId="{4C71ED24-115E-432D-933D-C801DA3E52F1}" dt="2024-12-29T03:12:49.974" v="2" actId="47"/>
-        <pc:sldMkLst>
-          <pc:docMk/>
-          <pc:sldMk cId="3934257344" sldId="703"/>
-        </pc:sldMkLst>
-      </pc:sldChg>
     </pc:docChg>
   </pc:docChgLst>
   <pc:docChgLst>
@@ -217,265 +184,6 @@
       <pc:docMkLst>
         <pc:docMk/>
       </pc:docMkLst>
-      <pc:sldChg chg="modSp mod">
-        <pc:chgData name="Mohammed Fasha" userId="cc64f42d-a1a6-4f08-b97b-0c37f877119f" providerId="ADAL" clId="{BECD4A7F-C1AF-4585-8C31-FE7D4FE3ED16}" dt="2024-12-30T18:47:27.683" v="988" actId="20577"/>
-        <pc:sldMkLst>
-          <pc:docMk/>
-          <pc:sldMk cId="2281221656" sldId="527"/>
-        </pc:sldMkLst>
-      </pc:sldChg>
-      <pc:sldChg chg="modSp mod">
-        <pc:chgData name="Mohammed Fasha" userId="cc64f42d-a1a6-4f08-b97b-0c37f877119f" providerId="ADAL" clId="{BECD4A7F-C1AF-4585-8C31-FE7D4FE3ED16}" dt="2024-12-27T13:59:26.893" v="366" actId="20577"/>
-        <pc:sldMkLst>
-          <pc:docMk/>
-          <pc:sldMk cId="3474268344" sldId="596"/>
-        </pc:sldMkLst>
-      </pc:sldChg>
-      <pc:sldChg chg="modSp mod">
-        <pc:chgData name="Mohammed Fasha" userId="cc64f42d-a1a6-4f08-b97b-0c37f877119f" providerId="ADAL" clId="{BECD4A7F-C1AF-4585-8C31-FE7D4FE3ED16}" dt="2024-12-30T18:44:34.649" v="884" actId="20577"/>
-        <pc:sldMkLst>
-          <pc:docMk/>
-          <pc:sldMk cId="916802035" sldId="651"/>
-        </pc:sldMkLst>
-      </pc:sldChg>
-      <pc:sldChg chg="del">
-        <pc:chgData name="Mohammed Fasha" userId="cc64f42d-a1a6-4f08-b97b-0c37f877119f" providerId="ADAL" clId="{BECD4A7F-C1AF-4585-8C31-FE7D4FE3ED16}" dt="2025-01-05T14:42:38.675" v="989" actId="2696"/>
-        <pc:sldMkLst>
-          <pc:docMk/>
-          <pc:sldMk cId="426516858" sldId="662"/>
-        </pc:sldMkLst>
-      </pc:sldChg>
-      <pc:sldChg chg="modSp add del mod">
-        <pc:chgData name="Mohammed Fasha" userId="cc64f42d-a1a6-4f08-b97b-0c37f877119f" providerId="ADAL" clId="{BECD4A7F-C1AF-4585-8C31-FE7D4FE3ED16}" dt="2025-01-05T16:34:59.233" v="1926" actId="20577"/>
-        <pc:sldMkLst>
-          <pc:docMk/>
-          <pc:sldMk cId="691538069" sldId="662"/>
-        </pc:sldMkLst>
-      </pc:sldChg>
-      <pc:sldChg chg="del">
-        <pc:chgData name="Mohammed Fasha" userId="cc64f42d-a1a6-4f08-b97b-0c37f877119f" providerId="ADAL" clId="{BECD4A7F-C1AF-4585-8C31-FE7D4FE3ED16}" dt="2025-01-05T14:42:38.675" v="989" actId="2696"/>
-        <pc:sldMkLst>
-          <pc:docMk/>
-          <pc:sldMk cId="895445062" sldId="663"/>
-        </pc:sldMkLst>
-      </pc:sldChg>
-      <pc:sldChg chg="add del">
-        <pc:chgData name="Mohammed Fasha" userId="cc64f42d-a1a6-4f08-b97b-0c37f877119f" providerId="ADAL" clId="{BECD4A7F-C1AF-4585-8C31-FE7D4FE3ED16}" dt="2025-01-05T14:43:16.100" v="993" actId="2696"/>
-        <pc:sldMkLst>
-          <pc:docMk/>
-          <pc:sldMk cId="3980180774" sldId="663"/>
-        </pc:sldMkLst>
-      </pc:sldChg>
-      <pc:sldChg chg="add del">
-        <pc:chgData name="Mohammed Fasha" userId="cc64f42d-a1a6-4f08-b97b-0c37f877119f" providerId="ADAL" clId="{BECD4A7F-C1AF-4585-8C31-FE7D4FE3ED16}" dt="2025-01-05T14:43:16.100" v="993" actId="2696"/>
-        <pc:sldMkLst>
-          <pc:docMk/>
-          <pc:sldMk cId="1728680596" sldId="664"/>
-        </pc:sldMkLst>
-      </pc:sldChg>
-      <pc:sldChg chg="del">
-        <pc:chgData name="Mohammed Fasha" userId="cc64f42d-a1a6-4f08-b97b-0c37f877119f" providerId="ADAL" clId="{BECD4A7F-C1AF-4585-8C31-FE7D4FE3ED16}" dt="2025-01-05T14:42:38.675" v="989" actId="2696"/>
-        <pc:sldMkLst>
-          <pc:docMk/>
-          <pc:sldMk cId="3900588277" sldId="664"/>
-        </pc:sldMkLst>
-      </pc:sldChg>
-      <pc:sldChg chg="del">
-        <pc:chgData name="Mohammed Fasha" userId="cc64f42d-a1a6-4f08-b97b-0c37f877119f" providerId="ADAL" clId="{BECD4A7F-C1AF-4585-8C31-FE7D4FE3ED16}" dt="2025-01-05T14:42:38.675" v="989" actId="2696"/>
-        <pc:sldMkLst>
-          <pc:docMk/>
-          <pc:sldMk cId="123002105" sldId="665"/>
-        </pc:sldMkLst>
-      </pc:sldChg>
-      <pc:sldChg chg="modSp add del mod">
-        <pc:chgData name="Mohammed Fasha" userId="cc64f42d-a1a6-4f08-b97b-0c37f877119f" providerId="ADAL" clId="{BECD4A7F-C1AF-4585-8C31-FE7D4FE3ED16}" dt="2025-01-05T15:05:12.729" v="1226" actId="21"/>
-        <pc:sldMkLst>
-          <pc:docMk/>
-          <pc:sldMk cId="148099094" sldId="665"/>
-        </pc:sldMkLst>
-      </pc:sldChg>
-      <pc:sldChg chg="del">
-        <pc:chgData name="Mohammed Fasha" userId="cc64f42d-a1a6-4f08-b97b-0c37f877119f" providerId="ADAL" clId="{BECD4A7F-C1AF-4585-8C31-FE7D4FE3ED16}" dt="2025-01-05T14:42:38.675" v="989" actId="2696"/>
-        <pc:sldMkLst>
-          <pc:docMk/>
-          <pc:sldMk cId="659863378" sldId="676"/>
-        </pc:sldMkLst>
-      </pc:sldChg>
-      <pc:sldChg chg="modSp add del mod">
-        <pc:chgData name="Mohammed Fasha" userId="cc64f42d-a1a6-4f08-b97b-0c37f877119f" providerId="ADAL" clId="{BECD4A7F-C1AF-4585-8C31-FE7D4FE3ED16}" dt="2025-01-05T14:55:27.595" v="1130" actId="255"/>
-        <pc:sldMkLst>
-          <pc:docMk/>
-          <pc:sldMk cId="1577854815" sldId="676"/>
-        </pc:sldMkLst>
-      </pc:sldChg>
-      <pc:sldChg chg="modSp add del mod">
-        <pc:chgData name="Mohammed Fasha" userId="cc64f42d-a1a6-4f08-b97b-0c37f877119f" providerId="ADAL" clId="{BECD4A7F-C1AF-4585-8C31-FE7D4FE3ED16}" dt="2025-01-05T14:55:43.754" v="1132" actId="1076"/>
-        <pc:sldMkLst>
-          <pc:docMk/>
-          <pc:sldMk cId="139882925" sldId="677"/>
-        </pc:sldMkLst>
-      </pc:sldChg>
-      <pc:sldChg chg="del">
-        <pc:chgData name="Mohammed Fasha" userId="cc64f42d-a1a6-4f08-b97b-0c37f877119f" providerId="ADAL" clId="{BECD4A7F-C1AF-4585-8C31-FE7D4FE3ED16}" dt="2025-01-05T14:42:38.675" v="989" actId="2696"/>
-        <pc:sldMkLst>
-          <pc:docMk/>
-          <pc:sldMk cId="2736863534" sldId="677"/>
-        </pc:sldMkLst>
-      </pc:sldChg>
-      <pc:sldChg chg="add del">
-        <pc:chgData name="Mohammed Fasha" userId="cc64f42d-a1a6-4f08-b97b-0c37f877119f" providerId="ADAL" clId="{BECD4A7F-C1AF-4585-8C31-FE7D4FE3ED16}" dt="2025-01-05T14:43:16.100" v="993" actId="2696"/>
-        <pc:sldMkLst>
-          <pc:docMk/>
-          <pc:sldMk cId="4146654093" sldId="678"/>
-        </pc:sldMkLst>
-      </pc:sldChg>
-      <pc:sldChg chg="del">
-        <pc:chgData name="Mohammed Fasha" userId="cc64f42d-a1a6-4f08-b97b-0c37f877119f" providerId="ADAL" clId="{BECD4A7F-C1AF-4585-8C31-FE7D4FE3ED16}" dt="2025-01-05T14:42:38.675" v="989" actId="2696"/>
-        <pc:sldMkLst>
-          <pc:docMk/>
-          <pc:sldMk cId="4228312762" sldId="678"/>
-        </pc:sldMkLst>
-      </pc:sldChg>
-      <pc:sldChg chg="del">
-        <pc:chgData name="Mohammed Fasha" userId="cc64f42d-a1a6-4f08-b97b-0c37f877119f" providerId="ADAL" clId="{BECD4A7F-C1AF-4585-8C31-FE7D4FE3ED16}" dt="2025-01-05T14:42:38.675" v="989" actId="2696"/>
-        <pc:sldMkLst>
-          <pc:docMk/>
-          <pc:sldMk cId="581717462" sldId="679"/>
-        </pc:sldMkLst>
-      </pc:sldChg>
-      <pc:sldChg chg="addSp delSp modSp add del mod chgLayout">
-        <pc:chgData name="Mohammed Fasha" userId="cc64f42d-a1a6-4f08-b97b-0c37f877119f" providerId="ADAL" clId="{BECD4A7F-C1AF-4585-8C31-FE7D4FE3ED16}" dt="2025-01-05T16:36:16.605" v="1945" actId="1076"/>
-        <pc:sldMkLst>
-          <pc:docMk/>
-          <pc:sldMk cId="3454522070" sldId="679"/>
-        </pc:sldMkLst>
-      </pc:sldChg>
-      <pc:sldChg chg="add del">
-        <pc:chgData name="Mohammed Fasha" userId="cc64f42d-a1a6-4f08-b97b-0c37f877119f" providerId="ADAL" clId="{BECD4A7F-C1AF-4585-8C31-FE7D4FE3ED16}" dt="2025-01-05T14:43:16.100" v="993" actId="2696"/>
-        <pc:sldMkLst>
-          <pc:docMk/>
-          <pc:sldMk cId="2856814121" sldId="681"/>
-        </pc:sldMkLst>
-      </pc:sldChg>
-      <pc:sldChg chg="del">
-        <pc:chgData name="Mohammed Fasha" userId="cc64f42d-a1a6-4f08-b97b-0c37f877119f" providerId="ADAL" clId="{BECD4A7F-C1AF-4585-8C31-FE7D4FE3ED16}" dt="2025-01-05T14:42:38.675" v="989" actId="2696"/>
-        <pc:sldMkLst>
-          <pc:docMk/>
-          <pc:sldMk cId="3083966018" sldId="681"/>
-        </pc:sldMkLst>
-      </pc:sldChg>
-      <pc:sldChg chg="modSp mod">
-        <pc:chgData name="Mohammed Fasha" userId="cc64f42d-a1a6-4f08-b97b-0c37f877119f" providerId="ADAL" clId="{BECD4A7F-C1AF-4585-8C31-FE7D4FE3ED16}" dt="2025-01-05T14:42:50.596" v="990" actId="14100"/>
-        <pc:sldMkLst>
-          <pc:docMk/>
-          <pc:sldMk cId="1697141369" sldId="695"/>
-        </pc:sldMkLst>
-      </pc:sldChg>
-      <pc:sldChg chg="addSp delSp modSp add del mod">
-        <pc:chgData name="Mohammed Fasha" userId="cc64f42d-a1a6-4f08-b97b-0c37f877119f" providerId="ADAL" clId="{BECD4A7F-C1AF-4585-8C31-FE7D4FE3ED16}" dt="2025-01-05T14:54:31.375" v="1125" actId="14100"/>
-        <pc:sldMkLst>
-          <pc:docMk/>
-          <pc:sldMk cId="265576630" sldId="698"/>
-        </pc:sldMkLst>
-      </pc:sldChg>
-      <pc:sldChg chg="del">
-        <pc:chgData name="Mohammed Fasha" userId="cc64f42d-a1a6-4f08-b97b-0c37f877119f" providerId="ADAL" clId="{BECD4A7F-C1AF-4585-8C31-FE7D4FE3ED16}" dt="2025-01-05T14:42:38.675" v="989" actId="2696"/>
-        <pc:sldMkLst>
-          <pc:docMk/>
-          <pc:sldMk cId="991725834" sldId="698"/>
-        </pc:sldMkLst>
-      </pc:sldChg>
-      <pc:sldChg chg="del">
-        <pc:chgData name="Mohammed Fasha" userId="cc64f42d-a1a6-4f08-b97b-0c37f877119f" providerId="ADAL" clId="{BECD4A7F-C1AF-4585-8C31-FE7D4FE3ED16}" dt="2025-01-05T14:42:38.675" v="989" actId="2696"/>
-        <pc:sldMkLst>
-          <pc:docMk/>
-          <pc:sldMk cId="3109561867" sldId="700"/>
-        </pc:sldMkLst>
-      </pc:sldChg>
-      <pc:sldChg chg="addSp delSp modSp add del mod">
-        <pc:chgData name="Mohammed Fasha" userId="cc64f42d-a1a6-4f08-b97b-0c37f877119f" providerId="ADAL" clId="{BECD4A7F-C1AF-4585-8C31-FE7D4FE3ED16}" dt="2025-01-05T16:00:05.564" v="1529" actId="20577"/>
-        <pc:sldMkLst>
-          <pc:docMk/>
-          <pc:sldMk cId="4247717824" sldId="700"/>
-        </pc:sldMkLst>
-      </pc:sldChg>
-      <pc:sldChg chg="addSp delSp modSp add mod">
-        <pc:chgData name="Mohammed Fasha" userId="cc64f42d-a1a6-4f08-b97b-0c37f877119f" providerId="ADAL" clId="{BECD4A7F-C1AF-4585-8C31-FE7D4FE3ED16}" dt="2025-01-05T14:53:29.185" v="1101" actId="21"/>
-        <pc:sldMkLst>
-          <pc:docMk/>
-          <pc:sldMk cId="67871309" sldId="709"/>
-        </pc:sldMkLst>
-      </pc:sldChg>
-      <pc:sldChg chg="modSp add mod">
-        <pc:chgData name="Mohammed Fasha" userId="cc64f42d-a1a6-4f08-b97b-0c37f877119f" providerId="ADAL" clId="{BECD4A7F-C1AF-4585-8C31-FE7D4FE3ED16}" dt="2025-01-05T15:31:09.113" v="1385" actId="6549"/>
-        <pc:sldMkLst>
-          <pc:docMk/>
-          <pc:sldMk cId="4114896152" sldId="710"/>
-        </pc:sldMkLst>
-      </pc:sldChg>
-      <pc:sldChg chg="addSp modSp add mod">
-        <pc:chgData name="Mohammed Fasha" userId="cc64f42d-a1a6-4f08-b97b-0c37f877119f" providerId="ADAL" clId="{BECD4A7F-C1AF-4585-8C31-FE7D4FE3ED16}" dt="2025-01-05T15:27:36.027" v="1348" actId="20577"/>
-        <pc:sldMkLst>
-          <pc:docMk/>
-          <pc:sldMk cId="3794385322" sldId="711"/>
-        </pc:sldMkLst>
-      </pc:sldChg>
-      <pc:sldChg chg="add del">
-        <pc:chgData name="Mohammed Fasha" userId="cc64f42d-a1a6-4f08-b97b-0c37f877119f" providerId="ADAL" clId="{BECD4A7F-C1AF-4585-8C31-FE7D4FE3ED16}" dt="2025-01-05T14:57:43.613" v="1146" actId="2696"/>
-        <pc:sldMkLst>
-          <pc:docMk/>
-          <pc:sldMk cId="501127302" sldId="712"/>
-        </pc:sldMkLst>
-      </pc:sldChg>
-      <pc:sldChg chg="modSp add mod">
-        <pc:chgData name="Mohammed Fasha" userId="cc64f42d-a1a6-4f08-b97b-0c37f877119f" providerId="ADAL" clId="{BECD4A7F-C1AF-4585-8C31-FE7D4FE3ED16}" dt="2025-01-05T15:32:23.870" v="1388"/>
-        <pc:sldMkLst>
-          <pc:docMk/>
-          <pc:sldMk cId="3701206727" sldId="712"/>
-        </pc:sldMkLst>
-      </pc:sldChg>
-      <pc:sldChg chg="addSp modSp add mod">
-        <pc:chgData name="Mohammed Fasha" userId="cc64f42d-a1a6-4f08-b97b-0c37f877119f" providerId="ADAL" clId="{BECD4A7F-C1AF-4585-8C31-FE7D4FE3ED16}" dt="2025-01-05T16:06:36.028" v="1538" actId="1076"/>
-        <pc:sldMkLst>
-          <pc:docMk/>
-          <pc:sldMk cId="1499972066" sldId="713"/>
-        </pc:sldMkLst>
-      </pc:sldChg>
-      <pc:sldChg chg="addSp delSp modSp add mod">
-        <pc:chgData name="Mohammed Fasha" userId="cc64f42d-a1a6-4f08-b97b-0c37f877119f" providerId="ADAL" clId="{BECD4A7F-C1AF-4585-8C31-FE7D4FE3ED16}" dt="2025-01-05T16:19:08.436" v="1705" actId="1036"/>
-        <pc:sldMkLst>
-          <pc:docMk/>
-          <pc:sldMk cId="1270641495" sldId="714"/>
-        </pc:sldMkLst>
-      </pc:sldChg>
-      <pc:sldChg chg="addSp modSp new mod">
-        <pc:chgData name="Mohammed Fasha" userId="cc64f42d-a1a6-4f08-b97b-0c37f877119f" providerId="ADAL" clId="{BECD4A7F-C1AF-4585-8C31-FE7D4FE3ED16}" dt="2025-01-05T16:23:44.632" v="1736" actId="12"/>
-        <pc:sldMkLst>
-          <pc:docMk/>
-          <pc:sldMk cId="1096386322" sldId="715"/>
-        </pc:sldMkLst>
-      </pc:sldChg>
-      <pc:sldChg chg="modSp new mod">
-        <pc:chgData name="Mohammed Fasha" userId="cc64f42d-a1a6-4f08-b97b-0c37f877119f" providerId="ADAL" clId="{BECD4A7F-C1AF-4585-8C31-FE7D4FE3ED16}" dt="2025-01-05T16:34:02.360" v="1902" actId="27636"/>
-        <pc:sldMkLst>
-          <pc:docMk/>
-          <pc:sldMk cId="1784058309" sldId="716"/>
-        </pc:sldMkLst>
-      </pc:sldChg>
-      <pc:sldChg chg="modSp add mod ord">
-        <pc:chgData name="Mohammed Fasha" userId="cc64f42d-a1a6-4f08-b97b-0c37f877119f" providerId="ADAL" clId="{BECD4A7F-C1AF-4585-8C31-FE7D4FE3ED16}" dt="2025-01-05T16:27:20.520" v="1803"/>
-        <pc:sldMkLst>
-          <pc:docMk/>
-          <pc:sldMk cId="3139017106" sldId="717"/>
-        </pc:sldMkLst>
-      </pc:sldChg>
-      <pc:sldChg chg="addSp delSp modSp new mod">
-        <pc:chgData name="Mohammed Fasha" userId="cc64f42d-a1a6-4f08-b97b-0c37f877119f" providerId="ADAL" clId="{BECD4A7F-C1AF-4585-8C31-FE7D4FE3ED16}" dt="2025-01-05T16:32:45.446" v="1897" actId="20577"/>
-        <pc:sldMkLst>
-          <pc:docMk/>
-          <pc:sldMk cId="3043812923" sldId="718"/>
-        </pc:sldMkLst>
-      </pc:sldChg>
     </pc:docChg>
   </pc:docChgLst>
   <pc:docChgLst>
@@ -485,356 +193,6 @@
       <pc:docMkLst>
         <pc:docMk/>
       </pc:docMkLst>
-      <pc:sldChg chg="del">
-        <pc:chgData name="Mohammed Fasha" userId="cc64f42d-a1a6-4f08-b97b-0c37f877119f" providerId="ADAL" clId="{1BAE7373-BC78-49F1-9262-209B991CDE28}" dt="2025-03-13T04:04:55.107" v="2" actId="47"/>
-        <pc:sldMkLst>
-          <pc:docMk/>
-          <pc:sldMk cId="89912501" sldId="274"/>
-        </pc:sldMkLst>
-      </pc:sldChg>
-      <pc:sldChg chg="del">
-        <pc:chgData name="Mohammed Fasha" userId="cc64f42d-a1a6-4f08-b97b-0c37f877119f" providerId="ADAL" clId="{1BAE7373-BC78-49F1-9262-209B991CDE28}" dt="2025-03-13T04:04:55.107" v="2" actId="47"/>
-        <pc:sldMkLst>
-          <pc:docMk/>
-          <pc:sldMk cId="1847087325" sldId="283"/>
-        </pc:sldMkLst>
-      </pc:sldChg>
-      <pc:sldChg chg="del">
-        <pc:chgData name="Mohammed Fasha" userId="cc64f42d-a1a6-4f08-b97b-0c37f877119f" providerId="ADAL" clId="{1BAE7373-BC78-49F1-9262-209B991CDE28}" dt="2025-03-13T04:04:55.107" v="2" actId="47"/>
-        <pc:sldMkLst>
-          <pc:docMk/>
-          <pc:sldMk cId="771290671" sldId="284"/>
-        </pc:sldMkLst>
-      </pc:sldChg>
-      <pc:sldChg chg="del">
-        <pc:chgData name="Mohammed Fasha" userId="cc64f42d-a1a6-4f08-b97b-0c37f877119f" providerId="ADAL" clId="{1BAE7373-BC78-49F1-9262-209B991CDE28}" dt="2025-03-13T04:04:55.107" v="2" actId="47"/>
-        <pc:sldMkLst>
-          <pc:docMk/>
-          <pc:sldMk cId="1234327519" sldId="287"/>
-        </pc:sldMkLst>
-      </pc:sldChg>
-      <pc:sldChg chg="del">
-        <pc:chgData name="Mohammed Fasha" userId="cc64f42d-a1a6-4f08-b97b-0c37f877119f" providerId="ADAL" clId="{1BAE7373-BC78-49F1-9262-209B991CDE28}" dt="2025-03-13T04:04:55.107" v="2" actId="47"/>
-        <pc:sldMkLst>
-          <pc:docMk/>
-          <pc:sldMk cId="3304405524" sldId="292"/>
-        </pc:sldMkLst>
-      </pc:sldChg>
-      <pc:sldChg chg="del">
-        <pc:chgData name="Mohammed Fasha" userId="cc64f42d-a1a6-4f08-b97b-0c37f877119f" providerId="ADAL" clId="{1BAE7373-BC78-49F1-9262-209B991CDE28}" dt="2025-03-13T04:04:55.107" v="2" actId="47"/>
-        <pc:sldMkLst>
-          <pc:docMk/>
-          <pc:sldMk cId="1217643332" sldId="294"/>
-        </pc:sldMkLst>
-      </pc:sldChg>
-      <pc:sldChg chg="del">
-        <pc:chgData name="Mohammed Fasha" userId="cc64f42d-a1a6-4f08-b97b-0c37f877119f" providerId="ADAL" clId="{1BAE7373-BC78-49F1-9262-209B991CDE28}" dt="2025-03-13T04:04:55.107" v="2" actId="47"/>
-        <pc:sldMkLst>
-          <pc:docMk/>
-          <pc:sldMk cId="3526654973" sldId="295"/>
-        </pc:sldMkLst>
-      </pc:sldChg>
-      <pc:sldChg chg="del">
-        <pc:chgData name="Mohammed Fasha" userId="cc64f42d-a1a6-4f08-b97b-0c37f877119f" providerId="ADAL" clId="{1BAE7373-BC78-49F1-9262-209B991CDE28}" dt="2025-03-13T04:04:55.107" v="2" actId="47"/>
-        <pc:sldMkLst>
-          <pc:docMk/>
-          <pc:sldMk cId="0" sldId="300"/>
-        </pc:sldMkLst>
-      </pc:sldChg>
-      <pc:sldChg chg="del">
-        <pc:chgData name="Mohammed Fasha" userId="cc64f42d-a1a6-4f08-b97b-0c37f877119f" providerId="ADAL" clId="{1BAE7373-BC78-49F1-9262-209B991CDE28}" dt="2025-03-13T04:04:55.107" v="2" actId="47"/>
-        <pc:sldMkLst>
-          <pc:docMk/>
-          <pc:sldMk cId="0" sldId="301"/>
-        </pc:sldMkLst>
-      </pc:sldChg>
-      <pc:sldChg chg="del">
-        <pc:chgData name="Mohammed Fasha" userId="cc64f42d-a1a6-4f08-b97b-0c37f877119f" providerId="ADAL" clId="{1BAE7373-BC78-49F1-9262-209B991CDE28}" dt="2025-03-13T04:04:55.107" v="2" actId="47"/>
-        <pc:sldMkLst>
-          <pc:docMk/>
-          <pc:sldMk cId="0" sldId="304"/>
-        </pc:sldMkLst>
-      </pc:sldChg>
-      <pc:sldChg chg="del">
-        <pc:chgData name="Mohammed Fasha" userId="cc64f42d-a1a6-4f08-b97b-0c37f877119f" providerId="ADAL" clId="{1BAE7373-BC78-49F1-9262-209B991CDE28}" dt="2025-03-13T04:04:55.107" v="2" actId="47"/>
-        <pc:sldMkLst>
-          <pc:docMk/>
-          <pc:sldMk cId="0" sldId="314"/>
-        </pc:sldMkLst>
-      </pc:sldChg>
-      <pc:sldChg chg="del">
-        <pc:chgData name="Mohammed Fasha" userId="cc64f42d-a1a6-4f08-b97b-0c37f877119f" providerId="ADAL" clId="{1BAE7373-BC78-49F1-9262-209B991CDE28}" dt="2025-03-13T04:04:55.107" v="2" actId="47"/>
-        <pc:sldMkLst>
-          <pc:docMk/>
-          <pc:sldMk cId="2362708721" sldId="321"/>
-        </pc:sldMkLst>
-      </pc:sldChg>
-      <pc:sldChg chg="del">
-        <pc:chgData name="Mohammed Fasha" userId="cc64f42d-a1a6-4f08-b97b-0c37f877119f" providerId="ADAL" clId="{1BAE7373-BC78-49F1-9262-209B991CDE28}" dt="2025-03-13T04:04:55.107" v="2" actId="47"/>
-        <pc:sldMkLst>
-          <pc:docMk/>
-          <pc:sldMk cId="1477953107" sldId="324"/>
-        </pc:sldMkLst>
-      </pc:sldChg>
-      <pc:sldChg chg="del">
-        <pc:chgData name="Mohammed Fasha" userId="cc64f42d-a1a6-4f08-b97b-0c37f877119f" providerId="ADAL" clId="{1BAE7373-BC78-49F1-9262-209B991CDE28}" dt="2025-03-13T04:04:55.107" v="2" actId="47"/>
-        <pc:sldMkLst>
-          <pc:docMk/>
-          <pc:sldMk cId="1624740157" sldId="346"/>
-        </pc:sldMkLst>
-      </pc:sldChg>
-      <pc:sldChg chg="del">
-        <pc:chgData name="Mohammed Fasha" userId="cc64f42d-a1a6-4f08-b97b-0c37f877119f" providerId="ADAL" clId="{1BAE7373-BC78-49F1-9262-209B991CDE28}" dt="2025-03-13T04:04:55.107" v="2" actId="47"/>
-        <pc:sldMkLst>
-          <pc:docMk/>
-          <pc:sldMk cId="1093295885" sldId="365"/>
-        </pc:sldMkLst>
-      </pc:sldChg>
-      <pc:sldChg chg="del">
-        <pc:chgData name="Mohammed Fasha" userId="cc64f42d-a1a6-4f08-b97b-0c37f877119f" providerId="ADAL" clId="{1BAE7373-BC78-49F1-9262-209B991CDE28}" dt="2025-03-13T04:04:55.107" v="2" actId="47"/>
-        <pc:sldMkLst>
-          <pc:docMk/>
-          <pc:sldMk cId="3638528156" sldId="366"/>
-        </pc:sldMkLst>
-      </pc:sldChg>
-      <pc:sldChg chg="del">
-        <pc:chgData name="Mohammed Fasha" userId="cc64f42d-a1a6-4f08-b97b-0c37f877119f" providerId="ADAL" clId="{1BAE7373-BC78-49F1-9262-209B991CDE28}" dt="2025-03-13T04:04:55.107" v="2" actId="47"/>
-        <pc:sldMkLst>
-          <pc:docMk/>
-          <pc:sldMk cId="2714000580" sldId="367"/>
-        </pc:sldMkLst>
-      </pc:sldChg>
-      <pc:sldChg chg="del">
-        <pc:chgData name="Mohammed Fasha" userId="cc64f42d-a1a6-4f08-b97b-0c37f877119f" providerId="ADAL" clId="{1BAE7373-BC78-49F1-9262-209B991CDE28}" dt="2025-03-13T04:04:55.107" v="2" actId="47"/>
-        <pc:sldMkLst>
-          <pc:docMk/>
-          <pc:sldMk cId="4103125789" sldId="368"/>
-        </pc:sldMkLst>
-      </pc:sldChg>
-      <pc:sldChg chg="del">
-        <pc:chgData name="Mohammed Fasha" userId="cc64f42d-a1a6-4f08-b97b-0c37f877119f" providerId="ADAL" clId="{1BAE7373-BC78-49F1-9262-209B991CDE28}" dt="2025-03-13T04:04:55.107" v="2" actId="47"/>
-        <pc:sldMkLst>
-          <pc:docMk/>
-          <pc:sldMk cId="3243173744" sldId="369"/>
-        </pc:sldMkLst>
-      </pc:sldChg>
-      <pc:sldChg chg="del">
-        <pc:chgData name="Mohammed Fasha" userId="cc64f42d-a1a6-4f08-b97b-0c37f877119f" providerId="ADAL" clId="{1BAE7373-BC78-49F1-9262-209B991CDE28}" dt="2025-03-13T04:04:55.107" v="2" actId="47"/>
-        <pc:sldMkLst>
-          <pc:docMk/>
-          <pc:sldMk cId="533099717" sldId="370"/>
-        </pc:sldMkLst>
-      </pc:sldChg>
-      <pc:sldChg chg="del">
-        <pc:chgData name="Mohammed Fasha" userId="cc64f42d-a1a6-4f08-b97b-0c37f877119f" providerId="ADAL" clId="{1BAE7373-BC78-49F1-9262-209B991CDE28}" dt="2025-03-13T04:04:55.107" v="2" actId="47"/>
-        <pc:sldMkLst>
-          <pc:docMk/>
-          <pc:sldMk cId="403304745" sldId="371"/>
-        </pc:sldMkLst>
-      </pc:sldChg>
-      <pc:sldChg chg="del">
-        <pc:chgData name="Mohammed Fasha" userId="cc64f42d-a1a6-4f08-b97b-0c37f877119f" providerId="ADAL" clId="{1BAE7373-BC78-49F1-9262-209B991CDE28}" dt="2025-03-13T04:04:55.107" v="2" actId="47"/>
-        <pc:sldMkLst>
-          <pc:docMk/>
-          <pc:sldMk cId="1274929313" sldId="372"/>
-        </pc:sldMkLst>
-      </pc:sldChg>
-      <pc:sldChg chg="del">
-        <pc:chgData name="Mohammed Fasha" userId="cc64f42d-a1a6-4f08-b97b-0c37f877119f" providerId="ADAL" clId="{1BAE7373-BC78-49F1-9262-209B991CDE28}" dt="2025-03-13T04:04:55.107" v="2" actId="47"/>
-        <pc:sldMkLst>
-          <pc:docMk/>
-          <pc:sldMk cId="3412111298" sldId="376"/>
-        </pc:sldMkLst>
-      </pc:sldChg>
-      <pc:sldChg chg="del">
-        <pc:chgData name="Mohammed Fasha" userId="cc64f42d-a1a6-4f08-b97b-0c37f877119f" providerId="ADAL" clId="{1BAE7373-BC78-49F1-9262-209B991CDE28}" dt="2025-03-13T04:04:55.107" v="2" actId="47"/>
-        <pc:sldMkLst>
-          <pc:docMk/>
-          <pc:sldMk cId="3601872685" sldId="382"/>
-        </pc:sldMkLst>
-      </pc:sldChg>
-      <pc:sldChg chg="del">
-        <pc:chgData name="Mohammed Fasha" userId="cc64f42d-a1a6-4f08-b97b-0c37f877119f" providerId="ADAL" clId="{1BAE7373-BC78-49F1-9262-209B991CDE28}" dt="2025-03-13T04:04:55.107" v="2" actId="47"/>
-        <pc:sldMkLst>
-          <pc:docMk/>
-          <pc:sldMk cId="215899539" sldId="384"/>
-        </pc:sldMkLst>
-      </pc:sldChg>
-      <pc:sldChg chg="del">
-        <pc:chgData name="Mohammed Fasha" userId="cc64f42d-a1a6-4f08-b97b-0c37f877119f" providerId="ADAL" clId="{1BAE7373-BC78-49F1-9262-209B991CDE28}" dt="2025-03-13T04:04:55.107" v="2" actId="47"/>
-        <pc:sldMkLst>
-          <pc:docMk/>
-          <pc:sldMk cId="2001631854" sldId="390"/>
-        </pc:sldMkLst>
-      </pc:sldChg>
-      <pc:sldChg chg="del">
-        <pc:chgData name="Mohammed Fasha" userId="cc64f42d-a1a6-4f08-b97b-0c37f877119f" providerId="ADAL" clId="{1BAE7373-BC78-49F1-9262-209B991CDE28}" dt="2025-03-13T04:04:55.107" v="2" actId="47"/>
-        <pc:sldMkLst>
-          <pc:docMk/>
-          <pc:sldMk cId="2976191511" sldId="393"/>
-        </pc:sldMkLst>
-      </pc:sldChg>
-      <pc:sldChg chg="del">
-        <pc:chgData name="Mohammed Fasha" userId="cc64f42d-a1a6-4f08-b97b-0c37f877119f" providerId="ADAL" clId="{1BAE7373-BC78-49F1-9262-209B991CDE28}" dt="2025-03-13T04:04:55.107" v="2" actId="47"/>
-        <pc:sldMkLst>
-          <pc:docMk/>
-          <pc:sldMk cId="3942416368" sldId="394"/>
-        </pc:sldMkLst>
-      </pc:sldChg>
-      <pc:sldChg chg="del">
-        <pc:chgData name="Mohammed Fasha" userId="cc64f42d-a1a6-4f08-b97b-0c37f877119f" providerId="ADAL" clId="{1BAE7373-BC78-49F1-9262-209B991CDE28}" dt="2025-03-13T04:04:55.107" v="2" actId="47"/>
-        <pc:sldMkLst>
-          <pc:docMk/>
-          <pc:sldMk cId="2455239288" sldId="398"/>
-        </pc:sldMkLst>
-      </pc:sldChg>
-      <pc:sldChg chg="del">
-        <pc:chgData name="Mohammed Fasha" userId="cc64f42d-a1a6-4f08-b97b-0c37f877119f" providerId="ADAL" clId="{1BAE7373-BC78-49F1-9262-209B991CDE28}" dt="2025-03-13T04:04:55.107" v="2" actId="47"/>
-        <pc:sldMkLst>
-          <pc:docMk/>
-          <pc:sldMk cId="322630100" sldId="401"/>
-        </pc:sldMkLst>
-      </pc:sldChg>
-      <pc:sldChg chg="del">
-        <pc:chgData name="Mohammed Fasha" userId="cc64f42d-a1a6-4f08-b97b-0c37f877119f" providerId="ADAL" clId="{1BAE7373-BC78-49F1-9262-209B991CDE28}" dt="2025-03-13T04:04:55.107" v="2" actId="47"/>
-        <pc:sldMkLst>
-          <pc:docMk/>
-          <pc:sldMk cId="2446723419" sldId="402"/>
-        </pc:sldMkLst>
-      </pc:sldChg>
-      <pc:sldChg chg="del">
-        <pc:chgData name="Mohammed Fasha" userId="cc64f42d-a1a6-4f08-b97b-0c37f877119f" providerId="ADAL" clId="{1BAE7373-BC78-49F1-9262-209B991CDE28}" dt="2025-03-13T04:04:55.107" v="2" actId="47"/>
-        <pc:sldMkLst>
-          <pc:docMk/>
-          <pc:sldMk cId="2708838154" sldId="405"/>
-        </pc:sldMkLst>
-      </pc:sldChg>
-      <pc:sldChg chg="del">
-        <pc:chgData name="Mohammed Fasha" userId="cc64f42d-a1a6-4f08-b97b-0c37f877119f" providerId="ADAL" clId="{1BAE7373-BC78-49F1-9262-209B991CDE28}" dt="2025-03-13T04:04:55.107" v="2" actId="47"/>
-        <pc:sldMkLst>
-          <pc:docMk/>
-          <pc:sldMk cId="711859222" sldId="406"/>
-        </pc:sldMkLst>
-      </pc:sldChg>
-      <pc:sldChg chg="del">
-        <pc:chgData name="Mohammed Fasha" userId="cc64f42d-a1a6-4f08-b97b-0c37f877119f" providerId="ADAL" clId="{1BAE7373-BC78-49F1-9262-209B991CDE28}" dt="2025-03-13T04:04:55.107" v="2" actId="47"/>
-        <pc:sldMkLst>
-          <pc:docMk/>
-          <pc:sldMk cId="430192280" sldId="409"/>
-        </pc:sldMkLst>
-      </pc:sldChg>
-      <pc:sldChg chg="del">
-        <pc:chgData name="Mohammed Fasha" userId="cc64f42d-a1a6-4f08-b97b-0c37f877119f" providerId="ADAL" clId="{1BAE7373-BC78-49F1-9262-209B991CDE28}" dt="2025-03-13T04:04:55.107" v="2" actId="47"/>
-        <pc:sldMkLst>
-          <pc:docMk/>
-          <pc:sldMk cId="1261728788" sldId="410"/>
-        </pc:sldMkLst>
-      </pc:sldChg>
-      <pc:sldChg chg="del">
-        <pc:chgData name="Mohammed Fasha" userId="cc64f42d-a1a6-4f08-b97b-0c37f877119f" providerId="ADAL" clId="{1BAE7373-BC78-49F1-9262-209B991CDE28}" dt="2025-03-13T04:04:55.107" v="2" actId="47"/>
-        <pc:sldMkLst>
-          <pc:docMk/>
-          <pc:sldMk cId="465427976" sldId="414"/>
-        </pc:sldMkLst>
-      </pc:sldChg>
-      <pc:sldChg chg="del">
-        <pc:chgData name="Mohammed Fasha" userId="cc64f42d-a1a6-4f08-b97b-0c37f877119f" providerId="ADAL" clId="{1BAE7373-BC78-49F1-9262-209B991CDE28}" dt="2025-03-13T04:04:55.107" v="2" actId="47"/>
-        <pc:sldMkLst>
-          <pc:docMk/>
-          <pc:sldMk cId="4222832899" sldId="419"/>
-        </pc:sldMkLst>
-      </pc:sldChg>
-      <pc:sldChg chg="del">
-        <pc:chgData name="Mohammed Fasha" userId="cc64f42d-a1a6-4f08-b97b-0c37f877119f" providerId="ADAL" clId="{1BAE7373-BC78-49F1-9262-209B991CDE28}" dt="2025-03-13T04:04:55.107" v="2" actId="47"/>
-        <pc:sldMkLst>
-          <pc:docMk/>
-          <pc:sldMk cId="3168225218" sldId="422"/>
-        </pc:sldMkLst>
-      </pc:sldChg>
-      <pc:sldChg chg="del">
-        <pc:chgData name="Mohammed Fasha" userId="cc64f42d-a1a6-4f08-b97b-0c37f877119f" providerId="ADAL" clId="{1BAE7373-BC78-49F1-9262-209B991CDE28}" dt="2025-03-13T04:04:55.107" v="2" actId="47"/>
-        <pc:sldMkLst>
-          <pc:docMk/>
-          <pc:sldMk cId="2310344807" sldId="423"/>
-        </pc:sldMkLst>
-      </pc:sldChg>
-      <pc:sldChg chg="del">
-        <pc:chgData name="Mohammed Fasha" userId="cc64f42d-a1a6-4f08-b97b-0c37f877119f" providerId="ADAL" clId="{1BAE7373-BC78-49F1-9262-209B991CDE28}" dt="2025-03-13T04:04:55.107" v="2" actId="47"/>
-        <pc:sldMkLst>
-          <pc:docMk/>
-          <pc:sldMk cId="707737036" sldId="425"/>
-        </pc:sldMkLst>
-      </pc:sldChg>
-      <pc:sldChg chg="del">
-        <pc:chgData name="Mohammed Fasha" userId="cc64f42d-a1a6-4f08-b97b-0c37f877119f" providerId="ADAL" clId="{1BAE7373-BC78-49F1-9262-209B991CDE28}" dt="2025-03-13T04:04:55.107" v="2" actId="47"/>
-        <pc:sldMkLst>
-          <pc:docMk/>
-          <pc:sldMk cId="232656594" sldId="429"/>
-        </pc:sldMkLst>
-      </pc:sldChg>
-      <pc:sldChg chg="del">
-        <pc:chgData name="Mohammed Fasha" userId="cc64f42d-a1a6-4f08-b97b-0c37f877119f" providerId="ADAL" clId="{1BAE7373-BC78-49F1-9262-209B991CDE28}" dt="2025-03-13T04:04:55.107" v="2" actId="47"/>
-        <pc:sldMkLst>
-          <pc:docMk/>
-          <pc:sldMk cId="404333880" sldId="433"/>
-        </pc:sldMkLst>
-      </pc:sldChg>
-      <pc:sldChg chg="del">
-        <pc:chgData name="Mohammed Fasha" userId="cc64f42d-a1a6-4f08-b97b-0c37f877119f" providerId="ADAL" clId="{1BAE7373-BC78-49F1-9262-209B991CDE28}" dt="2025-03-13T04:04:55.107" v="2" actId="47"/>
-        <pc:sldMkLst>
-          <pc:docMk/>
-          <pc:sldMk cId="2523349106" sldId="442"/>
-        </pc:sldMkLst>
-      </pc:sldChg>
-      <pc:sldChg chg="del">
-        <pc:chgData name="Mohammed Fasha" userId="cc64f42d-a1a6-4f08-b97b-0c37f877119f" providerId="ADAL" clId="{1BAE7373-BC78-49F1-9262-209B991CDE28}" dt="2025-03-13T04:04:55.107" v="2" actId="47"/>
-        <pc:sldMkLst>
-          <pc:docMk/>
-          <pc:sldMk cId="2515022167" sldId="443"/>
-        </pc:sldMkLst>
-      </pc:sldChg>
-      <pc:sldChg chg="del">
-        <pc:chgData name="Mohammed Fasha" userId="cc64f42d-a1a6-4f08-b97b-0c37f877119f" providerId="ADAL" clId="{1BAE7373-BC78-49F1-9262-209B991CDE28}" dt="2025-03-13T04:04:55.107" v="2" actId="47"/>
-        <pc:sldMkLst>
-          <pc:docMk/>
-          <pc:sldMk cId="1977389857" sldId="445"/>
-        </pc:sldMkLst>
-      </pc:sldChg>
-      <pc:sldChg chg="del">
-        <pc:chgData name="Mohammed Fasha" userId="cc64f42d-a1a6-4f08-b97b-0c37f877119f" providerId="ADAL" clId="{1BAE7373-BC78-49F1-9262-209B991CDE28}" dt="2025-03-13T04:04:55.107" v="2" actId="47"/>
-        <pc:sldMkLst>
-          <pc:docMk/>
-          <pc:sldMk cId="2140515002" sldId="446"/>
-        </pc:sldMkLst>
-      </pc:sldChg>
-      <pc:sldChg chg="del">
-        <pc:chgData name="Mohammed Fasha" userId="cc64f42d-a1a6-4f08-b97b-0c37f877119f" providerId="ADAL" clId="{1BAE7373-BC78-49F1-9262-209B991CDE28}" dt="2025-03-13T04:04:55.107" v="2" actId="47"/>
-        <pc:sldMkLst>
-          <pc:docMk/>
-          <pc:sldMk cId="1932795151" sldId="448"/>
-        </pc:sldMkLst>
-      </pc:sldChg>
-      <pc:sldChg chg="del">
-        <pc:chgData name="Mohammed Fasha" userId="cc64f42d-a1a6-4f08-b97b-0c37f877119f" providerId="ADAL" clId="{1BAE7373-BC78-49F1-9262-209B991CDE28}" dt="2025-03-13T04:04:55.107" v="2" actId="47"/>
-        <pc:sldMkLst>
-          <pc:docMk/>
-          <pc:sldMk cId="1837964685" sldId="451"/>
-        </pc:sldMkLst>
-      </pc:sldChg>
-      <pc:sldChg chg="del">
-        <pc:chgData name="Mohammed Fasha" userId="cc64f42d-a1a6-4f08-b97b-0c37f877119f" providerId="ADAL" clId="{1BAE7373-BC78-49F1-9262-209B991CDE28}" dt="2025-03-13T04:04:55.107" v="2" actId="47"/>
-        <pc:sldMkLst>
-          <pc:docMk/>
-          <pc:sldMk cId="1229244997" sldId="452"/>
-        </pc:sldMkLst>
-      </pc:sldChg>
-      <pc:sldChg chg="del">
-        <pc:chgData name="Mohammed Fasha" userId="cc64f42d-a1a6-4f08-b97b-0c37f877119f" providerId="ADAL" clId="{1BAE7373-BC78-49F1-9262-209B991CDE28}" dt="2025-03-13T04:04:55.107" v="2" actId="47"/>
-        <pc:sldMkLst>
-          <pc:docMk/>
-          <pc:sldMk cId="1789205401" sldId="453"/>
-        </pc:sldMkLst>
-      </pc:sldChg>
       <pc:sldChg chg="modSp mod">
         <pc:chgData name="Mohammed Fasha" userId="cc64f42d-a1a6-4f08-b97b-0c37f877119f" providerId="ADAL" clId="{1BAE7373-BC78-49F1-9262-209B991CDE28}" dt="2025-03-13T04:05:10.584" v="53" actId="20577"/>
         <pc:sldMkLst>
@@ -849,195 +207,6 @@
             <ac:spMk id="8" creationId="{107CF054-390C-DCFC-C9A6-9E95C859A175}"/>
           </ac:spMkLst>
         </pc:spChg>
-      </pc:sldChg>
-      <pc:sldChg chg="del">
-        <pc:chgData name="Mohammed Fasha" userId="cc64f42d-a1a6-4f08-b97b-0c37f877119f" providerId="ADAL" clId="{1BAE7373-BC78-49F1-9262-209B991CDE28}" dt="2025-03-13T04:04:55.107" v="2" actId="47"/>
-        <pc:sldMkLst>
-          <pc:docMk/>
-          <pc:sldMk cId="2921402285" sldId="457"/>
-        </pc:sldMkLst>
-      </pc:sldChg>
-      <pc:sldChg chg="del">
-        <pc:chgData name="Mohammed Fasha" userId="cc64f42d-a1a6-4f08-b97b-0c37f877119f" providerId="ADAL" clId="{1BAE7373-BC78-49F1-9262-209B991CDE28}" dt="2025-03-13T04:04:55.107" v="2" actId="47"/>
-        <pc:sldMkLst>
-          <pc:docMk/>
-          <pc:sldMk cId="1912979039" sldId="458"/>
-        </pc:sldMkLst>
-      </pc:sldChg>
-      <pc:sldChg chg="del">
-        <pc:chgData name="Mohammed Fasha" userId="cc64f42d-a1a6-4f08-b97b-0c37f877119f" providerId="ADAL" clId="{1BAE7373-BC78-49F1-9262-209B991CDE28}" dt="2025-03-13T04:04:55.107" v="2" actId="47"/>
-        <pc:sldMkLst>
-          <pc:docMk/>
-          <pc:sldMk cId="484589733" sldId="459"/>
-        </pc:sldMkLst>
-      </pc:sldChg>
-      <pc:sldChg chg="del">
-        <pc:chgData name="Mohammed Fasha" userId="cc64f42d-a1a6-4f08-b97b-0c37f877119f" providerId="ADAL" clId="{1BAE7373-BC78-49F1-9262-209B991CDE28}" dt="2025-03-13T04:04:55.107" v="2" actId="47"/>
-        <pc:sldMkLst>
-          <pc:docMk/>
-          <pc:sldMk cId="1770736122" sldId="460"/>
-        </pc:sldMkLst>
-      </pc:sldChg>
-      <pc:sldChg chg="del">
-        <pc:chgData name="Mohammed Fasha" userId="cc64f42d-a1a6-4f08-b97b-0c37f877119f" providerId="ADAL" clId="{1BAE7373-BC78-49F1-9262-209B991CDE28}" dt="2025-03-13T04:04:55.107" v="2" actId="47"/>
-        <pc:sldMkLst>
-          <pc:docMk/>
-          <pc:sldMk cId="2965647848" sldId="463"/>
-        </pc:sldMkLst>
-      </pc:sldChg>
-      <pc:sldChg chg="del">
-        <pc:chgData name="Mohammed Fasha" userId="cc64f42d-a1a6-4f08-b97b-0c37f877119f" providerId="ADAL" clId="{1BAE7373-BC78-49F1-9262-209B991CDE28}" dt="2025-03-13T04:04:55.107" v="2" actId="47"/>
-        <pc:sldMkLst>
-          <pc:docMk/>
-          <pc:sldMk cId="109379533" sldId="464"/>
-        </pc:sldMkLst>
-      </pc:sldChg>
-      <pc:sldChg chg="del">
-        <pc:chgData name="Mohammed Fasha" userId="cc64f42d-a1a6-4f08-b97b-0c37f877119f" providerId="ADAL" clId="{1BAE7373-BC78-49F1-9262-209B991CDE28}" dt="2025-03-13T04:04:55.107" v="2" actId="47"/>
-        <pc:sldMkLst>
-          <pc:docMk/>
-          <pc:sldMk cId="719424402" sldId="467"/>
-        </pc:sldMkLst>
-      </pc:sldChg>
-      <pc:sldChg chg="del">
-        <pc:chgData name="Mohammed Fasha" userId="cc64f42d-a1a6-4f08-b97b-0c37f877119f" providerId="ADAL" clId="{1BAE7373-BC78-49F1-9262-209B991CDE28}" dt="2025-03-13T04:04:55.107" v="2" actId="47"/>
-        <pc:sldMkLst>
-          <pc:docMk/>
-          <pc:sldMk cId="3168600941" sldId="471"/>
-        </pc:sldMkLst>
-      </pc:sldChg>
-      <pc:sldChg chg="del">
-        <pc:chgData name="Mohammed Fasha" userId="cc64f42d-a1a6-4f08-b97b-0c37f877119f" providerId="ADAL" clId="{1BAE7373-BC78-49F1-9262-209B991CDE28}" dt="2025-03-13T04:04:55.107" v="2" actId="47"/>
-        <pc:sldMkLst>
-          <pc:docMk/>
-          <pc:sldMk cId="2302099845" sldId="472"/>
-        </pc:sldMkLst>
-      </pc:sldChg>
-      <pc:sldChg chg="del">
-        <pc:chgData name="Mohammed Fasha" userId="cc64f42d-a1a6-4f08-b97b-0c37f877119f" providerId="ADAL" clId="{1BAE7373-BC78-49F1-9262-209B991CDE28}" dt="2025-03-13T04:04:55.107" v="2" actId="47"/>
-        <pc:sldMkLst>
-          <pc:docMk/>
-          <pc:sldMk cId="118211851" sldId="473"/>
-        </pc:sldMkLst>
-      </pc:sldChg>
-      <pc:sldChg chg="del">
-        <pc:chgData name="Mohammed Fasha" userId="cc64f42d-a1a6-4f08-b97b-0c37f877119f" providerId="ADAL" clId="{1BAE7373-BC78-49F1-9262-209B991CDE28}" dt="2025-03-13T04:04:55.107" v="2" actId="47"/>
-        <pc:sldMkLst>
-          <pc:docMk/>
-          <pc:sldMk cId="1150689950" sldId="474"/>
-        </pc:sldMkLst>
-      </pc:sldChg>
-      <pc:sldChg chg="del">
-        <pc:chgData name="Mohammed Fasha" userId="cc64f42d-a1a6-4f08-b97b-0c37f877119f" providerId="ADAL" clId="{1BAE7373-BC78-49F1-9262-209B991CDE28}" dt="2025-03-13T04:04:55.107" v="2" actId="47"/>
-        <pc:sldMkLst>
-          <pc:docMk/>
-          <pc:sldMk cId="942593251" sldId="475"/>
-        </pc:sldMkLst>
-      </pc:sldChg>
-      <pc:sldChg chg="del">
-        <pc:chgData name="Mohammed Fasha" userId="cc64f42d-a1a6-4f08-b97b-0c37f877119f" providerId="ADAL" clId="{1BAE7373-BC78-49F1-9262-209B991CDE28}" dt="2025-03-13T04:04:55.107" v="2" actId="47"/>
-        <pc:sldMkLst>
-          <pc:docMk/>
-          <pc:sldMk cId="94366255" sldId="476"/>
-        </pc:sldMkLst>
-      </pc:sldChg>
-      <pc:sldChg chg="del">
-        <pc:chgData name="Mohammed Fasha" userId="cc64f42d-a1a6-4f08-b97b-0c37f877119f" providerId="ADAL" clId="{1BAE7373-BC78-49F1-9262-209B991CDE28}" dt="2025-03-13T04:04:55.107" v="2" actId="47"/>
-        <pc:sldMkLst>
-          <pc:docMk/>
-          <pc:sldMk cId="3109107256" sldId="477"/>
-        </pc:sldMkLst>
-      </pc:sldChg>
-      <pc:sldChg chg="del">
-        <pc:chgData name="Mohammed Fasha" userId="cc64f42d-a1a6-4f08-b97b-0c37f877119f" providerId="ADAL" clId="{1BAE7373-BC78-49F1-9262-209B991CDE28}" dt="2025-03-13T04:04:55.107" v="2" actId="47"/>
-        <pc:sldMkLst>
-          <pc:docMk/>
-          <pc:sldMk cId="408884363" sldId="483"/>
-        </pc:sldMkLst>
-      </pc:sldChg>
-      <pc:sldChg chg="del">
-        <pc:chgData name="Mohammed Fasha" userId="cc64f42d-a1a6-4f08-b97b-0c37f877119f" providerId="ADAL" clId="{1BAE7373-BC78-49F1-9262-209B991CDE28}" dt="2025-03-13T04:04:55.107" v="2" actId="47"/>
-        <pc:sldMkLst>
-          <pc:docMk/>
-          <pc:sldMk cId="994101439" sldId="484"/>
-        </pc:sldMkLst>
-      </pc:sldChg>
-      <pc:sldChg chg="del">
-        <pc:chgData name="Mohammed Fasha" userId="cc64f42d-a1a6-4f08-b97b-0c37f877119f" providerId="ADAL" clId="{1BAE7373-BC78-49F1-9262-209B991CDE28}" dt="2025-03-13T04:04:55.107" v="2" actId="47"/>
-        <pc:sldMkLst>
-          <pc:docMk/>
-          <pc:sldMk cId="1440183149" sldId="485"/>
-        </pc:sldMkLst>
-      </pc:sldChg>
-      <pc:sldChg chg="del">
-        <pc:chgData name="Mohammed Fasha" userId="cc64f42d-a1a6-4f08-b97b-0c37f877119f" providerId="ADAL" clId="{1BAE7373-BC78-49F1-9262-209B991CDE28}" dt="2025-03-13T04:04:55.107" v="2" actId="47"/>
-        <pc:sldMkLst>
-          <pc:docMk/>
-          <pc:sldMk cId="3841714060" sldId="486"/>
-        </pc:sldMkLst>
-      </pc:sldChg>
-      <pc:sldChg chg="del">
-        <pc:chgData name="Mohammed Fasha" userId="cc64f42d-a1a6-4f08-b97b-0c37f877119f" providerId="ADAL" clId="{1BAE7373-BC78-49F1-9262-209B991CDE28}" dt="2025-03-13T04:04:55.107" v="2" actId="47"/>
-        <pc:sldMkLst>
-          <pc:docMk/>
-          <pc:sldMk cId="833725597" sldId="488"/>
-        </pc:sldMkLst>
-      </pc:sldChg>
-      <pc:sldChg chg="del">
-        <pc:chgData name="Mohammed Fasha" userId="cc64f42d-a1a6-4f08-b97b-0c37f877119f" providerId="ADAL" clId="{1BAE7373-BC78-49F1-9262-209B991CDE28}" dt="2025-03-13T04:04:55.107" v="2" actId="47"/>
-        <pc:sldMkLst>
-          <pc:docMk/>
-          <pc:sldMk cId="4123470834" sldId="489"/>
-        </pc:sldMkLst>
-      </pc:sldChg>
-      <pc:sldChg chg="del">
-        <pc:chgData name="Mohammed Fasha" userId="cc64f42d-a1a6-4f08-b97b-0c37f877119f" providerId="ADAL" clId="{1BAE7373-BC78-49F1-9262-209B991CDE28}" dt="2025-03-13T04:04:55.107" v="2" actId="47"/>
-        <pc:sldMkLst>
-          <pc:docMk/>
-          <pc:sldMk cId="4022017735" sldId="490"/>
-        </pc:sldMkLst>
-      </pc:sldChg>
-      <pc:sldChg chg="del">
-        <pc:chgData name="Mohammed Fasha" userId="cc64f42d-a1a6-4f08-b97b-0c37f877119f" providerId="ADAL" clId="{1BAE7373-BC78-49F1-9262-209B991CDE28}" dt="2025-03-13T04:04:55.107" v="2" actId="47"/>
-        <pc:sldMkLst>
-          <pc:docMk/>
-          <pc:sldMk cId="2225061527" sldId="491"/>
-        </pc:sldMkLst>
-      </pc:sldChg>
-      <pc:sldChg chg="del">
-        <pc:chgData name="Mohammed Fasha" userId="cc64f42d-a1a6-4f08-b97b-0c37f877119f" providerId="ADAL" clId="{1BAE7373-BC78-49F1-9262-209B991CDE28}" dt="2025-03-13T04:04:55.107" v="2" actId="47"/>
-        <pc:sldMkLst>
-          <pc:docMk/>
-          <pc:sldMk cId="673932695" sldId="492"/>
-        </pc:sldMkLst>
-      </pc:sldChg>
-      <pc:sldChg chg="del">
-        <pc:chgData name="Mohammed Fasha" userId="cc64f42d-a1a6-4f08-b97b-0c37f877119f" providerId="ADAL" clId="{1BAE7373-BC78-49F1-9262-209B991CDE28}" dt="2025-03-13T04:04:55.107" v="2" actId="47"/>
-        <pc:sldMkLst>
-          <pc:docMk/>
-          <pc:sldMk cId="2512069021" sldId="493"/>
-        </pc:sldMkLst>
-      </pc:sldChg>
-      <pc:sldChg chg="del">
-        <pc:chgData name="Mohammed Fasha" userId="cc64f42d-a1a6-4f08-b97b-0c37f877119f" providerId="ADAL" clId="{1BAE7373-BC78-49F1-9262-209B991CDE28}" dt="2025-03-13T04:04:55.107" v="2" actId="47"/>
-        <pc:sldMkLst>
-          <pc:docMk/>
-          <pc:sldMk cId="3290660304" sldId="494"/>
-        </pc:sldMkLst>
-      </pc:sldChg>
-      <pc:sldChg chg="del">
-        <pc:chgData name="Mohammed Fasha" userId="cc64f42d-a1a6-4f08-b97b-0c37f877119f" providerId="ADAL" clId="{1BAE7373-BC78-49F1-9262-209B991CDE28}" dt="2025-03-13T04:04:55.107" v="2" actId="47"/>
-        <pc:sldMkLst>
-          <pc:docMk/>
-          <pc:sldMk cId="4079654275" sldId="495"/>
-        </pc:sldMkLst>
-      </pc:sldChg>
-      <pc:sldChg chg="del">
-        <pc:chgData name="Mohammed Fasha" userId="cc64f42d-a1a6-4f08-b97b-0c37f877119f" providerId="ADAL" clId="{1BAE7373-BC78-49F1-9262-209B991CDE28}" dt="2025-03-13T04:04:55.107" v="2" actId="47"/>
-        <pc:sldMkLst>
-          <pc:docMk/>
-          <pc:sldMk cId="1501311303" sldId="496"/>
-        </pc:sldMkLst>
       </pc:sldChg>
       <pc:sldChg chg="modSp new mod">
         <pc:chgData name="Mohammed Fasha" userId="cc64f42d-a1a6-4f08-b97b-0c37f877119f" providerId="ADAL" clId="{1BAE7373-BC78-49F1-9262-209B991CDE28}" dt="2025-03-13T04:10:14.044" v="122" actId="6549"/>
@@ -1061,13 +230,6 @@
             <ac:spMk id="3" creationId="{A5195869-3520-9DAA-D835-4CA6C4C9E68B}"/>
           </ac:spMkLst>
         </pc:spChg>
-      </pc:sldChg>
-      <pc:sldChg chg="del">
-        <pc:chgData name="Mohammed Fasha" userId="cc64f42d-a1a6-4f08-b97b-0c37f877119f" providerId="ADAL" clId="{1BAE7373-BC78-49F1-9262-209B991CDE28}" dt="2025-03-13T04:04:46.913" v="0" actId="47"/>
-        <pc:sldMkLst>
-          <pc:docMk/>
-          <pc:sldMk cId="2557217836" sldId="497"/>
-        </pc:sldMkLst>
       </pc:sldChg>
       <pc:sldChg chg="modSp add del mod modClrScheme chgLayout">
         <pc:chgData name="Mohammed Fasha" userId="cc64f42d-a1a6-4f08-b97b-0c37f877119f" providerId="ADAL" clId="{1BAE7373-BC78-49F1-9262-209B991CDE28}" dt="2025-03-15T11:51:52.430" v="903" actId="47"/>
@@ -1514,115 +676,10 @@
       <pc:docMkLst>
         <pc:docMk/>
       </pc:docMkLst>
-      <pc:sldChg chg="delSp">
-        <pc:chgData name="Mohammed Fasha" userId="cc64f42d-a1a6-4f08-b97b-0c37f877119f" providerId="ADAL" clId="{2E5FBF59-3168-4932-9518-582502FE1AD5}" dt="2024-11-19T07:40:47.121" v="208" actId="478"/>
-        <pc:sldMkLst>
-          <pc:docMk/>
-          <pc:sldMk cId="391491219" sldId="428"/>
-        </pc:sldMkLst>
-      </pc:sldChg>
-      <pc:sldChg chg="modSp">
-        <pc:chgData name="Mohammed Fasha" userId="cc64f42d-a1a6-4f08-b97b-0c37f877119f" providerId="ADAL" clId="{2E5FBF59-3168-4932-9518-582502FE1AD5}" dt="2024-12-03T07:43:58.007" v="456" actId="1076"/>
-        <pc:sldMkLst>
-          <pc:docMk/>
-          <pc:sldMk cId="3339445507" sldId="430"/>
-        </pc:sldMkLst>
-      </pc:sldChg>
-      <pc:sldChg chg="modSp">
-        <pc:chgData name="Mohammed Fasha" userId="cc64f42d-a1a6-4f08-b97b-0c37f877119f" providerId="ADAL" clId="{2E5FBF59-3168-4932-9518-582502FE1AD5}" dt="2024-12-03T07:45:08.136" v="474" actId="20577"/>
-        <pc:sldMkLst>
-          <pc:docMk/>
-          <pc:sldMk cId="3389046835" sldId="431"/>
-        </pc:sldMkLst>
-      </pc:sldChg>
-      <pc:sldChg chg="modSp">
-        <pc:chgData name="Mohammed Fasha" userId="cc64f42d-a1a6-4f08-b97b-0c37f877119f" providerId="ADAL" clId="{2E5FBF59-3168-4932-9518-582502FE1AD5}" dt="2024-11-10T06:33:09.727" v="37" actId="207"/>
-        <pc:sldMkLst>
-          <pc:docMk/>
-          <pc:sldMk cId="2726994946" sldId="479"/>
-        </pc:sldMkLst>
-      </pc:sldChg>
-      <pc:sldChg chg="modSp">
-        <pc:chgData name="Mohammed Fasha" userId="cc64f42d-a1a6-4f08-b97b-0c37f877119f" providerId="ADAL" clId="{2E5FBF59-3168-4932-9518-582502FE1AD5}" dt="2024-11-19T07:44:28.766" v="211" actId="20577"/>
-        <pc:sldMkLst>
-          <pc:docMk/>
-          <pc:sldMk cId="2297456757" sldId="483"/>
-        </pc:sldMkLst>
-      </pc:sldChg>
-      <pc:sldChg chg="modSp">
-        <pc:chgData name="Mohammed Fasha" userId="cc64f42d-a1a6-4f08-b97b-0c37f877119f" providerId="ADAL" clId="{2E5FBF59-3168-4932-9518-582502FE1AD5}" dt="2024-11-10T06:45:09.392" v="40" actId="20577"/>
-        <pc:sldMkLst>
-          <pc:docMk/>
-          <pc:sldMk cId="3474268344" sldId="596"/>
-        </pc:sldMkLst>
-      </pc:sldChg>
-      <pc:sldChg chg="modSp">
-        <pc:chgData name="Mohammed Fasha" userId="cc64f42d-a1a6-4f08-b97b-0c37f877119f" providerId="ADAL" clId="{2E5FBF59-3168-4932-9518-582502FE1AD5}" dt="2024-12-03T07:47:21.561" v="476" actId="6549"/>
-        <pc:sldMkLst>
-          <pc:docMk/>
-          <pc:sldMk cId="399592497" sldId="613"/>
-        </pc:sldMkLst>
-      </pc:sldChg>
-      <pc:sldChg chg="modSp">
-        <pc:chgData name="Mohammed Fasha" userId="cc64f42d-a1a6-4f08-b97b-0c37f877119f" providerId="ADAL" clId="{2E5FBF59-3168-4932-9518-582502FE1AD5}" dt="2024-12-03T07:49:02.980" v="478" actId="207"/>
-        <pc:sldMkLst>
-          <pc:docMk/>
-          <pc:sldMk cId="3329135496" sldId="617"/>
-        </pc:sldMkLst>
-      </pc:sldChg>
-      <pc:sldChg chg="modSp">
-        <pc:chgData name="Mohammed Fasha" userId="cc64f42d-a1a6-4f08-b97b-0c37f877119f" providerId="ADAL" clId="{2E5FBF59-3168-4932-9518-582502FE1AD5}" dt="2024-12-24T08:05:16.608" v="482" actId="403"/>
-        <pc:sldMkLst>
-          <pc:docMk/>
-          <pc:sldMk cId="2990045589" sldId="659"/>
-        </pc:sldMkLst>
-      </pc:sldChg>
-      <pc:sldChg chg="modSp">
-        <pc:chgData name="Mohammed Fasha" userId="cc64f42d-a1a6-4f08-b97b-0c37f877119f" providerId="ADAL" clId="{2E5FBF59-3168-4932-9518-582502FE1AD5}" dt="2024-12-24T08:08:19.987" v="550" actId="20577"/>
-        <pc:sldMkLst>
-          <pc:docMk/>
-          <pc:sldMk cId="2680231355" sldId="669"/>
-        </pc:sldMkLst>
-      </pc:sldChg>
-      <pc:sldChg chg="addSp modSp">
-        <pc:chgData name="Mohammed Fasha" userId="cc64f42d-a1a6-4f08-b97b-0c37f877119f" providerId="ADAL" clId="{2E5FBF59-3168-4932-9518-582502FE1AD5}" dt="2024-12-24T08:05:52.910" v="488" actId="1076"/>
-        <pc:sldMkLst>
-          <pc:docMk/>
-          <pc:sldMk cId="916102856" sldId="685"/>
-        </pc:sldMkLst>
-      </pc:sldChg>
-      <pc:sldChg chg="modSp">
-        <pc:chgData name="Mohammed Fasha" userId="cc64f42d-a1a6-4f08-b97b-0c37f877119f" providerId="ADAL" clId="{2E5FBF59-3168-4932-9518-582502FE1AD5}" dt="2024-11-19T07:03:29.557" v="206" actId="207"/>
-        <pc:sldMkLst>
-          <pc:docMk/>
-          <pc:sldMk cId="32004852" sldId="708"/>
-        </pc:sldMkLst>
-      </pc:sldChg>
     </pc:docChg>
   </pc:docChgLst>
   <pc:docChgLst>
     <pc:chgData name="Mohammed Fasha" userId="cc64f42d-a1a6-4f08-b97b-0c37f877119f" providerId="ADAL" clId="{6804A8E6-8D7F-46E3-B091-66A8F6B926BF}"/>
-    <pc:docChg chg="custSel modMainMaster">
-      <pc:chgData name="Mohammed Fasha" userId="cc64f42d-a1a6-4f08-b97b-0c37f877119f" providerId="ADAL" clId="{6804A8E6-8D7F-46E3-B091-66A8F6B926BF}" dt="2024-11-09T05:15:35.019" v="2" actId="1076"/>
-      <pc:docMkLst>
-        <pc:docMk/>
-      </pc:docMkLst>
-      <pc:sldMasterChg chg="delSp mod modSldLayout">
-        <pc:chgData name="Mohammed Fasha" userId="cc64f42d-a1a6-4f08-b97b-0c37f877119f" providerId="ADAL" clId="{6804A8E6-8D7F-46E3-B091-66A8F6B926BF}" dt="2024-11-09T05:15:35.019" v="2" actId="1076"/>
-        <pc:sldMasterMkLst>
-          <pc:docMk/>
-          <pc:sldMasterMk cId="742811419" sldId="2147483648"/>
-        </pc:sldMasterMkLst>
-        <pc:sldLayoutChg chg="addSp modSp mod">
-          <pc:chgData name="Mohammed Fasha" userId="cc64f42d-a1a6-4f08-b97b-0c37f877119f" providerId="ADAL" clId="{6804A8E6-8D7F-46E3-B091-66A8F6B926BF}" dt="2024-11-09T05:15:35.019" v="2" actId="1076"/>
-          <pc:sldLayoutMkLst>
-            <pc:docMk/>
-            <pc:sldMasterMk cId="742811419" sldId="2147483648"/>
-            <pc:sldLayoutMk cId="4063788262" sldId="2147483649"/>
-          </pc:sldLayoutMkLst>
-        </pc:sldLayoutChg>
-      </pc:sldMasterChg>
-    </pc:docChg>
   </pc:docChgLst>
   <pc:docChgLst>
     <pc:chgData name="Mohammed Fasha" userId="cc64f42d-a1a6-4f08-b97b-0c37f877119f" providerId="ADAL" clId="{534F862C-5423-415F-8625-CCE86B4944CE}"/>
@@ -2711,6 +1768,184 @@
       </pc:sldChg>
     </pc:docChg>
   </pc:docChgLst>
+  <pc:docChgLst>
+    <pc:chgData name="Mohammed Fasha" userId="cc64f42d-a1a6-4f08-b97b-0c37f877119f" providerId="ADAL" clId="{C411E271-76BA-4F65-AAC3-462D3CC4567C}"/>
+    <pc:docChg chg="undo custSel addSld modSld">
+      <pc:chgData name="Mohammed Fasha" userId="cc64f42d-a1a6-4f08-b97b-0c37f877119f" providerId="ADAL" clId="{C411E271-76BA-4F65-AAC3-462D3CC4567C}" dt="2025-03-16T06:42:54.392" v="163" actId="12"/>
+      <pc:docMkLst>
+        <pc:docMk/>
+      </pc:docMkLst>
+      <pc:sldChg chg="addSp modSp">
+        <pc:chgData name="Mohammed Fasha" userId="cc64f42d-a1a6-4f08-b97b-0c37f877119f" providerId="ADAL" clId="{C411E271-76BA-4F65-AAC3-462D3CC4567C}" dt="2025-03-16T06:34:53.182" v="34" actId="1076"/>
+        <pc:sldMkLst>
+          <pc:docMk/>
+          <pc:sldMk cId="3162735116" sldId="532"/>
+        </pc:sldMkLst>
+        <pc:spChg chg="add mod">
+          <ac:chgData name="Mohammed Fasha" userId="cc64f42d-a1a6-4f08-b97b-0c37f877119f" providerId="ADAL" clId="{C411E271-76BA-4F65-AAC3-462D3CC4567C}" dt="2025-03-16T06:34:53.182" v="34" actId="1076"/>
+          <ac:spMkLst>
+            <pc:docMk/>
+            <pc:sldMk cId="3162735116" sldId="532"/>
+            <ac:spMk id="5" creationId="{276D0FCF-4391-4D56-854A-F184802E65F6}"/>
+          </ac:spMkLst>
+        </pc:spChg>
+        <pc:picChg chg="add mod">
+          <ac:chgData name="Mohammed Fasha" userId="cc64f42d-a1a6-4f08-b97b-0c37f877119f" providerId="ADAL" clId="{C411E271-76BA-4F65-AAC3-462D3CC4567C}" dt="2025-03-16T06:34:16.367" v="14" actId="1076"/>
+          <ac:picMkLst>
+            <pc:docMk/>
+            <pc:sldMk cId="3162735116" sldId="532"/>
+            <ac:picMk id="7" creationId="{DC2CF0F7-2D5E-4690-AF02-D9A372D347F3}"/>
+          </ac:picMkLst>
+        </pc:picChg>
+      </pc:sldChg>
+      <pc:sldChg chg="addSp delSp modSp">
+        <pc:chgData name="Mohammed Fasha" userId="cc64f42d-a1a6-4f08-b97b-0c37f877119f" providerId="ADAL" clId="{C411E271-76BA-4F65-AAC3-462D3CC4567C}" dt="2025-03-16T06:39:34.453" v="68" actId="12"/>
+        <pc:sldMkLst>
+          <pc:docMk/>
+          <pc:sldMk cId="601496234" sldId="533"/>
+        </pc:sldMkLst>
+        <pc:spChg chg="add del mod">
+          <ac:chgData name="Mohammed Fasha" userId="cc64f42d-a1a6-4f08-b97b-0c37f877119f" providerId="ADAL" clId="{C411E271-76BA-4F65-AAC3-462D3CC4567C}" dt="2025-03-16T06:38:37.457" v="55"/>
+          <ac:spMkLst>
+            <pc:docMk/>
+            <pc:sldMk cId="601496234" sldId="533"/>
+            <ac:spMk id="5" creationId="{4B36095E-A4BA-44E7-8F69-A775646D0956}"/>
+          </ac:spMkLst>
+        </pc:spChg>
+        <pc:spChg chg="add del">
+          <ac:chgData name="Mohammed Fasha" userId="cc64f42d-a1a6-4f08-b97b-0c37f877119f" providerId="ADAL" clId="{C411E271-76BA-4F65-AAC3-462D3CC4567C}" dt="2025-03-16T06:38:34.922" v="54"/>
+          <ac:spMkLst>
+            <pc:docMk/>
+            <pc:sldMk cId="601496234" sldId="533"/>
+            <ac:spMk id="6" creationId="{07137515-EE97-4896-8B5A-41231EAF77F7}"/>
+          </ac:spMkLst>
+        </pc:spChg>
+        <pc:spChg chg="add del mod">
+          <ac:chgData name="Mohammed Fasha" userId="cc64f42d-a1a6-4f08-b97b-0c37f877119f" providerId="ADAL" clId="{C411E271-76BA-4F65-AAC3-462D3CC4567C}" dt="2025-03-16T06:37:45.884" v="42"/>
+          <ac:spMkLst>
+            <pc:docMk/>
+            <pc:sldMk cId="601496234" sldId="533"/>
+            <ac:spMk id="7" creationId="{01B05A74-6BBD-41F5-92E5-4F4C2B1A9DBE}"/>
+          </ac:spMkLst>
+        </pc:spChg>
+        <pc:spChg chg="add mod">
+          <ac:chgData name="Mohammed Fasha" userId="cc64f42d-a1a6-4f08-b97b-0c37f877119f" providerId="ADAL" clId="{C411E271-76BA-4F65-AAC3-462D3CC4567C}" dt="2025-03-16T06:39:34.453" v="68" actId="12"/>
+          <ac:spMkLst>
+            <pc:docMk/>
+            <pc:sldMk cId="601496234" sldId="533"/>
+            <ac:spMk id="8" creationId="{A4BECA11-0014-431F-A8D8-3FFAF66D6978}"/>
+          </ac:spMkLst>
+        </pc:spChg>
+        <pc:spChg chg="mod">
+          <ac:chgData name="Mohammed Fasha" userId="cc64f42d-a1a6-4f08-b97b-0c37f877119f" providerId="ADAL" clId="{C411E271-76BA-4F65-AAC3-462D3CC4567C}" dt="2025-03-16T06:39:23.803" v="65" actId="14100"/>
+          <ac:spMkLst>
+            <pc:docMk/>
+            <pc:sldMk cId="601496234" sldId="533"/>
+            <ac:spMk id="1044" creationId="{75470B80-147E-475F-A4A3-BAFF5796EB38}"/>
+          </ac:spMkLst>
+        </pc:spChg>
+      </pc:sldChg>
+      <pc:sldChg chg="modSp">
+        <pc:chgData name="Mohammed Fasha" userId="cc64f42d-a1a6-4f08-b97b-0c37f877119f" providerId="ADAL" clId="{C411E271-76BA-4F65-AAC3-462D3CC4567C}" dt="2025-03-16T06:40:23.281" v="69" actId="1076"/>
+        <pc:sldMkLst>
+          <pc:docMk/>
+          <pc:sldMk cId="514683601" sldId="538"/>
+        </pc:sldMkLst>
+        <pc:spChg chg="mod">
+          <ac:chgData name="Mohammed Fasha" userId="cc64f42d-a1a6-4f08-b97b-0c37f877119f" providerId="ADAL" clId="{C411E271-76BA-4F65-AAC3-462D3CC4567C}" dt="2025-03-16T06:40:23.281" v="69" actId="1076"/>
+          <ac:spMkLst>
+            <pc:docMk/>
+            <pc:sldMk cId="514683601" sldId="538"/>
+            <ac:spMk id="9" creationId="{75B9AF69-3646-8E91-9453-C8E6CB2B3637}"/>
+          </ac:spMkLst>
+        </pc:spChg>
+      </pc:sldChg>
+      <pc:sldChg chg="modSp">
+        <pc:chgData name="Mohammed Fasha" userId="cc64f42d-a1a6-4f08-b97b-0c37f877119f" providerId="ADAL" clId="{C411E271-76BA-4F65-AAC3-462D3CC4567C}" dt="2025-03-16T06:41:36.036" v="156" actId="113"/>
+        <pc:sldMkLst>
+          <pc:docMk/>
+          <pc:sldMk cId="2711506933" sldId="539"/>
+        </pc:sldMkLst>
+        <pc:spChg chg="mod">
+          <ac:chgData name="Mohammed Fasha" userId="cc64f42d-a1a6-4f08-b97b-0c37f877119f" providerId="ADAL" clId="{C411E271-76BA-4F65-AAC3-462D3CC4567C}" dt="2025-03-16T06:40:45.011" v="74" actId="27636"/>
+          <ac:spMkLst>
+            <pc:docMk/>
+            <pc:sldMk cId="2711506933" sldId="539"/>
+            <ac:spMk id="4" creationId="{F25A1EB7-D40C-B625-AFB4-8394BE551BEA}"/>
+          </ac:spMkLst>
+        </pc:spChg>
+        <pc:spChg chg="mod">
+          <ac:chgData name="Mohammed Fasha" userId="cc64f42d-a1a6-4f08-b97b-0c37f877119f" providerId="ADAL" clId="{C411E271-76BA-4F65-AAC3-462D3CC4567C}" dt="2025-03-16T06:41:36.036" v="156" actId="113"/>
+          <ac:spMkLst>
+            <pc:docMk/>
+            <pc:sldMk cId="2711506933" sldId="539"/>
+            <ac:spMk id="5" creationId="{2FB81DB4-B6A3-092F-D836-C7A4C6021F60}"/>
+          </ac:spMkLst>
+        </pc:spChg>
+      </pc:sldChg>
+      <pc:sldChg chg="modSp">
+        <pc:chgData name="Mohammed Fasha" userId="cc64f42d-a1a6-4f08-b97b-0c37f877119f" providerId="ADAL" clId="{C411E271-76BA-4F65-AAC3-462D3CC4567C}" dt="2025-03-16T06:42:32.733" v="160" actId="6549"/>
+        <pc:sldMkLst>
+          <pc:docMk/>
+          <pc:sldMk cId="3088397267" sldId="543"/>
+        </pc:sldMkLst>
+        <pc:spChg chg="mod">
+          <ac:chgData name="Mohammed Fasha" userId="cc64f42d-a1a6-4f08-b97b-0c37f877119f" providerId="ADAL" clId="{C411E271-76BA-4F65-AAC3-462D3CC4567C}" dt="2025-03-16T06:42:32.733" v="160" actId="6549"/>
+          <ac:spMkLst>
+            <pc:docMk/>
+            <pc:sldMk cId="3088397267" sldId="543"/>
+            <ac:spMk id="2" creationId="{E9C280EE-865C-D7D4-DFE1-0BC32081155C}"/>
+          </ac:spMkLst>
+        </pc:spChg>
+      </pc:sldChg>
+      <pc:sldChg chg="modSp">
+        <pc:chgData name="Mohammed Fasha" userId="cc64f42d-a1a6-4f08-b97b-0c37f877119f" providerId="ADAL" clId="{C411E271-76BA-4F65-AAC3-462D3CC4567C}" dt="2025-03-16T06:34:03.041" v="12" actId="1076"/>
+        <pc:sldMkLst>
+          <pc:docMk/>
+          <pc:sldMk cId="51728829" sldId="550"/>
+        </pc:sldMkLst>
+        <pc:spChg chg="mod">
+          <ac:chgData name="Mohammed Fasha" userId="cc64f42d-a1a6-4f08-b97b-0c37f877119f" providerId="ADAL" clId="{C411E271-76BA-4F65-AAC3-462D3CC4567C}" dt="2025-03-16T06:34:03.041" v="12" actId="1076"/>
+          <ac:spMkLst>
+            <pc:docMk/>
+            <pc:sldMk cId="51728829" sldId="550"/>
+            <ac:spMk id="5" creationId="{E4B45F60-6A90-D73F-5226-35583B598BAF}"/>
+          </ac:spMkLst>
+        </pc:spChg>
+        <pc:picChg chg="mod">
+          <ac:chgData name="Mohammed Fasha" userId="cc64f42d-a1a6-4f08-b97b-0c37f877119f" providerId="ADAL" clId="{C411E271-76BA-4F65-AAC3-462D3CC4567C}" dt="2025-03-16T06:33:51.803" v="10" actId="1076"/>
+          <ac:picMkLst>
+            <pc:docMk/>
+            <pc:sldMk cId="51728829" sldId="550"/>
+            <ac:picMk id="7" creationId="{4E45092A-0334-B657-140F-ACD092334510}"/>
+          </ac:picMkLst>
+        </pc:picChg>
+      </pc:sldChg>
+      <pc:sldChg chg="addSp modSp add">
+        <pc:chgData name="Mohammed Fasha" userId="cc64f42d-a1a6-4f08-b97b-0c37f877119f" providerId="ADAL" clId="{C411E271-76BA-4F65-AAC3-462D3CC4567C}" dt="2025-03-16T06:42:54.392" v="163" actId="12"/>
+        <pc:sldMkLst>
+          <pc:docMk/>
+          <pc:sldMk cId="3239849650" sldId="559"/>
+        </pc:sldMkLst>
+        <pc:spChg chg="add mod">
+          <ac:chgData name="Mohammed Fasha" userId="cc64f42d-a1a6-4f08-b97b-0c37f877119f" providerId="ADAL" clId="{C411E271-76BA-4F65-AAC3-462D3CC4567C}" dt="2025-03-16T06:41:05.571" v="131" actId="20577"/>
+          <ac:spMkLst>
+            <pc:docMk/>
+            <pc:sldMk cId="3239849650" sldId="559"/>
+            <ac:spMk id="2" creationId="{887C57B6-3E6E-4198-898B-15902BBEF30D}"/>
+          </ac:spMkLst>
+        </pc:spChg>
+        <pc:spChg chg="add mod">
+          <ac:chgData name="Mohammed Fasha" userId="cc64f42d-a1a6-4f08-b97b-0c37f877119f" providerId="ADAL" clId="{C411E271-76BA-4F65-AAC3-462D3CC4567C}" dt="2025-03-16T06:42:54.392" v="163" actId="12"/>
+          <ac:spMkLst>
+            <pc:docMk/>
+            <pc:sldMk cId="3239849650" sldId="559"/>
+            <ac:spMk id="3" creationId="{FB5E93FF-24A9-43C1-B819-289CE164A1E4}"/>
+          </ac:spMkLst>
+        </pc:spChg>
+      </pc:sldChg>
+    </pc:docChg>
+  </pc:docChgLst>
 </pc:chgInfo>
 </file>
 
@@ -2796,7 +2031,7 @@
           <a:p>
             <a:fld id="{13BA03A4-B9F1-404C-8A74-B1AFD6480953}" type="datetimeFigureOut">
               <a:rPr lang="en-US" smtClean="0"/>
-              <a:t>3/15/2025</a:t>
+              <a:t>3/16/2025</a:t>
             </a:fld>
             <a:endParaRPr lang="en-US"/>
           </a:p>
@@ -3210,7 +2445,7 @@
           <a:p>
             <a:fld id="{0DB78E95-DE77-44D3-BDB9-E242948FB112}" type="datetimeFigureOut">
               <a:rPr lang="en-US" smtClean="0"/>
-              <a:t>3/15/2025</a:t>
+              <a:t>3/16/2025</a:t>
             </a:fld>
             <a:endParaRPr lang="en-US"/>
           </a:p>
@@ -3438,7 +2673,7 @@
           <a:p>
             <a:fld id="{0DB78E95-DE77-44D3-BDB9-E242948FB112}" type="datetimeFigureOut">
               <a:rPr lang="en-US" smtClean="0"/>
-              <a:t>3/15/2025</a:t>
+              <a:t>3/16/2025</a:t>
             </a:fld>
             <a:endParaRPr lang="en-US"/>
           </a:p>
@@ -3646,7 +2881,7 @@
           <a:p>
             <a:fld id="{0DB78E95-DE77-44D3-BDB9-E242948FB112}" type="datetimeFigureOut">
               <a:rPr lang="en-US" smtClean="0"/>
-              <a:t>3/15/2025</a:t>
+              <a:t>3/16/2025</a:t>
             </a:fld>
             <a:endParaRPr lang="en-US"/>
           </a:p>
@@ -4077,7 +3312,7 @@
           <a:p>
             <a:fld id="{0DB78E95-DE77-44D3-BDB9-E242948FB112}" type="datetimeFigureOut">
               <a:rPr lang="en-US" smtClean="0"/>
-              <a:t>3/15/2025</a:t>
+              <a:t>3/16/2025</a:t>
             </a:fld>
             <a:endParaRPr lang="en-US"/>
           </a:p>
@@ -4456,7 +3691,7 @@
           <a:p>
             <a:fld id="{0DB78E95-DE77-44D3-BDB9-E242948FB112}" type="datetimeFigureOut">
               <a:rPr lang="en-US" smtClean="0"/>
-              <a:t>3/15/2025</a:t>
+              <a:t>3/16/2025</a:t>
             </a:fld>
             <a:endParaRPr lang="en-US"/>
           </a:p>
@@ -4868,7 +4103,7 @@
           <a:p>
             <a:fld id="{0DB78E95-DE77-44D3-BDB9-E242948FB112}" type="datetimeFigureOut">
               <a:rPr lang="en-US" smtClean="0"/>
-              <a:t>3/15/2025</a:t>
+              <a:t>3/16/2025</a:t>
             </a:fld>
             <a:endParaRPr lang="en-US"/>
           </a:p>
@@ -5009,7 +4244,7 @@
           <a:p>
             <a:fld id="{0DB78E95-DE77-44D3-BDB9-E242948FB112}" type="datetimeFigureOut">
               <a:rPr lang="en-US" smtClean="0"/>
-              <a:t>3/15/2025</a:t>
+              <a:t>3/16/2025</a:t>
             </a:fld>
             <a:endParaRPr lang="en-US"/>
           </a:p>
@@ -5122,7 +4357,7 @@
           <a:p>
             <a:fld id="{0DB78E95-DE77-44D3-BDB9-E242948FB112}" type="datetimeFigureOut">
               <a:rPr lang="en-US" smtClean="0"/>
-              <a:t>3/15/2025</a:t>
+              <a:t>3/16/2025</a:t>
             </a:fld>
             <a:endParaRPr lang="en-US"/>
           </a:p>
@@ -5433,7 +4668,7 @@
           <a:p>
             <a:fld id="{0DB78E95-DE77-44D3-BDB9-E242948FB112}" type="datetimeFigureOut">
               <a:rPr lang="en-US" smtClean="0"/>
-              <a:t>3/15/2025</a:t>
+              <a:t>3/16/2025</a:t>
             </a:fld>
             <a:endParaRPr lang="en-US"/>
           </a:p>
@@ -5721,7 +4956,7 @@
           <a:p>
             <a:fld id="{0DB78E95-DE77-44D3-BDB9-E242948FB112}" type="datetimeFigureOut">
               <a:rPr lang="en-US" smtClean="0"/>
-              <a:t>3/15/2025</a:t>
+              <a:t>3/16/2025</a:t>
             </a:fld>
             <a:endParaRPr lang="en-US"/>
           </a:p>
@@ -5962,7 +5197,7 @@
           <a:p>
             <a:fld id="{0DB78E95-DE77-44D3-BDB9-E242948FB112}" type="datetimeFigureOut">
               <a:rPr lang="en-US" smtClean="0"/>
-              <a:t>3/15/2025</a:t>
+              <a:t>3/16/2025</a:t>
             </a:fld>
             <a:endParaRPr lang="en-US"/>
           </a:p>
@@ -8408,7 +7643,7 @@
         </p:nvSpPr>
         <p:spPr>
           <a:xfrm>
-            <a:off x="990600" y="3398170"/>
+            <a:off x="838200" y="3429000"/>
             <a:ext cx="10017034" cy="286360"/>
           </a:xfrm>
           <a:prstGeom prst="rect">
@@ -8452,6 +7687,109 @@
 </file>
 
 <file path=ppt/slides/slide15.xml><?xml version="1.0" encoding="utf-8"?>
+<p:sld xmlns:a="http://schemas.openxmlformats.org/drawingml/2006/main" xmlns:r="http://schemas.openxmlformats.org/officeDocument/2006/relationships" xmlns:p="http://schemas.openxmlformats.org/presentationml/2006/main">
+  <p:cSld>
+    <p:spTree>
+      <p:nvGrpSpPr>
+        <p:cNvPr id="1" name=""/>
+        <p:cNvGrpSpPr/>
+        <p:nvPr/>
+      </p:nvGrpSpPr>
+      <p:grpSpPr>
+        <a:xfrm>
+          <a:off x="0" y="0"/>
+          <a:ext cx="0" cy="0"/>
+          <a:chOff x="0" y="0"/>
+          <a:chExt cx="0" cy="0"/>
+        </a:xfrm>
+      </p:grpSpPr>
+      <p:sp>
+        <p:nvSpPr>
+          <p:cNvPr id="2" name="Title 1">
+            <a:extLst>
+              <a:ext uri="{FF2B5EF4-FFF2-40B4-BE49-F238E27FC236}">
+                <a16:creationId xmlns:a16="http://schemas.microsoft.com/office/drawing/2014/main" id="{887C57B6-3E6E-4198-898B-15902BBEF30D}"/>
+              </a:ext>
+            </a:extLst>
+          </p:cNvPr>
+          <p:cNvSpPr>
+            <a:spLocks noGrp="1"/>
+          </p:cNvSpPr>
+          <p:nvPr>
+            <p:ph type="title"/>
+          </p:nvPr>
+        </p:nvSpPr>
+        <p:spPr/>
+        <p:txBody>
+          <a:bodyPr/>
+          <a:lstStyle/>
+          <a:p>
+            <a:r>
+              <a:rPr lang="en-US" dirty="0"/>
+              <a:t>Representing Text – Converting Text into Numbers</a:t>
+            </a:r>
+          </a:p>
+        </p:txBody>
+      </p:sp>
+      <p:sp>
+        <p:nvSpPr>
+          <p:cNvPr id="3" name="Content Placeholder 2">
+            <a:extLst>
+              <a:ext uri="{FF2B5EF4-FFF2-40B4-BE49-F238E27FC236}">
+                <a16:creationId xmlns:a16="http://schemas.microsoft.com/office/drawing/2014/main" id="{FB5E93FF-24A9-43C1-B819-289CE164A1E4}"/>
+              </a:ext>
+            </a:extLst>
+          </p:cNvPr>
+          <p:cNvSpPr>
+            <a:spLocks noGrp="1"/>
+          </p:cNvSpPr>
+          <p:nvPr>
+            <p:ph idx="1"/>
+          </p:nvPr>
+        </p:nvSpPr>
+        <p:spPr/>
+        <p:txBody>
+          <a:bodyPr/>
+          <a:lstStyle/>
+          <a:p>
+            <a:pPr marL="457200" indent="-457200">
+              <a:buFont typeface="+mj-lt"/>
+              <a:buAutoNum type="arabicPeriod"/>
+            </a:pPr>
+            <a:r>
+              <a:rPr lang="en-US" dirty="0"/>
+              <a:t>Bag of Words Method.</a:t>
+            </a:r>
+          </a:p>
+          <a:p>
+            <a:pPr marL="457200" indent="-457200">
+              <a:buFont typeface="+mj-lt"/>
+              <a:buAutoNum type="arabicPeriod"/>
+            </a:pPr>
+            <a:r>
+              <a:rPr lang="en-US" dirty="0"/>
+              <a:t>TF-IDF (Term Frequency-Inverse Document Frequency)</a:t>
+            </a:r>
+          </a:p>
+          <a:p>
+            <a:endParaRPr lang="en-US" dirty="0"/>
+          </a:p>
+        </p:txBody>
+      </p:sp>
+    </p:spTree>
+    <p:extLst>
+      <p:ext uri="{BB962C8B-B14F-4D97-AF65-F5344CB8AC3E}">
+        <p14:creationId xmlns:p14="http://schemas.microsoft.com/office/powerpoint/2010/main" val="3239849650"/>
+      </p:ext>
+    </p:extLst>
+  </p:cSld>
+  <p:clrMapOvr>
+    <a:masterClrMapping/>
+  </p:clrMapOvr>
+</p:sld>
+</file>
+
+<file path=ppt/slides/slide16.xml><?xml version="1.0" encoding="utf-8"?>
 <p:sld xmlns:a="http://schemas.openxmlformats.org/drawingml/2006/main" xmlns:r="http://schemas.openxmlformats.org/officeDocument/2006/relationships" xmlns:p="http://schemas.openxmlformats.org/presentationml/2006/main">
   <p:cSld>
     <p:spTree>
@@ -8487,20 +7825,13 @@
         <p:spPr/>
         <p:txBody>
           <a:bodyPr>
-            <a:normAutofit fontScale="90000"/>
+            <a:normAutofit/>
           </a:bodyPr>
           <a:lstStyle/>
           <a:p>
             <a:r>
               <a:rPr lang="en-US" dirty="0"/>
-              <a:t>Representing Text</a:t>
-            </a:r>
-            <a:br>
-              <a:rPr lang="en-US" dirty="0"/>
-            </a:br>
-            <a:r>
-              <a:rPr lang="en-US" dirty="0"/>
-              <a:t>Bag of Words (</a:t>
+              <a:t>Representing Text - Bag of Words (</a:t>
             </a:r>
             <a:r>
               <a:rPr lang="en-US" dirty="0" err="1"/>
@@ -8532,18 +7863,24 @@
         <p:spPr/>
         <p:txBody>
           <a:bodyPr>
-            <a:normAutofit fontScale="92500" lnSpcReduction="10000"/>
+            <a:normAutofit fontScale="92500"/>
           </a:bodyPr>
           <a:lstStyle/>
           <a:p>
+            <a:pPr marL="0" indent="0">
+              <a:buNone/>
+            </a:pPr>
             <a:r>
               <a:rPr lang="en-US" dirty="0"/>
               <a:t>Bag of Words is a fundamental technique in Natural Language Processing (NLP) that represents text as a collection of word frequencies, disregarding grammar and word order.</a:t>
             </a:r>
           </a:p>
           <a:p>
-            <a:r>
-              <a:rPr lang="en-US" dirty="0"/>
+            <a:pPr marL="0" indent="0">
+              <a:buNone/>
+            </a:pPr>
+            <a:r>
+              <a:rPr lang="en-US" b="1" dirty="0"/>
               <a:t>Core Concept</a:t>
             </a:r>
           </a:p>
@@ -8637,7 +7974,7 @@
 </p:sld>
 </file>
 
-<file path=ppt/slides/slide16.xml><?xml version="1.0" encoding="utf-8"?>
+<file path=ppt/slides/slide17.xml><?xml version="1.0" encoding="utf-8"?>
 <p:sld xmlns:a="http://schemas.openxmlformats.org/drawingml/2006/main" xmlns:r="http://schemas.openxmlformats.org/officeDocument/2006/relationships" xmlns:p="http://schemas.openxmlformats.org/presentationml/2006/main">
   <p:cSld>
     <p:spTree>
@@ -8876,7 +8213,7 @@
 </p:sld>
 </file>
 
-<file path=ppt/slides/slide17.xml><?xml version="1.0" encoding="utf-8"?>
+<file path=ppt/slides/slide18.xml><?xml version="1.0" encoding="utf-8"?>
 <p:sld xmlns:a="http://schemas.openxmlformats.org/drawingml/2006/main" xmlns:r="http://schemas.openxmlformats.org/officeDocument/2006/relationships" xmlns:p="http://schemas.openxmlformats.org/presentationml/2006/main">
   <p:cSld>
     <p:spTree>
@@ -9468,7 +8805,7 @@
 </p:sld>
 </file>
 
-<file path=ppt/slides/slide18.xml><?xml version="1.0" encoding="utf-8"?>
+<file path=ppt/slides/slide19.xml><?xml version="1.0" encoding="utf-8"?>
 <p:sld xmlns:a="http://schemas.openxmlformats.org/drawingml/2006/main" xmlns:r="http://schemas.openxmlformats.org/officeDocument/2006/relationships" xmlns:p="http://schemas.openxmlformats.org/presentationml/2006/main">
   <p:cSld>
     <p:spTree>
@@ -9510,14 +8847,7 @@
           <a:p>
             <a:r>
               <a:rPr lang="en-US" dirty="0"/>
-              <a:t>Representing Text</a:t>
-            </a:r>
-            <a:br>
-              <a:rPr lang="en-US" dirty="0"/>
-            </a:br>
-            <a:r>
-              <a:rPr lang="en-US" dirty="0"/>
-              <a:t>TF-IDF (Term Frequency-Inverse Document Frequency)</a:t>
+              <a:t>Representing Text - TF-IDF (Term Frequency-Inverse Document Frequency)</a:t>
             </a:r>
           </a:p>
         </p:txBody>
@@ -9655,213 +8985,6 @@
     <p:extLst>
       <p:ext uri="{BB962C8B-B14F-4D97-AF65-F5344CB8AC3E}">
         <p14:creationId xmlns:p14="http://schemas.microsoft.com/office/powerpoint/2010/main" val="3088397267"/>
-      </p:ext>
-    </p:extLst>
-  </p:cSld>
-  <p:clrMapOvr>
-    <a:masterClrMapping/>
-  </p:clrMapOvr>
-</p:sld>
-</file>
-
-<file path=ppt/slides/slide19.xml><?xml version="1.0" encoding="utf-8"?>
-<p:sld xmlns:a="http://schemas.openxmlformats.org/drawingml/2006/main" xmlns:r="http://schemas.openxmlformats.org/officeDocument/2006/relationships" xmlns:p="http://schemas.openxmlformats.org/presentationml/2006/main">
-  <p:cSld>
-    <p:spTree>
-      <p:nvGrpSpPr>
-        <p:cNvPr id="1" name=""/>
-        <p:cNvGrpSpPr/>
-        <p:nvPr/>
-      </p:nvGrpSpPr>
-      <p:grpSpPr>
-        <a:xfrm>
-          <a:off x="0" y="0"/>
-          <a:ext cx="0" cy="0"/>
-          <a:chOff x="0" y="0"/>
-          <a:chExt cx="0" cy="0"/>
-        </a:xfrm>
-      </p:grpSpPr>
-      <p:sp>
-        <p:nvSpPr>
-          <p:cNvPr id="2" name="Title 1">
-            <a:extLst>
-              <a:ext uri="{FF2B5EF4-FFF2-40B4-BE49-F238E27FC236}">
-                <a16:creationId xmlns:a16="http://schemas.microsoft.com/office/drawing/2014/main" id="{6D6CD322-7C4B-DC57-D26A-F5E7F2BC26F0}"/>
-              </a:ext>
-            </a:extLst>
-          </p:cNvPr>
-          <p:cNvSpPr>
-            <a:spLocks noGrp="1"/>
-          </p:cNvSpPr>
-          <p:nvPr>
-            <p:ph type="title"/>
-          </p:nvPr>
-        </p:nvSpPr>
-        <p:spPr/>
-        <p:txBody>
-          <a:bodyPr/>
-          <a:lstStyle/>
-          <a:p>
-            <a:r>
-              <a:rPr lang="en-US" dirty="0"/>
-              <a:t>TF-IDF (Term Frequency-Inverse Document Frequency)</a:t>
-            </a:r>
-          </a:p>
-        </p:txBody>
-      </p:sp>
-      <p:sp>
-        <p:nvSpPr>
-          <p:cNvPr id="3" name="Content Placeholder 2">
-            <a:extLst>
-              <a:ext uri="{FF2B5EF4-FFF2-40B4-BE49-F238E27FC236}">
-                <a16:creationId xmlns:a16="http://schemas.microsoft.com/office/drawing/2014/main" id="{5DDC1007-FCCB-A791-C158-E92A75DD215B}"/>
-              </a:ext>
-            </a:extLst>
-          </p:cNvPr>
-          <p:cNvSpPr>
-            <a:spLocks noGrp="1"/>
-          </p:cNvSpPr>
-          <p:nvPr>
-            <p:ph idx="1"/>
-          </p:nvPr>
-        </p:nvSpPr>
-        <p:spPr/>
-        <p:txBody>
-          <a:bodyPr>
-            <a:normAutofit lnSpcReduction="10000"/>
-          </a:bodyPr>
-          <a:lstStyle/>
-          <a:p>
-            <a:pPr>
-              <a:buNone/>
-            </a:pPr>
-            <a:r>
-              <a:rPr lang="en-US" b="1" dirty="0"/>
-              <a:t>Example</a:t>
-            </a:r>
-          </a:p>
-          <a:p>
-            <a:pPr>
-              <a:buNone/>
-            </a:pPr>
-            <a:r>
-              <a:rPr lang="en-US" dirty="0"/>
-              <a:t>For documents:</a:t>
-            </a:r>
-          </a:p>
-          <a:p>
-            <a:pPr>
-              <a:buFont typeface="Arial" panose="020B0604020202020204" pitchFamily="34" charset="0"/>
-              <a:buChar char="•"/>
-            </a:pPr>
-            <a:r>
-              <a:rPr lang="en-US" dirty="0"/>
-              <a:t>Doc1: "I love machine learning"</a:t>
-            </a:r>
-          </a:p>
-          <a:p>
-            <a:pPr>
-              <a:buFont typeface="Arial" panose="020B0604020202020204" pitchFamily="34" charset="0"/>
-              <a:buChar char="•"/>
-            </a:pPr>
-            <a:r>
-              <a:rPr lang="en-US" dirty="0"/>
-              <a:t>Doc2: "I love natural language processing"</a:t>
-            </a:r>
-          </a:p>
-          <a:p>
-            <a:pPr>
-              <a:buFont typeface="Arial" panose="020B0604020202020204" pitchFamily="34" charset="0"/>
-              <a:buChar char="•"/>
-            </a:pPr>
-            <a:r>
-              <a:rPr lang="en-US" dirty="0"/>
-              <a:t>Doc3: "Machine learning models require data"</a:t>
-            </a:r>
-          </a:p>
-          <a:p>
-            <a:pPr marL="0" indent="0">
-              <a:buNone/>
-            </a:pPr>
-            <a:r>
-              <a:rPr lang="en-US" dirty="0"/>
-              <a:t>The word "love" appears in multiple documents, so its IDF value is lower. The word "processing" appears in only one document, giving it a higher IDF value.</a:t>
-            </a:r>
-          </a:p>
-          <a:p>
-            <a:pPr>
-              <a:buNone/>
-            </a:pPr>
-            <a:r>
-              <a:rPr lang="en-US" b="1" dirty="0"/>
-              <a:t>Applications</a:t>
-            </a:r>
-          </a:p>
-          <a:p>
-            <a:pPr>
-              <a:buFont typeface="Arial" panose="020B0604020202020204" pitchFamily="34" charset="0"/>
-              <a:buChar char="•"/>
-            </a:pPr>
-            <a:r>
-              <a:rPr lang="en-US" b="1" dirty="0"/>
-              <a:t>Document retrieval and search engines</a:t>
-            </a:r>
-            <a:r>
-              <a:rPr lang="en-US" dirty="0"/>
-              <a:t>: Ranking documents by relevance</a:t>
-            </a:r>
-          </a:p>
-          <a:p>
-            <a:pPr>
-              <a:buFont typeface="Arial" panose="020B0604020202020204" pitchFamily="34" charset="0"/>
-              <a:buChar char="•"/>
-            </a:pPr>
-            <a:r>
-              <a:rPr lang="en-US" b="1" dirty="0"/>
-              <a:t>Document classification</a:t>
-            </a:r>
-            <a:r>
-              <a:rPr lang="en-US" dirty="0"/>
-              <a:t>: Identifying distinguishing terms</a:t>
-            </a:r>
-          </a:p>
-          <a:p>
-            <a:pPr>
-              <a:buFont typeface="Arial" panose="020B0604020202020204" pitchFamily="34" charset="0"/>
-              <a:buChar char="•"/>
-            </a:pPr>
-            <a:r>
-              <a:rPr lang="en-US" b="1" dirty="0"/>
-              <a:t>Keyword extraction</a:t>
-            </a:r>
-            <a:r>
-              <a:rPr lang="en-US" dirty="0"/>
-              <a:t>: Finding important terms in documents</a:t>
-            </a:r>
-          </a:p>
-          <a:p>
-            <a:pPr>
-              <a:buFont typeface="Arial" panose="020B0604020202020204" pitchFamily="34" charset="0"/>
-              <a:buChar char="•"/>
-            </a:pPr>
-            <a:r>
-              <a:rPr lang="en-US" b="1" dirty="0"/>
-              <a:t>Text summarization</a:t>
-            </a:r>
-            <a:r>
-              <a:rPr lang="en-US" dirty="0"/>
-              <a:t>: Identifying key sentences</a:t>
-            </a:r>
-          </a:p>
-          <a:p>
-            <a:endParaRPr lang="en-US" dirty="0"/>
-          </a:p>
-        </p:txBody>
-      </p:sp>
-    </p:spTree>
-    <p:extLst>
-      <p:ext uri="{BB962C8B-B14F-4D97-AF65-F5344CB8AC3E}">
-        <p14:creationId xmlns:p14="http://schemas.microsoft.com/office/powerpoint/2010/main" val="3439562204"/>
       </p:ext>
     </p:extLst>
   </p:cSld>
@@ -10039,6 +9162,213 @@
   <p:cSld>
     <p:spTree>
       <p:nvGrpSpPr>
+        <p:cNvPr id="1" name=""/>
+        <p:cNvGrpSpPr/>
+        <p:nvPr/>
+      </p:nvGrpSpPr>
+      <p:grpSpPr>
+        <a:xfrm>
+          <a:off x="0" y="0"/>
+          <a:ext cx="0" cy="0"/>
+          <a:chOff x="0" y="0"/>
+          <a:chExt cx="0" cy="0"/>
+        </a:xfrm>
+      </p:grpSpPr>
+      <p:sp>
+        <p:nvSpPr>
+          <p:cNvPr id="2" name="Title 1">
+            <a:extLst>
+              <a:ext uri="{FF2B5EF4-FFF2-40B4-BE49-F238E27FC236}">
+                <a16:creationId xmlns:a16="http://schemas.microsoft.com/office/drawing/2014/main" id="{6D6CD322-7C4B-DC57-D26A-F5E7F2BC26F0}"/>
+              </a:ext>
+            </a:extLst>
+          </p:cNvPr>
+          <p:cNvSpPr>
+            <a:spLocks noGrp="1"/>
+          </p:cNvSpPr>
+          <p:nvPr>
+            <p:ph type="title"/>
+          </p:nvPr>
+        </p:nvSpPr>
+        <p:spPr/>
+        <p:txBody>
+          <a:bodyPr/>
+          <a:lstStyle/>
+          <a:p>
+            <a:r>
+              <a:rPr lang="en-US" dirty="0"/>
+              <a:t>TF-IDF (Term Frequency-Inverse Document Frequency)</a:t>
+            </a:r>
+          </a:p>
+        </p:txBody>
+      </p:sp>
+      <p:sp>
+        <p:nvSpPr>
+          <p:cNvPr id="3" name="Content Placeholder 2">
+            <a:extLst>
+              <a:ext uri="{FF2B5EF4-FFF2-40B4-BE49-F238E27FC236}">
+                <a16:creationId xmlns:a16="http://schemas.microsoft.com/office/drawing/2014/main" id="{5DDC1007-FCCB-A791-C158-E92A75DD215B}"/>
+              </a:ext>
+            </a:extLst>
+          </p:cNvPr>
+          <p:cNvSpPr>
+            <a:spLocks noGrp="1"/>
+          </p:cNvSpPr>
+          <p:nvPr>
+            <p:ph idx="1"/>
+          </p:nvPr>
+        </p:nvSpPr>
+        <p:spPr/>
+        <p:txBody>
+          <a:bodyPr>
+            <a:normAutofit lnSpcReduction="10000"/>
+          </a:bodyPr>
+          <a:lstStyle/>
+          <a:p>
+            <a:pPr>
+              <a:buNone/>
+            </a:pPr>
+            <a:r>
+              <a:rPr lang="en-US" b="1" dirty="0"/>
+              <a:t>Example</a:t>
+            </a:r>
+          </a:p>
+          <a:p>
+            <a:pPr>
+              <a:buNone/>
+            </a:pPr>
+            <a:r>
+              <a:rPr lang="en-US" dirty="0"/>
+              <a:t>For documents:</a:t>
+            </a:r>
+          </a:p>
+          <a:p>
+            <a:pPr>
+              <a:buFont typeface="Arial" panose="020B0604020202020204" pitchFamily="34" charset="0"/>
+              <a:buChar char="•"/>
+            </a:pPr>
+            <a:r>
+              <a:rPr lang="en-US" dirty="0"/>
+              <a:t>Doc1: "I love machine learning"</a:t>
+            </a:r>
+          </a:p>
+          <a:p>
+            <a:pPr>
+              <a:buFont typeface="Arial" panose="020B0604020202020204" pitchFamily="34" charset="0"/>
+              <a:buChar char="•"/>
+            </a:pPr>
+            <a:r>
+              <a:rPr lang="en-US" dirty="0"/>
+              <a:t>Doc2: "I love natural language processing"</a:t>
+            </a:r>
+          </a:p>
+          <a:p>
+            <a:pPr>
+              <a:buFont typeface="Arial" panose="020B0604020202020204" pitchFamily="34" charset="0"/>
+              <a:buChar char="•"/>
+            </a:pPr>
+            <a:r>
+              <a:rPr lang="en-US" dirty="0"/>
+              <a:t>Doc3: "Machine learning models require data"</a:t>
+            </a:r>
+          </a:p>
+          <a:p>
+            <a:pPr marL="0" indent="0">
+              <a:buNone/>
+            </a:pPr>
+            <a:r>
+              <a:rPr lang="en-US" dirty="0"/>
+              <a:t>The word "love" appears in multiple documents, so its IDF value is lower. The word "processing" appears in only one document, giving it a higher IDF value.</a:t>
+            </a:r>
+          </a:p>
+          <a:p>
+            <a:pPr>
+              <a:buNone/>
+            </a:pPr>
+            <a:r>
+              <a:rPr lang="en-US" b="1" dirty="0"/>
+              <a:t>Applications</a:t>
+            </a:r>
+          </a:p>
+          <a:p>
+            <a:pPr>
+              <a:buFont typeface="Arial" panose="020B0604020202020204" pitchFamily="34" charset="0"/>
+              <a:buChar char="•"/>
+            </a:pPr>
+            <a:r>
+              <a:rPr lang="en-US" b="1" dirty="0"/>
+              <a:t>Document retrieval and search engines</a:t>
+            </a:r>
+            <a:r>
+              <a:rPr lang="en-US" dirty="0"/>
+              <a:t>: Ranking documents by relevance</a:t>
+            </a:r>
+          </a:p>
+          <a:p>
+            <a:pPr>
+              <a:buFont typeface="Arial" panose="020B0604020202020204" pitchFamily="34" charset="0"/>
+              <a:buChar char="•"/>
+            </a:pPr>
+            <a:r>
+              <a:rPr lang="en-US" b="1" dirty="0"/>
+              <a:t>Document classification</a:t>
+            </a:r>
+            <a:r>
+              <a:rPr lang="en-US" dirty="0"/>
+              <a:t>: Identifying distinguishing terms</a:t>
+            </a:r>
+          </a:p>
+          <a:p>
+            <a:pPr>
+              <a:buFont typeface="Arial" panose="020B0604020202020204" pitchFamily="34" charset="0"/>
+              <a:buChar char="•"/>
+            </a:pPr>
+            <a:r>
+              <a:rPr lang="en-US" b="1" dirty="0"/>
+              <a:t>Keyword extraction</a:t>
+            </a:r>
+            <a:r>
+              <a:rPr lang="en-US" dirty="0"/>
+              <a:t>: Finding important terms in documents</a:t>
+            </a:r>
+          </a:p>
+          <a:p>
+            <a:pPr>
+              <a:buFont typeface="Arial" panose="020B0604020202020204" pitchFamily="34" charset="0"/>
+              <a:buChar char="•"/>
+            </a:pPr>
+            <a:r>
+              <a:rPr lang="en-US" b="1" dirty="0"/>
+              <a:t>Text summarization</a:t>
+            </a:r>
+            <a:r>
+              <a:rPr lang="en-US" dirty="0"/>
+              <a:t>: Identifying key sentences</a:t>
+            </a:r>
+          </a:p>
+          <a:p>
+            <a:endParaRPr lang="en-US" dirty="0"/>
+          </a:p>
+        </p:txBody>
+      </p:sp>
+    </p:spTree>
+    <p:extLst>
+      <p:ext uri="{BB962C8B-B14F-4D97-AF65-F5344CB8AC3E}">
+        <p14:creationId xmlns:p14="http://schemas.microsoft.com/office/powerpoint/2010/main" val="3439562204"/>
+      </p:ext>
+    </p:extLst>
+  </p:cSld>
+  <p:clrMapOvr>
+    <a:masterClrMapping/>
+  </p:clrMapOvr>
+</p:sld>
+</file>
+
+<file path=ppt/slides/slide21.xml><?xml version="1.0" encoding="utf-8"?>
+<p:sld xmlns:a="http://schemas.openxmlformats.org/drawingml/2006/main" xmlns:r="http://schemas.openxmlformats.org/officeDocument/2006/relationships" xmlns:p="http://schemas.openxmlformats.org/presentationml/2006/main">
+  <p:cSld>
+    <p:spTree>
+      <p:nvGrpSpPr>
         <p:cNvPr id="1" name="">
           <a:extLst>
             <a:ext uri="{FF2B5EF4-FFF2-40B4-BE49-F238E27FC236}">
@@ -10229,7 +9559,7 @@
 </p:sld>
 </file>
 
-<file path=ppt/slides/slide21.xml><?xml version="1.0" encoding="utf-8"?>
+<file path=ppt/slides/slide22.xml><?xml version="1.0" encoding="utf-8"?>
 <p:sld xmlns:a="http://schemas.openxmlformats.org/drawingml/2006/main" xmlns:r="http://schemas.openxmlformats.org/officeDocument/2006/relationships" xmlns:p="http://schemas.openxmlformats.org/presentationml/2006/main">
   <p:cSld>
     <p:spTree>
@@ -10898,7 +10228,7 @@
 </p:sld>
 </file>
 
-<file path=ppt/slides/slide22.xml><?xml version="1.0" encoding="utf-8"?>
+<file path=ppt/slides/slide23.xml><?xml version="1.0" encoding="utf-8"?>
 <p:sld xmlns:a="http://schemas.openxmlformats.org/drawingml/2006/main" xmlns:r="http://schemas.openxmlformats.org/officeDocument/2006/relationships" xmlns:p="http://schemas.openxmlformats.org/presentationml/2006/main">
   <p:cSld>
     <p:spTree>
@@ -10991,7 +10321,7 @@
 </p:sld>
 </file>
 
-<file path=ppt/slides/slide23.xml><?xml version="1.0" encoding="utf-8"?>
+<file path=ppt/slides/slide24.xml><?xml version="1.0" encoding="utf-8"?>
 <p:sld xmlns:a="http://schemas.openxmlformats.org/drawingml/2006/main" xmlns:r="http://schemas.openxmlformats.org/officeDocument/2006/relationships" xmlns:p="http://schemas.openxmlformats.org/presentationml/2006/main">
   <p:cSld>
     <p:spTree>
@@ -11122,7 +10452,7 @@
         </p:nvSpPr>
         <p:spPr>
           <a:xfrm>
-            <a:off x="3503025" y="5256704"/>
+            <a:off x="4628433" y="5378867"/>
             <a:ext cx="2114006" cy="399925"/>
           </a:xfrm>
           <a:prstGeom prst="rect">
@@ -11131,7 +10461,7 @@
         </p:spPr>
         <p:txBody>
           <a:bodyPr vert="horz" lIns="91440" tIns="45720" rIns="91440" bIns="45720" rtlCol="0">
-            <a:normAutofit fontScale="92500"/>
+            <a:normAutofit fontScale="62500" lnSpcReduction="20000"/>
           </a:bodyPr>
           <a:lstStyle>
             <a:lvl1pPr marL="228600" indent="-228600" algn="l" defTabSz="914400" rtl="0" eaLnBrk="1" latinLnBrk="0" hangingPunct="1">
@@ -11303,7 +10633,7 @@
             </a:pPr>
             <a:r>
               <a:rPr lang="en-US" dirty="0"/>
-              <a:t>Click to code file</a:t>
+              <a:t>Click to open code file</a:t>
             </a:r>
           </a:p>
         </p:txBody>
@@ -11337,7 +10667,7 @@
         </p:blipFill>
         <p:spPr>
           <a:xfrm>
-            <a:off x="5780450" y="5361417"/>
+            <a:off x="4981575" y="5151992"/>
             <a:ext cx="1114425" cy="190500"/>
           </a:xfrm>
           <a:prstGeom prst="rect">
@@ -11358,7 +10688,7 @@
 </p:sld>
 </file>
 
-<file path=ppt/slides/slide24.xml><?xml version="1.0" encoding="utf-8"?>
+<file path=ppt/slides/slide25.xml><?xml version="1.0" encoding="utf-8"?>
 <p:sld xmlns:a="http://schemas.openxmlformats.org/drawingml/2006/main" xmlns:r="http://schemas.openxmlformats.org/officeDocument/2006/relationships" xmlns:p="http://schemas.openxmlformats.org/presentationml/2006/main">
   <p:cSld>
     <p:spTree>
@@ -13645,7 +12975,7 @@
 </p:sld>
 </file>
 
-<file path=ppt/slides/slide25.xml><?xml version="1.0" encoding="utf-8"?>
+<file path=ppt/slides/slide26.xml><?xml version="1.0" encoding="utf-8"?>
 <p:sld xmlns:a="http://schemas.openxmlformats.org/drawingml/2006/main" xmlns:r="http://schemas.openxmlformats.org/officeDocument/2006/relationships" xmlns:p="http://schemas.openxmlformats.org/presentationml/2006/main">
   <p:cSld>
     <p:spTree>
@@ -15534,7 +14864,7 @@
 </p:sld>
 </file>
 
-<file path=ppt/slides/slide26.xml><?xml version="1.0" encoding="utf-8"?>
+<file path=ppt/slides/slide27.xml><?xml version="1.0" encoding="utf-8"?>
 <p:sld xmlns:a="http://schemas.openxmlformats.org/drawingml/2006/main" xmlns:r="http://schemas.openxmlformats.org/officeDocument/2006/relationships" xmlns:p="http://schemas.openxmlformats.org/presentationml/2006/main">
   <p:cSld>
     <p:spTree>
@@ -17550,7 +16880,7 @@
 </p:sld>
 </file>
 
-<file path=ppt/slides/slide27.xml><?xml version="1.0" encoding="utf-8"?>
+<file path=ppt/slides/slide28.xml><?xml version="1.0" encoding="utf-8"?>
 <p:sld xmlns:a="http://schemas.openxmlformats.org/drawingml/2006/main" xmlns:r="http://schemas.openxmlformats.org/officeDocument/2006/relationships" xmlns:p="http://schemas.openxmlformats.org/presentationml/2006/main">
   <p:cSld>
     <p:spTree>
@@ -19479,7 +18809,7 @@
 </p:sld>
 </file>
 
-<file path=ppt/slides/slide28.xml><?xml version="1.0" encoding="utf-8"?>
+<file path=ppt/slides/slide29.xml><?xml version="1.0" encoding="utf-8"?>
 <p:sld xmlns:a="http://schemas.openxmlformats.org/drawingml/2006/main" xmlns:r="http://schemas.openxmlformats.org/officeDocument/2006/relationships" xmlns:p="http://schemas.openxmlformats.org/presentationml/2006/main">
   <p:cSld>
     <p:spTree>
@@ -19553,277 +18883,6 @@
     <p:extLst>
       <p:ext uri="{BB962C8B-B14F-4D97-AF65-F5344CB8AC3E}">
         <p14:creationId xmlns:p14="http://schemas.microsoft.com/office/powerpoint/2010/main" val="1962627052"/>
-      </p:ext>
-    </p:extLst>
-  </p:cSld>
-  <p:clrMapOvr>
-    <a:masterClrMapping/>
-  </p:clrMapOvr>
-</p:sld>
-</file>
-
-<file path=ppt/slides/slide29.xml><?xml version="1.0" encoding="utf-8"?>
-<p:sld xmlns:a="http://schemas.openxmlformats.org/drawingml/2006/main" xmlns:r="http://schemas.openxmlformats.org/officeDocument/2006/relationships" xmlns:p="http://schemas.openxmlformats.org/presentationml/2006/main">
-  <p:cSld>
-    <p:spTree>
-      <p:nvGrpSpPr>
-        <p:cNvPr id="1" name="">
-          <a:extLst>
-            <a:ext uri="{FF2B5EF4-FFF2-40B4-BE49-F238E27FC236}">
-              <a16:creationId xmlns:a16="http://schemas.microsoft.com/office/drawing/2014/main" id="{780EF83F-1AF2-9F93-36C9-599166F18D98}"/>
-            </a:ext>
-          </a:extLst>
-        </p:cNvPr>
-        <p:cNvGrpSpPr/>
-        <p:nvPr/>
-      </p:nvGrpSpPr>
-      <p:grpSpPr>
-        <a:xfrm>
-          <a:off x="0" y="0"/>
-          <a:ext cx="0" cy="0"/>
-          <a:chOff x="0" y="0"/>
-          <a:chExt cx="0" cy="0"/>
-        </a:xfrm>
-      </p:grpSpPr>
-      <p:sp>
-        <p:nvSpPr>
-          <p:cNvPr id="2" name="Title 1">
-            <a:extLst>
-              <a:ext uri="{FF2B5EF4-FFF2-40B4-BE49-F238E27FC236}">
-                <a16:creationId xmlns:a16="http://schemas.microsoft.com/office/drawing/2014/main" id="{52903DAF-5696-AC19-F8F3-CD988D3057AE}"/>
-              </a:ext>
-            </a:extLst>
-          </p:cNvPr>
-          <p:cNvSpPr>
-            <a:spLocks noGrp="1"/>
-          </p:cNvSpPr>
-          <p:nvPr>
-            <p:ph type="title"/>
-          </p:nvPr>
-        </p:nvSpPr>
-        <p:spPr/>
-        <p:txBody>
-          <a:bodyPr/>
-          <a:lstStyle/>
-          <a:p>
-            <a:r>
-              <a:rPr lang="en-US" dirty="0"/>
-              <a:t>Language Models: N-grams</a:t>
-            </a:r>
-          </a:p>
-        </p:txBody>
-      </p:sp>
-      <p:sp>
-        <p:nvSpPr>
-          <p:cNvPr id="3" name="Content Placeholder 2">
-            <a:extLst>
-              <a:ext uri="{FF2B5EF4-FFF2-40B4-BE49-F238E27FC236}">
-                <a16:creationId xmlns:a16="http://schemas.microsoft.com/office/drawing/2014/main" id="{7D988BEA-61D0-FF52-BEAC-D65E0B8CE8A1}"/>
-              </a:ext>
-            </a:extLst>
-          </p:cNvPr>
-          <p:cNvSpPr>
-            <a:spLocks noGrp="1"/>
-          </p:cNvSpPr>
-          <p:nvPr>
-            <p:ph idx="1"/>
-          </p:nvPr>
-        </p:nvSpPr>
-        <p:spPr/>
-        <p:txBody>
-          <a:bodyPr>
-            <a:normAutofit fontScale="77500" lnSpcReduction="20000"/>
-          </a:bodyPr>
-          <a:lstStyle/>
-          <a:p>
-            <a:pPr marL="0" indent="0">
-              <a:buNone/>
-            </a:pPr>
-            <a:r>
-              <a:rPr lang="en-US" dirty="0"/>
-              <a:t>Language models are statistical or neural models that capture the probability distribution of words or tokens in a language. </a:t>
-            </a:r>
-          </a:p>
-          <a:p>
-            <a:pPr marL="0" indent="0">
-              <a:buNone/>
-            </a:pPr>
-            <a:r>
-              <a:rPr lang="en-US" dirty="0"/>
-              <a:t>They predict the likelihood of a sequence of words occurring together, enabling machines to understand and generate human language.</a:t>
-            </a:r>
-          </a:p>
-          <a:p>
-            <a:pPr>
-              <a:buNone/>
-            </a:pPr>
-            <a:r>
-              <a:rPr lang="en-US" b="1" dirty="0"/>
-              <a:t>Types of Language Models</a:t>
-            </a:r>
-          </a:p>
-          <a:p>
-            <a:pPr>
-              <a:buNone/>
-            </a:pPr>
-            <a:r>
-              <a:rPr lang="en-US" b="1" dirty="0"/>
-              <a:t>1) Statistical Language Models</a:t>
-            </a:r>
-          </a:p>
-          <a:p>
-            <a:pPr>
-              <a:buFont typeface="Arial" panose="020B0604020202020204" pitchFamily="34" charset="0"/>
-              <a:buChar char="•"/>
-            </a:pPr>
-            <a:r>
-              <a:rPr lang="en-US" b="1" dirty="0"/>
-              <a:t>N-gram Models</a:t>
-            </a:r>
-            <a:r>
-              <a:rPr lang="en-US" dirty="0"/>
-              <a:t>: Predict the next word based on the previous N-1 words </a:t>
-            </a:r>
-          </a:p>
-          <a:p>
-            <a:pPr marL="742950" lvl="1" indent="-285750">
-              <a:buFont typeface="Arial" panose="020B0604020202020204" pitchFamily="34" charset="0"/>
-              <a:buChar char="•"/>
-            </a:pPr>
-            <a:r>
-              <a:rPr lang="en-US" dirty="0"/>
-              <a:t>Unigram: P(word) - individual word probabilities</a:t>
-            </a:r>
-          </a:p>
-          <a:p>
-            <a:pPr marL="742950" lvl="1" indent="-285750">
-              <a:buFont typeface="Arial" panose="020B0604020202020204" pitchFamily="34" charset="0"/>
-              <a:buChar char="•"/>
-            </a:pPr>
-            <a:r>
-              <a:rPr lang="en-US" dirty="0"/>
-              <a:t>Bigram: P(word₂|word₁) - probability of word₂ given word₁</a:t>
-            </a:r>
-          </a:p>
-          <a:p>
-            <a:pPr marL="742950" lvl="1" indent="-285750">
-              <a:buFont typeface="Arial" panose="020B0604020202020204" pitchFamily="34" charset="0"/>
-              <a:buChar char="•"/>
-            </a:pPr>
-            <a:r>
-              <a:rPr lang="en-US" dirty="0"/>
-              <a:t>Trigram: P(word₃|</a:t>
-            </a:r>
-            <a:r>
-              <a:rPr lang="en-US" dirty="0" err="1"/>
-              <a:t>word₁,word</a:t>
-            </a:r>
-            <a:r>
-              <a:rPr lang="en-US" dirty="0"/>
-              <a:t>₂) - probability of word₃ given word₁ and word₂</a:t>
-            </a:r>
-          </a:p>
-          <a:p>
-            <a:pPr>
-              <a:buNone/>
-            </a:pPr>
-            <a:r>
-              <a:rPr lang="en-US" b="1" dirty="0"/>
-              <a:t>2) Neural Language Models</a:t>
-            </a:r>
-          </a:p>
-          <a:p>
-            <a:pPr>
-              <a:buFont typeface="Arial" panose="020B0604020202020204" pitchFamily="34" charset="0"/>
-              <a:buChar char="•"/>
-            </a:pPr>
-            <a:r>
-              <a:rPr lang="en-US" b="1" dirty="0"/>
-              <a:t>RNN/LSTM-based</a:t>
-            </a:r>
-            <a:r>
-              <a:rPr lang="en-US" dirty="0"/>
-              <a:t>: Process sequences by maintaining hidden states </a:t>
-            </a:r>
-          </a:p>
-          <a:p>
-            <a:pPr marL="742950" lvl="1" indent="-285750">
-              <a:buFont typeface="Arial" panose="020B0604020202020204" pitchFamily="34" charset="0"/>
-              <a:buChar char="•"/>
-            </a:pPr>
-            <a:r>
-              <a:rPr lang="en-US" dirty="0"/>
-              <a:t>Better at capturing long-range dependencies than n-grams</a:t>
-            </a:r>
-          </a:p>
-          <a:p>
-            <a:pPr marL="742950" lvl="1" indent="-285750">
-              <a:buFont typeface="Arial" panose="020B0604020202020204" pitchFamily="34" charset="0"/>
-              <a:buChar char="•"/>
-            </a:pPr>
-            <a:r>
-              <a:rPr lang="en-US" dirty="0"/>
-              <a:t>Examples: Early versions of Google Translate</a:t>
-            </a:r>
-          </a:p>
-          <a:p>
-            <a:pPr>
-              <a:buFont typeface="Arial" panose="020B0604020202020204" pitchFamily="34" charset="0"/>
-              <a:buChar char="•"/>
-            </a:pPr>
-            <a:r>
-              <a:rPr lang="en-US" b="1" dirty="0"/>
-              <a:t>Transformer-based</a:t>
-            </a:r>
-            <a:r>
-              <a:rPr lang="en-US" dirty="0"/>
-              <a:t>: Use attention mechanisms to process entire sequences </a:t>
-            </a:r>
-          </a:p>
-          <a:p>
-            <a:pPr marL="742950" lvl="1" indent="-285750">
-              <a:buFont typeface="Arial" panose="020B0604020202020204" pitchFamily="34" charset="0"/>
-              <a:buChar char="•"/>
-            </a:pPr>
-            <a:r>
-              <a:rPr lang="en-US" dirty="0"/>
-              <a:t>BERT: Bidirectional, focuses on understanding context</a:t>
-            </a:r>
-          </a:p>
-          <a:p>
-            <a:pPr marL="742950" lvl="1" indent="-285750">
-              <a:buFont typeface="Arial" panose="020B0604020202020204" pitchFamily="34" charset="0"/>
-              <a:buChar char="•"/>
-            </a:pPr>
-            <a:r>
-              <a:rPr lang="en-US" dirty="0"/>
-              <a:t>GPT: Autoregressive, focuses on text generation</a:t>
-            </a:r>
-          </a:p>
-          <a:p>
-            <a:pPr marL="742950" lvl="1" indent="-285750">
-              <a:buFont typeface="Arial" panose="020B0604020202020204" pitchFamily="34" charset="0"/>
-              <a:buChar char="•"/>
-            </a:pPr>
-            <a:r>
-              <a:rPr lang="en-US" dirty="0"/>
-              <a:t>T5, </a:t>
-            </a:r>
-            <a:r>
-              <a:rPr lang="en-US" dirty="0" err="1"/>
-              <a:t>RoBERTa</a:t>
-            </a:r>
-            <a:r>
-              <a:rPr lang="en-US" dirty="0"/>
-              <a:t>, ELECTRA: Refinements of transformer architecture</a:t>
-            </a:r>
-          </a:p>
-        </p:txBody>
-      </p:sp>
-    </p:spTree>
-    <p:extLst>
-      <p:ext uri="{BB962C8B-B14F-4D97-AF65-F5344CB8AC3E}">
-        <p14:creationId xmlns:p14="http://schemas.microsoft.com/office/powerpoint/2010/main" val="184126415"/>
       </p:ext>
     </p:extLst>
   </p:cSld>
@@ -20058,6 +19117,277 @@
   <p:cSld>
     <p:spTree>
       <p:nvGrpSpPr>
+        <p:cNvPr id="1" name="">
+          <a:extLst>
+            <a:ext uri="{FF2B5EF4-FFF2-40B4-BE49-F238E27FC236}">
+              <a16:creationId xmlns:a16="http://schemas.microsoft.com/office/drawing/2014/main" id="{780EF83F-1AF2-9F93-36C9-599166F18D98}"/>
+            </a:ext>
+          </a:extLst>
+        </p:cNvPr>
+        <p:cNvGrpSpPr/>
+        <p:nvPr/>
+      </p:nvGrpSpPr>
+      <p:grpSpPr>
+        <a:xfrm>
+          <a:off x="0" y="0"/>
+          <a:ext cx="0" cy="0"/>
+          <a:chOff x="0" y="0"/>
+          <a:chExt cx="0" cy="0"/>
+        </a:xfrm>
+      </p:grpSpPr>
+      <p:sp>
+        <p:nvSpPr>
+          <p:cNvPr id="2" name="Title 1">
+            <a:extLst>
+              <a:ext uri="{FF2B5EF4-FFF2-40B4-BE49-F238E27FC236}">
+                <a16:creationId xmlns:a16="http://schemas.microsoft.com/office/drawing/2014/main" id="{52903DAF-5696-AC19-F8F3-CD988D3057AE}"/>
+              </a:ext>
+            </a:extLst>
+          </p:cNvPr>
+          <p:cNvSpPr>
+            <a:spLocks noGrp="1"/>
+          </p:cNvSpPr>
+          <p:nvPr>
+            <p:ph type="title"/>
+          </p:nvPr>
+        </p:nvSpPr>
+        <p:spPr/>
+        <p:txBody>
+          <a:bodyPr/>
+          <a:lstStyle/>
+          <a:p>
+            <a:r>
+              <a:rPr lang="en-US" dirty="0"/>
+              <a:t>Language Models: N-grams</a:t>
+            </a:r>
+          </a:p>
+        </p:txBody>
+      </p:sp>
+      <p:sp>
+        <p:nvSpPr>
+          <p:cNvPr id="3" name="Content Placeholder 2">
+            <a:extLst>
+              <a:ext uri="{FF2B5EF4-FFF2-40B4-BE49-F238E27FC236}">
+                <a16:creationId xmlns:a16="http://schemas.microsoft.com/office/drawing/2014/main" id="{7D988BEA-61D0-FF52-BEAC-D65E0B8CE8A1}"/>
+              </a:ext>
+            </a:extLst>
+          </p:cNvPr>
+          <p:cNvSpPr>
+            <a:spLocks noGrp="1"/>
+          </p:cNvSpPr>
+          <p:nvPr>
+            <p:ph idx="1"/>
+          </p:nvPr>
+        </p:nvSpPr>
+        <p:spPr/>
+        <p:txBody>
+          <a:bodyPr>
+            <a:normAutofit fontScale="77500" lnSpcReduction="20000"/>
+          </a:bodyPr>
+          <a:lstStyle/>
+          <a:p>
+            <a:pPr marL="0" indent="0">
+              <a:buNone/>
+            </a:pPr>
+            <a:r>
+              <a:rPr lang="en-US" dirty="0"/>
+              <a:t>Language models are statistical or neural models that capture the probability distribution of words or tokens in a language. </a:t>
+            </a:r>
+          </a:p>
+          <a:p>
+            <a:pPr marL="0" indent="0">
+              <a:buNone/>
+            </a:pPr>
+            <a:r>
+              <a:rPr lang="en-US" dirty="0"/>
+              <a:t>They predict the likelihood of a sequence of words occurring together, enabling machines to understand and generate human language.</a:t>
+            </a:r>
+          </a:p>
+          <a:p>
+            <a:pPr>
+              <a:buNone/>
+            </a:pPr>
+            <a:r>
+              <a:rPr lang="en-US" b="1" dirty="0"/>
+              <a:t>Types of Language Models</a:t>
+            </a:r>
+          </a:p>
+          <a:p>
+            <a:pPr>
+              <a:buNone/>
+            </a:pPr>
+            <a:r>
+              <a:rPr lang="en-US" b="1" dirty="0"/>
+              <a:t>1) Statistical Language Models</a:t>
+            </a:r>
+          </a:p>
+          <a:p>
+            <a:pPr>
+              <a:buFont typeface="Arial" panose="020B0604020202020204" pitchFamily="34" charset="0"/>
+              <a:buChar char="•"/>
+            </a:pPr>
+            <a:r>
+              <a:rPr lang="en-US" b="1" dirty="0"/>
+              <a:t>N-gram Models</a:t>
+            </a:r>
+            <a:r>
+              <a:rPr lang="en-US" dirty="0"/>
+              <a:t>: Predict the next word based on the previous N-1 words </a:t>
+            </a:r>
+          </a:p>
+          <a:p>
+            <a:pPr marL="742950" lvl="1" indent="-285750">
+              <a:buFont typeface="Arial" panose="020B0604020202020204" pitchFamily="34" charset="0"/>
+              <a:buChar char="•"/>
+            </a:pPr>
+            <a:r>
+              <a:rPr lang="en-US" dirty="0"/>
+              <a:t>Unigram: P(word) - individual word probabilities</a:t>
+            </a:r>
+          </a:p>
+          <a:p>
+            <a:pPr marL="742950" lvl="1" indent="-285750">
+              <a:buFont typeface="Arial" panose="020B0604020202020204" pitchFamily="34" charset="0"/>
+              <a:buChar char="•"/>
+            </a:pPr>
+            <a:r>
+              <a:rPr lang="en-US" dirty="0"/>
+              <a:t>Bigram: P(word₂|word₁) - probability of word₂ given word₁</a:t>
+            </a:r>
+          </a:p>
+          <a:p>
+            <a:pPr marL="742950" lvl="1" indent="-285750">
+              <a:buFont typeface="Arial" panose="020B0604020202020204" pitchFamily="34" charset="0"/>
+              <a:buChar char="•"/>
+            </a:pPr>
+            <a:r>
+              <a:rPr lang="en-US" dirty="0"/>
+              <a:t>Trigram: P(word₃|</a:t>
+            </a:r>
+            <a:r>
+              <a:rPr lang="en-US" dirty="0" err="1"/>
+              <a:t>word₁,word</a:t>
+            </a:r>
+            <a:r>
+              <a:rPr lang="en-US" dirty="0"/>
+              <a:t>₂) - probability of word₃ given word₁ and word₂</a:t>
+            </a:r>
+          </a:p>
+          <a:p>
+            <a:pPr>
+              <a:buNone/>
+            </a:pPr>
+            <a:r>
+              <a:rPr lang="en-US" b="1" dirty="0"/>
+              <a:t>2) Neural Language Models</a:t>
+            </a:r>
+          </a:p>
+          <a:p>
+            <a:pPr>
+              <a:buFont typeface="Arial" panose="020B0604020202020204" pitchFamily="34" charset="0"/>
+              <a:buChar char="•"/>
+            </a:pPr>
+            <a:r>
+              <a:rPr lang="en-US" b="1" dirty="0"/>
+              <a:t>RNN/LSTM-based</a:t>
+            </a:r>
+            <a:r>
+              <a:rPr lang="en-US" dirty="0"/>
+              <a:t>: Process sequences by maintaining hidden states </a:t>
+            </a:r>
+          </a:p>
+          <a:p>
+            <a:pPr marL="742950" lvl="1" indent="-285750">
+              <a:buFont typeface="Arial" panose="020B0604020202020204" pitchFamily="34" charset="0"/>
+              <a:buChar char="•"/>
+            </a:pPr>
+            <a:r>
+              <a:rPr lang="en-US" dirty="0"/>
+              <a:t>Better at capturing long-range dependencies than n-grams</a:t>
+            </a:r>
+          </a:p>
+          <a:p>
+            <a:pPr marL="742950" lvl="1" indent="-285750">
+              <a:buFont typeface="Arial" panose="020B0604020202020204" pitchFamily="34" charset="0"/>
+              <a:buChar char="•"/>
+            </a:pPr>
+            <a:r>
+              <a:rPr lang="en-US" dirty="0"/>
+              <a:t>Examples: Early versions of Google Translate</a:t>
+            </a:r>
+          </a:p>
+          <a:p>
+            <a:pPr>
+              <a:buFont typeface="Arial" panose="020B0604020202020204" pitchFamily="34" charset="0"/>
+              <a:buChar char="•"/>
+            </a:pPr>
+            <a:r>
+              <a:rPr lang="en-US" b="1" dirty="0"/>
+              <a:t>Transformer-based</a:t>
+            </a:r>
+            <a:r>
+              <a:rPr lang="en-US" dirty="0"/>
+              <a:t>: Use attention mechanisms to process entire sequences </a:t>
+            </a:r>
+          </a:p>
+          <a:p>
+            <a:pPr marL="742950" lvl="1" indent="-285750">
+              <a:buFont typeface="Arial" panose="020B0604020202020204" pitchFamily="34" charset="0"/>
+              <a:buChar char="•"/>
+            </a:pPr>
+            <a:r>
+              <a:rPr lang="en-US" dirty="0"/>
+              <a:t>BERT: Bidirectional, focuses on understanding context</a:t>
+            </a:r>
+          </a:p>
+          <a:p>
+            <a:pPr marL="742950" lvl="1" indent="-285750">
+              <a:buFont typeface="Arial" panose="020B0604020202020204" pitchFamily="34" charset="0"/>
+              <a:buChar char="•"/>
+            </a:pPr>
+            <a:r>
+              <a:rPr lang="en-US" dirty="0"/>
+              <a:t>GPT: Autoregressive, focuses on text generation</a:t>
+            </a:r>
+          </a:p>
+          <a:p>
+            <a:pPr marL="742950" lvl="1" indent="-285750">
+              <a:buFont typeface="Arial" panose="020B0604020202020204" pitchFamily="34" charset="0"/>
+              <a:buChar char="•"/>
+            </a:pPr>
+            <a:r>
+              <a:rPr lang="en-US" dirty="0"/>
+              <a:t>T5, </a:t>
+            </a:r>
+            <a:r>
+              <a:rPr lang="en-US" dirty="0" err="1"/>
+              <a:t>RoBERTa</a:t>
+            </a:r>
+            <a:r>
+              <a:rPr lang="en-US" dirty="0"/>
+              <a:t>, ELECTRA: Refinements of transformer architecture</a:t>
+            </a:r>
+          </a:p>
+        </p:txBody>
+      </p:sp>
+    </p:spTree>
+    <p:extLst>
+      <p:ext uri="{BB962C8B-B14F-4D97-AF65-F5344CB8AC3E}">
+        <p14:creationId xmlns:p14="http://schemas.microsoft.com/office/powerpoint/2010/main" val="184126415"/>
+      </p:ext>
+    </p:extLst>
+  </p:cSld>
+  <p:clrMapOvr>
+    <a:masterClrMapping/>
+  </p:clrMapOvr>
+</p:sld>
+</file>
+
+<file path=ppt/slides/slide31.xml><?xml version="1.0" encoding="utf-8"?>
+<p:sld xmlns:a="http://schemas.openxmlformats.org/drawingml/2006/main" xmlns:r="http://schemas.openxmlformats.org/officeDocument/2006/relationships" xmlns:p="http://schemas.openxmlformats.org/presentationml/2006/main">
+  <p:cSld>
+    <p:spTree>
+      <p:nvGrpSpPr>
         <p:cNvPr id="1" name=""/>
         <p:cNvGrpSpPr/>
         <p:nvPr/>
@@ -20327,7 +19657,7 @@
 </p:sld>
 </file>
 
-<file path=ppt/slides/slide31.xml><?xml version="1.0" encoding="utf-8"?>
+<file path=ppt/slides/slide32.xml><?xml version="1.0" encoding="utf-8"?>
 <p:sld xmlns:a="http://schemas.openxmlformats.org/drawingml/2006/main" xmlns:r="http://schemas.openxmlformats.org/officeDocument/2006/relationships" xmlns:p="http://schemas.openxmlformats.org/presentationml/2006/main">
   <p:cSld>
     <p:spTree>
@@ -22478,7 +21808,7 @@
 </p:sld>
 </file>
 
-<file path=ppt/slides/slide32.xml><?xml version="1.0" encoding="utf-8"?>
+<file path=ppt/slides/slide33.xml><?xml version="1.0" encoding="utf-8"?>
 <p:sld xmlns:a="http://schemas.openxmlformats.org/drawingml/2006/main" xmlns:r="http://schemas.openxmlformats.org/officeDocument/2006/relationships" xmlns:p="http://schemas.openxmlformats.org/presentationml/2006/main">
   <p:cSld>
     <p:spTree>
@@ -22590,7 +21920,7 @@
 </p:sld>
 </file>
 
-<file path=ppt/slides/slide33.xml><?xml version="1.0" encoding="utf-8"?>
+<file path=ppt/slides/slide34.xml><?xml version="1.0" encoding="utf-8"?>
 <p:sld xmlns:a="http://schemas.openxmlformats.org/drawingml/2006/main" xmlns:r="http://schemas.openxmlformats.org/officeDocument/2006/relationships" xmlns:p="http://schemas.openxmlformats.org/presentationml/2006/main">
   <p:cSld>
     <p:spTree>
@@ -24017,6 +23347,249 @@
           </a:p>
         </p:txBody>
       </p:sp>
+      <p:sp>
+        <p:nvSpPr>
+          <p:cNvPr id="5" name="Content Placeholder 2">
+            <a:extLst>
+              <a:ext uri="{FF2B5EF4-FFF2-40B4-BE49-F238E27FC236}">
+                <a16:creationId xmlns:a16="http://schemas.microsoft.com/office/drawing/2014/main" id="{276D0FCF-4391-4D56-854A-F184802E65F6}"/>
+              </a:ext>
+            </a:extLst>
+          </p:cNvPr>
+          <p:cNvSpPr txBox="1">
+            <a:spLocks/>
+          </p:cNvSpPr>
+          <p:nvPr/>
+        </p:nvSpPr>
+        <p:spPr>
+          <a:xfrm>
+            <a:off x="10162954" y="6435843"/>
+            <a:ext cx="1650788" cy="399925"/>
+          </a:xfrm>
+          <a:prstGeom prst="rect">
+            <a:avLst/>
+          </a:prstGeom>
+        </p:spPr>
+        <p:txBody>
+          <a:bodyPr vert="horz" lIns="91440" tIns="45720" rIns="91440" bIns="45720" rtlCol="0">
+            <a:normAutofit/>
+          </a:bodyPr>
+          <a:lstStyle>
+            <a:lvl1pPr marL="228600" indent="-228600" algn="l" defTabSz="914400" rtl="0" eaLnBrk="1" latinLnBrk="0" hangingPunct="1">
+              <a:lnSpc>
+                <a:spcPct val="90000"/>
+              </a:lnSpc>
+              <a:spcBef>
+                <a:spcPts val="1000"/>
+              </a:spcBef>
+              <a:buFont typeface="Arial" panose="020B0604020202020204" pitchFamily="34" charset="0"/>
+              <a:buChar char="•"/>
+              <a:defRPr sz="2400" kern="1200">
+                <a:solidFill>
+                  <a:schemeClr val="tx1"/>
+                </a:solidFill>
+                <a:latin typeface="+mn-lt"/>
+                <a:ea typeface="+mn-ea"/>
+                <a:cs typeface="+mn-cs"/>
+              </a:defRPr>
+            </a:lvl1pPr>
+            <a:lvl2pPr marL="685800" indent="-228600" algn="l" defTabSz="914400" rtl="0" eaLnBrk="1" latinLnBrk="0" hangingPunct="1">
+              <a:lnSpc>
+                <a:spcPct val="90000"/>
+              </a:lnSpc>
+              <a:spcBef>
+                <a:spcPts val="500"/>
+              </a:spcBef>
+              <a:buFont typeface="Arial" panose="020B0604020202020204" pitchFamily="34" charset="0"/>
+              <a:buChar char="•"/>
+              <a:defRPr sz="2000" kern="1200">
+                <a:solidFill>
+                  <a:schemeClr val="tx1"/>
+                </a:solidFill>
+                <a:latin typeface="+mn-lt"/>
+                <a:ea typeface="+mn-ea"/>
+                <a:cs typeface="+mn-cs"/>
+              </a:defRPr>
+            </a:lvl2pPr>
+            <a:lvl3pPr marL="1143000" indent="-228600" algn="l" defTabSz="914400" rtl="0" eaLnBrk="1" latinLnBrk="0" hangingPunct="1">
+              <a:lnSpc>
+                <a:spcPct val="90000"/>
+              </a:lnSpc>
+              <a:spcBef>
+                <a:spcPts val="500"/>
+              </a:spcBef>
+              <a:buFont typeface="Arial" panose="020B0604020202020204" pitchFamily="34" charset="0"/>
+              <a:buChar char="•"/>
+              <a:defRPr sz="1800" kern="1200">
+                <a:solidFill>
+                  <a:schemeClr val="tx1"/>
+                </a:solidFill>
+                <a:latin typeface="+mn-lt"/>
+                <a:ea typeface="+mn-ea"/>
+                <a:cs typeface="+mn-cs"/>
+              </a:defRPr>
+            </a:lvl3pPr>
+            <a:lvl4pPr marL="1600200" indent="-228600" algn="l" defTabSz="914400" rtl="0" eaLnBrk="1" latinLnBrk="0" hangingPunct="1">
+              <a:lnSpc>
+                <a:spcPct val="90000"/>
+              </a:lnSpc>
+              <a:spcBef>
+                <a:spcPts val="500"/>
+              </a:spcBef>
+              <a:buFont typeface="Arial" panose="020B0604020202020204" pitchFamily="34" charset="0"/>
+              <a:buChar char="•"/>
+              <a:defRPr sz="1600" kern="1200">
+                <a:solidFill>
+                  <a:schemeClr val="tx1"/>
+                </a:solidFill>
+                <a:latin typeface="+mn-lt"/>
+                <a:ea typeface="+mn-ea"/>
+                <a:cs typeface="+mn-cs"/>
+              </a:defRPr>
+            </a:lvl4pPr>
+            <a:lvl5pPr marL="2057400" indent="-228600" algn="l" defTabSz="914400" rtl="0" eaLnBrk="1" latinLnBrk="0" hangingPunct="1">
+              <a:lnSpc>
+                <a:spcPct val="90000"/>
+              </a:lnSpc>
+              <a:spcBef>
+                <a:spcPts val="500"/>
+              </a:spcBef>
+              <a:buFont typeface="Arial" panose="020B0604020202020204" pitchFamily="34" charset="0"/>
+              <a:buChar char="•"/>
+              <a:defRPr sz="1600" kern="1200">
+                <a:solidFill>
+                  <a:schemeClr val="tx1"/>
+                </a:solidFill>
+                <a:latin typeface="+mn-lt"/>
+                <a:ea typeface="+mn-ea"/>
+                <a:cs typeface="+mn-cs"/>
+              </a:defRPr>
+            </a:lvl5pPr>
+            <a:lvl6pPr marL="2514600" indent="-228600" algn="l" defTabSz="914400" rtl="0" eaLnBrk="1" latinLnBrk="0" hangingPunct="1">
+              <a:lnSpc>
+                <a:spcPct val="90000"/>
+              </a:lnSpc>
+              <a:spcBef>
+                <a:spcPts val="500"/>
+              </a:spcBef>
+              <a:buFont typeface="Arial" panose="020B0604020202020204" pitchFamily="34" charset="0"/>
+              <a:buChar char="•"/>
+              <a:defRPr sz="1800" kern="1200">
+                <a:solidFill>
+                  <a:schemeClr val="tx1"/>
+                </a:solidFill>
+                <a:latin typeface="+mn-lt"/>
+                <a:ea typeface="+mn-ea"/>
+                <a:cs typeface="+mn-cs"/>
+              </a:defRPr>
+            </a:lvl6pPr>
+            <a:lvl7pPr marL="2971800" indent="-228600" algn="l" defTabSz="914400" rtl="0" eaLnBrk="1" latinLnBrk="0" hangingPunct="1">
+              <a:lnSpc>
+                <a:spcPct val="90000"/>
+              </a:lnSpc>
+              <a:spcBef>
+                <a:spcPts val="500"/>
+              </a:spcBef>
+              <a:buFont typeface="Arial" panose="020B0604020202020204" pitchFamily="34" charset="0"/>
+              <a:buChar char="•"/>
+              <a:defRPr sz="1800" kern="1200">
+                <a:solidFill>
+                  <a:schemeClr val="tx1"/>
+                </a:solidFill>
+                <a:latin typeface="+mn-lt"/>
+                <a:ea typeface="+mn-ea"/>
+                <a:cs typeface="+mn-cs"/>
+              </a:defRPr>
+            </a:lvl7pPr>
+            <a:lvl8pPr marL="3429000" indent="-228600" algn="l" defTabSz="914400" rtl="0" eaLnBrk="1" latinLnBrk="0" hangingPunct="1">
+              <a:lnSpc>
+                <a:spcPct val="90000"/>
+              </a:lnSpc>
+              <a:spcBef>
+                <a:spcPts val="500"/>
+              </a:spcBef>
+              <a:buFont typeface="Arial" panose="020B0604020202020204" pitchFamily="34" charset="0"/>
+              <a:buChar char="•"/>
+              <a:defRPr sz="1800" kern="1200">
+                <a:solidFill>
+                  <a:schemeClr val="tx1"/>
+                </a:solidFill>
+                <a:latin typeface="+mn-lt"/>
+                <a:ea typeface="+mn-ea"/>
+                <a:cs typeface="+mn-cs"/>
+              </a:defRPr>
+            </a:lvl8pPr>
+            <a:lvl9pPr marL="3886200" indent="-228600" algn="l" defTabSz="914400" rtl="0" eaLnBrk="1" latinLnBrk="0" hangingPunct="1">
+              <a:lnSpc>
+                <a:spcPct val="90000"/>
+              </a:lnSpc>
+              <a:spcBef>
+                <a:spcPts val="500"/>
+              </a:spcBef>
+              <a:buFont typeface="Arial" panose="020B0604020202020204" pitchFamily="34" charset="0"/>
+              <a:buChar char="•"/>
+              <a:defRPr sz="1800" kern="1200">
+                <a:solidFill>
+                  <a:schemeClr val="tx1"/>
+                </a:solidFill>
+                <a:latin typeface="+mn-lt"/>
+                <a:ea typeface="+mn-ea"/>
+                <a:cs typeface="+mn-cs"/>
+              </a:defRPr>
+            </a:lvl9pPr>
+          </a:lstStyle>
+          <a:p>
+            <a:pPr marL="0" indent="0">
+              <a:buNone/>
+            </a:pPr>
+            <a:r>
+              <a:rPr lang="en-US" sz="1400" dirty="0">
+                <a:solidFill>
+                  <a:srgbClr val="0070C0"/>
+                </a:solidFill>
+              </a:rPr>
+              <a:t>Click to Open Code</a:t>
+            </a:r>
+          </a:p>
+        </p:txBody>
+      </p:sp>
+      <p:pic>
+        <p:nvPicPr>
+          <p:cNvPr id="7" name="Graphic 6">
+            <a:hlinkClick r:id="rId2"/>
+            <a:extLst>
+              <a:ext uri="{FF2B5EF4-FFF2-40B4-BE49-F238E27FC236}">
+                <a16:creationId xmlns:a16="http://schemas.microsoft.com/office/drawing/2014/main" id="{DC2CF0F7-2D5E-4690-AF02-D9A372D347F3}"/>
+              </a:ext>
+            </a:extLst>
+          </p:cNvPr>
+          <p:cNvPicPr>
+            <a:picLocks noChangeAspect="1"/>
+          </p:cNvPicPr>
+          <p:nvPr/>
+        </p:nvPicPr>
+        <p:blipFill>
+          <a:blip r:embed="rId3">
+            <a:extLst>
+              <a:ext uri="{96DAC541-7B7A-43D3-8B79-37D633B846F1}">
+                <asvg:svgBlip xmlns:asvg="http://schemas.microsoft.com/office/drawing/2016/SVG/main" r:embed="rId4"/>
+              </a:ext>
+            </a:extLst>
+          </a:blip>
+          <a:stretch>
+            <a:fillRect/>
+          </a:stretch>
+        </p:blipFill>
+        <p:spPr>
+          <a:xfrm>
+            <a:off x="10431136" y="6231200"/>
+            <a:ext cx="1114425" cy="190500"/>
+          </a:xfrm>
+          <a:prstGeom prst="rect">
+            <a:avLst/>
+          </a:prstGeom>
+        </p:spPr>
+      </p:pic>
     </p:spTree>
     <p:extLst>
       <p:ext uri="{BB962C8B-B14F-4D97-AF65-F5344CB8AC3E}">
@@ -24579,8 +24152,8 @@
         </p:nvSpPr>
         <p:spPr>
           <a:xfrm>
-            <a:off x="1241853" y="4429358"/>
-            <a:ext cx="10730299" cy="923330"/>
+            <a:off x="7755147" y="4135860"/>
+            <a:ext cx="3868282" cy="1754326"/>
           </a:xfrm>
           <a:prstGeom prst="rect">
             <a:avLst/>
@@ -24603,6 +24176,149 @@
               <a:rPr lang="en-US" dirty="0"/>
               <a:t>['large', 'language', 'models', 'are', 'revolutionizing', 'business', 'applications', '.']['large', 'language', 'models', 'are', 'revolutionizing', 'business', 'applications', '']</a:t>
             </a:r>
+          </a:p>
+        </p:txBody>
+      </p:sp>
+      <p:sp>
+        <p:nvSpPr>
+          <p:cNvPr id="8" name="TextBox 7">
+            <a:extLst>
+              <a:ext uri="{FF2B5EF4-FFF2-40B4-BE49-F238E27FC236}">
+                <a16:creationId xmlns:a16="http://schemas.microsoft.com/office/drawing/2014/main" id="{A4BECA11-0014-431F-A8D8-3FFAF66D6978}"/>
+              </a:ext>
+            </a:extLst>
+          </p:cNvPr>
+          <p:cNvSpPr txBox="1"/>
+          <p:nvPr/>
+        </p:nvSpPr>
+        <p:spPr>
+          <a:xfrm>
+            <a:off x="1241853" y="4070073"/>
+            <a:ext cx="6306260" cy="2785378"/>
+          </a:xfrm>
+          <a:prstGeom prst="rect">
+            <a:avLst/>
+          </a:prstGeom>
+          <a:noFill/>
+        </p:spPr>
+        <p:txBody>
+          <a:bodyPr wrap="square" rtlCol="0">
+            <a:spAutoFit/>
+          </a:bodyPr>
+          <a:lstStyle/>
+          <a:p>
+            <a:pPr>
+              <a:lnSpc>
+                <a:spcPts val="1425"/>
+              </a:lnSpc>
+              <a:buNone/>
+            </a:pPr>
+            <a:r>
+              <a:rPr lang="en-US" sz="1200" dirty="0">
+                <a:solidFill>
+                  <a:srgbClr val="000000"/>
+                </a:solidFill>
+                <a:latin typeface="Consolas" panose="020B0609020204030204" pitchFamily="49" charset="0"/>
+              </a:rPr>
+              <a:t>The regular expression r'[^\w\s]' does the following:</a:t>
+            </a:r>
+          </a:p>
+          <a:p>
+            <a:pPr marL="171450" indent="-171450">
+              <a:lnSpc>
+                <a:spcPts val="1425"/>
+              </a:lnSpc>
+              <a:buFont typeface="Arial" panose="020B0604020202020204" pitchFamily="34" charset="0"/>
+              <a:buChar char="•"/>
+            </a:pPr>
+            <a:r>
+              <a:rPr lang="en-US" sz="1200" dirty="0">
+                <a:solidFill>
+                  <a:srgbClr val="000000"/>
+                </a:solidFill>
+                <a:latin typeface="Consolas" panose="020B0609020204030204" pitchFamily="49" charset="0"/>
+              </a:rPr>
+              <a:t>r'...': This denotes a raw string in Python. Raw strings treat backslashes \ as literal characters, which is crucial for regular expressions.</a:t>
+            </a:r>
+          </a:p>
+          <a:p>
+            <a:pPr marL="171450" indent="-171450">
+              <a:lnSpc>
+                <a:spcPts val="1425"/>
+              </a:lnSpc>
+              <a:buFont typeface="Arial" panose="020B0604020202020204" pitchFamily="34" charset="0"/>
+              <a:buChar char="•"/>
+            </a:pPr>
+            <a:r>
+              <a:rPr lang="en-US" sz="1200" dirty="0">
+                <a:solidFill>
+                  <a:srgbClr val="000000"/>
+                </a:solidFill>
+                <a:latin typeface="Consolas" panose="020B0609020204030204" pitchFamily="49" charset="0"/>
+              </a:rPr>
+              <a:t>[...]: This represents a character set.^: Inside a character set, ^ negates the set. It means "match any character not in this set.</a:t>
+            </a:r>
+          </a:p>
+          <a:p>
+            <a:pPr marL="171450" indent="-171450">
+              <a:lnSpc>
+                <a:spcPts val="1425"/>
+              </a:lnSpc>
+              <a:buFont typeface="Arial" panose="020B0604020202020204" pitchFamily="34" charset="0"/>
+              <a:buChar char="•"/>
+            </a:pPr>
+            <a:r>
+              <a:rPr lang="en-US" sz="1200" dirty="0">
+                <a:solidFill>
+                  <a:srgbClr val="000000"/>
+                </a:solidFill>
+                <a:latin typeface="Consolas" panose="020B0609020204030204" pitchFamily="49" charset="0"/>
+              </a:rPr>
+              <a:t>"\w: This matches any word character, which includes alphanumeric characters (letters and digits) and the underscore (_).</a:t>
+            </a:r>
+          </a:p>
+          <a:p>
+            <a:pPr marL="171450" indent="-171450">
+              <a:lnSpc>
+                <a:spcPts val="1425"/>
+              </a:lnSpc>
+              <a:buFont typeface="Arial" panose="020B0604020202020204" pitchFamily="34" charset="0"/>
+              <a:buChar char="•"/>
+            </a:pPr>
+            <a:r>
+              <a:rPr lang="en-US" sz="1200" dirty="0">
+                <a:solidFill>
+                  <a:srgbClr val="000000"/>
+                </a:solidFill>
+                <a:latin typeface="Consolas" panose="020B0609020204030204" pitchFamily="49" charset="0"/>
+              </a:rPr>
+              <a:t>\s: This matches any whitespace character, such as spaces, tabs, and newlines.</a:t>
+            </a:r>
+          </a:p>
+          <a:p>
+            <a:pPr marL="171450" indent="-171450">
+              <a:lnSpc>
+                <a:spcPts val="1425"/>
+              </a:lnSpc>
+              <a:buFont typeface="Arial" panose="020B0604020202020204" pitchFamily="34" charset="0"/>
+              <a:buChar char="•"/>
+            </a:pPr>
+            <a:r>
+              <a:rPr lang="en-US" sz="1200" dirty="0">
+                <a:solidFill>
+                  <a:srgbClr val="000000"/>
+                </a:solidFill>
+                <a:latin typeface="Consolas" panose="020B0609020204030204" pitchFamily="49" charset="0"/>
+              </a:rPr>
+              <a:t>Therefore, r'[^\w\s]' matches any character that is not a word character or a whitespace character. In simpler terms, it matches any non-alphanumeric, non-underscore, and non-whitespace character. This effectively targets punctuation marks, symbols, and other special characters.</a:t>
+            </a:r>
+            <a:endParaRPr lang="en-US" sz="1200" b="0" dirty="0">
+              <a:solidFill>
+                <a:srgbClr val="000000"/>
+              </a:solidFill>
+              <a:effectLst/>
+              <a:latin typeface="Consolas" panose="020B0609020204030204" pitchFamily="49" charset="0"/>
+            </a:endParaRPr>
           </a:p>
         </p:txBody>
       </p:sp>

</xml_diff>